<commit_message>
Ret digital medarbejder til 4000 kr og genberegn kundescenarier
</commit_message>
<xml_diff>
--- a/INTELLI-prispraesentation.pptx
+++ b/INTELLI-prispraesentation.pptx
@@ -2,19 +2,19 @@
 <file path=ppt/presentation.xml><?xml version="1.0" encoding="utf-8"?>
 <p:presentation xmlns:p="http://schemas.openxmlformats.org/presentationml/2006/main">
   <p:sldMasterIdLst>
-    <p:sldMasterId xmlns:r="http://schemas.openxmlformats.org/officeDocument/2006/relationships" id="2147483648" r:id="R12066b44c7ce495c"/>
+    <p:sldMasterId xmlns:r="http://schemas.openxmlformats.org/officeDocument/2006/relationships" id="2147483648" r:id="Re6d7ada5152e4515"/>
   </p:sldMasterIdLst>
   <p:notesMasterIdLst>
-    <p:notesMasterId xmlns:r="http://schemas.openxmlformats.org/officeDocument/2006/relationships" r:id="R56b6b3d753214316"/>
+    <p:notesMasterId xmlns:r="http://schemas.openxmlformats.org/officeDocument/2006/relationships" r:id="R1d48dfa83f4b4d0c"/>
   </p:notesMasterIdLst>
   <p:sldIdLst>
-    <p:sldId xmlns:r="http://schemas.openxmlformats.org/officeDocument/2006/relationships" id="256" r:id="R60c73ed586894461"/>
-    <p:sldId xmlns:r="http://schemas.openxmlformats.org/officeDocument/2006/relationships" id="257" r:id="R8a6c8f04a7154392"/>
-    <p:sldId xmlns:r="http://schemas.openxmlformats.org/officeDocument/2006/relationships" id="258" r:id="R8128228b754f4d02"/>
-    <p:sldId xmlns:r="http://schemas.openxmlformats.org/officeDocument/2006/relationships" id="259" r:id="R1772559477854cf9"/>
-    <p:sldId xmlns:r="http://schemas.openxmlformats.org/officeDocument/2006/relationships" id="260" r:id="R7c5784b6b06d406b"/>
-    <p:sldId xmlns:r="http://schemas.openxmlformats.org/officeDocument/2006/relationships" id="261" r:id="Rec27fb3c19814757"/>
-    <p:sldId xmlns:r="http://schemas.openxmlformats.org/officeDocument/2006/relationships" id="262" r:id="Rd379714cae644636"/>
+    <p:sldId xmlns:r="http://schemas.openxmlformats.org/officeDocument/2006/relationships" id="256" r:id="R6e0fb86974c24b56"/>
+    <p:sldId xmlns:r="http://schemas.openxmlformats.org/officeDocument/2006/relationships" id="257" r:id="R14910541b5214c82"/>
+    <p:sldId xmlns:r="http://schemas.openxmlformats.org/officeDocument/2006/relationships" id="258" r:id="R42dabc04472e4d5b"/>
+    <p:sldId xmlns:r="http://schemas.openxmlformats.org/officeDocument/2006/relationships" id="259" r:id="R5a088be0462d494a"/>
+    <p:sldId xmlns:r="http://schemas.openxmlformats.org/officeDocument/2006/relationships" id="260" r:id="R101c42ff079f40c1"/>
+    <p:sldId xmlns:r="http://schemas.openxmlformats.org/officeDocument/2006/relationships" id="261" r:id="Rcd9f3ef3bfe941d5"/>
+    <p:sldId xmlns:r="http://schemas.openxmlformats.org/officeDocument/2006/relationships" id="262" r:id="Rf9026ff58684434d"/>
   </p:sldIdLst>
   <p:sldSz cx="12192000" cy="6858000"/>
   <p:notesSz cx="6858000" cy="9144000"/>
@@ -683,7 +683,7 @@
           </a:p>
           <a:p xmlns:a="http://schemas.openxmlformats.org/drawingml/2006/main">
             <a:r>
-              <a:t>Server tælles én gang pr. installation. 1-20: nuværende server. 50/100: større server med backup. Kapacitet er et skøn og skal belastningstestes. Ejerløn er 0,00 kr.</a:t>
+              <a:t>Server pr. installation. Kapacitet er et skøn og skal testes. Særtilbud i prisnoterne: 20 for 60.000,00 kr./md. (ikke indregnet i tabellen).</a:t>
             </a:r>
           </a:p>
           <a:p xmlns:a="http://schemas.openxmlformats.org/drawingml/2006/main">
@@ -893,7 +893,7 @@
           </a:p>
           <a:p xmlns:a="http://schemas.openxmlformats.org/drawingml/2006/main">
             <a:r>
-              <a:t>Månedsindtægt: 7.500,00 kr. abonnement + 12.000,00 kr. AI + 4.900,00 kr. omstilling. Ingen SMS, partner eller gebyr. Resultat før skat er efter de viste budgetudgifter.</a:t>
+              <a:t>Månedsindtægt: 12.000,00 kr. abonnement + 12.000,00 kr. AI + 4.900,00 kr. omstilling. Ingen SMS, partner eller gebyr. Resultat før skat er efter de viste budgetudgifter.</a:t>
             </a:r>
           </a:p>
           <a:p xmlns:a="http://schemas.openxmlformats.org/drawingml/2006/main">
@@ -1181,7 +1181,7 @@
   </p:cSld>
   <p:clrMap bg1="lt1" tx1="dk1" bg2="lt2" tx2="dk2" accent1="accent1" accent2="accent2" accent3="accent3" accent4="accent4" accent5="accent5" accent6="accent6" hlink="hlink" folHlink="folHlink"/>
   <p:sldLayoutIdLst>
-    <p:sldLayoutId xmlns:r="http://schemas.openxmlformats.org/officeDocument/2006/relationships" id="2147483649" r:id="R775ccff0d694453a"/>
+    <p:sldLayoutId xmlns:r="http://schemas.openxmlformats.org/officeDocument/2006/relationships" id="2147483649" r:id="R8f73cd9b09c0406b"/>
   </p:sldLayoutIdLst>
   <p:txStyles>
     <p:titleStyle>
@@ -1732,7 +1732,7 @@
           <p:cNvPr id="8" name="text-0">
             <a:extLst xmlns:a="http://schemas.openxmlformats.org/drawingml/2006/main">
               <a:ext uri="{FF2B5EF4-FFF2-40B4-BE49-F238E27FC236}">
-                <a16:creationId xmlns:a16="http://schemas.microsoft.com/office/drawing/2014/main" id="{63D0E08A-571E-41B7-B146-AB98BFCD0B08}"/>
+                <a16:creationId xmlns:a16="http://schemas.microsoft.com/office/drawing/2014/main" id="{A1814253-FBC7-4319-ACEB-5783086C2EEA}"/>
               </a:ext>
             </a:extLst>
           </p:cNvPr>
@@ -1789,7 +1789,7 @@
           <p:cNvPr id="2" name="text-1">
             <a:extLst xmlns:a="http://schemas.openxmlformats.org/drawingml/2006/main">
               <a:ext uri="{FF2B5EF4-FFF2-40B4-BE49-F238E27FC236}">
-                <a16:creationId xmlns:a16="http://schemas.microsoft.com/office/drawing/2014/main" id="{158F9B1D-B7F4-4EDB-BFE6-7AFCC9425735}"/>
+                <a16:creationId xmlns:a16="http://schemas.microsoft.com/office/drawing/2014/main" id="{EA94C800-8F3A-4811-BE79-93958D46D09F}"/>
               </a:ext>
             </a:extLst>
           </p:cNvPr>
@@ -2530,7 +2530,7 @@
           <p:cNvPr id="4" name="text-2">
             <a:extLst xmlns:a="http://schemas.openxmlformats.org/drawingml/2006/main">
               <a:ext uri="{FF2B5EF4-FFF2-40B4-BE49-F238E27FC236}">
-                <a16:creationId xmlns:a16="http://schemas.microsoft.com/office/drawing/2014/main" id="{BEE9BC2D-7B1F-4B0F-A207-A7D00B87091C}"/>
+                <a16:creationId xmlns:a16="http://schemas.microsoft.com/office/drawing/2014/main" id="{F6AD6EC1-6247-470A-A4C0-0DFF0556AF74}"/>
               </a:ext>
             </a:extLst>
           </p:cNvPr>
@@ -2577,7 +2577,7 @@
                 <a:ea typeface="Arial"/>
                 <a:cs typeface="Arial"/>
               </a:rPr>
-              <a:t>Abonnement: 2.500,00 kr. pr. digital medarbejder / måned</a:t>
+              <a:t>Abonnement: 4.000,00 kr. pr. digital medarbejder / måned</a:t>
             </a:r>
           </a:p>
         </p:txBody>
@@ -2587,7 +2587,7 @@
           <p:cNvPr id="5" name="text-3">
             <a:extLst xmlns:a="http://schemas.openxmlformats.org/drawingml/2006/main">
               <a:ext uri="{FF2B5EF4-FFF2-40B4-BE49-F238E27FC236}">
-                <a16:creationId xmlns:a16="http://schemas.microsoft.com/office/drawing/2014/main" id="{79B7B73B-DAAE-485B-AF64-890F18D77947}"/>
+                <a16:creationId xmlns:a16="http://schemas.microsoft.com/office/drawing/2014/main" id="{B8AEA6C8-FF58-4C2D-B358-6F5F63E597E3}"/>
               </a:ext>
             </a:extLst>
           </p:cNvPr>
@@ -2644,7 +2644,7 @@
           <p:cNvPr id="6" name="text-4">
             <a:extLst xmlns:a="http://schemas.openxmlformats.org/drawingml/2006/main">
               <a:ext uri="{FF2B5EF4-FFF2-40B4-BE49-F238E27FC236}">
-                <a16:creationId xmlns:a16="http://schemas.microsoft.com/office/drawing/2014/main" id="{BBBECD30-0871-49F0-A47F-A089B4BFFAA3}"/>
+                <a16:creationId xmlns:a16="http://schemas.microsoft.com/office/drawing/2014/main" id="{9B540B75-8315-4E0D-B001-8AE2067E13B6}"/>
               </a:ext>
             </a:extLst>
           </p:cNvPr>
@@ -2701,7 +2701,7 @@
           <p:cNvPr id="7" name="text-5">
             <a:extLst xmlns:a="http://schemas.openxmlformats.org/drawingml/2006/main">
               <a:ext uri="{FF2B5EF4-FFF2-40B4-BE49-F238E27FC236}">
-                <a16:creationId xmlns:a16="http://schemas.microsoft.com/office/drawing/2014/main" id="{A48AB5FA-D214-439C-97C8-214ADF6BBC7A}"/>
+                <a16:creationId xmlns:a16="http://schemas.microsoft.com/office/drawing/2014/main" id="{186EFC9C-8476-45C4-8D13-32D29D6A0E14}"/>
               </a:ext>
             </a:extLst>
           </p:cNvPr>
@@ -2756,7 +2756,7 @@
     </p:spTree>
     <p:extLst>
       <p:ext uri="{BB962C8B-B14F-4D97-AF65-F5344CB8AC3E}">
-        <p14:creationId xmlns:p14="http://schemas.microsoft.com/office/powerpoint/2010/main" val="2106018228"/>
+        <p14:creationId xmlns:p14="http://schemas.microsoft.com/office/powerpoint/2010/main" val="1743621669"/>
       </p:ext>
     </p:extLst>
   </p:cSld>
@@ -2787,7 +2787,7 @@
           <p:cNvPr id="9" name="text-0">
             <a:extLst xmlns:a="http://schemas.openxmlformats.org/drawingml/2006/main">
               <a:ext uri="{FF2B5EF4-FFF2-40B4-BE49-F238E27FC236}">
-                <a16:creationId xmlns:a16="http://schemas.microsoft.com/office/drawing/2014/main" id="{62A2079C-077B-47B6-8873-686EE70B67E0}"/>
+                <a16:creationId xmlns:a16="http://schemas.microsoft.com/office/drawing/2014/main" id="{DC5738E2-26FE-4221-B148-5FABF293FB64}"/>
               </a:ext>
             </a:extLst>
           </p:cNvPr>
@@ -2844,7 +2844,7 @@
           <p:cNvPr id="2" name="text-1">
             <a:extLst xmlns:a="http://schemas.openxmlformats.org/drawingml/2006/main">
               <a:ext uri="{FF2B5EF4-FFF2-40B4-BE49-F238E27FC236}">
-                <a16:creationId xmlns:a16="http://schemas.microsoft.com/office/drawing/2014/main" id="{F79629C6-3BD0-4E4F-A304-5102CF1C9E91}"/>
+                <a16:creationId xmlns:a16="http://schemas.microsoft.com/office/drawing/2014/main" id="{1A41E0E5-DBDE-449B-A1EF-6C4B90B4A294}"/>
               </a:ext>
             </a:extLst>
           </p:cNvPr>
@@ -2901,7 +2901,7 @@
           <p:cNvPr id="3" name="text-2">
             <a:extLst xmlns:a="http://schemas.openxmlformats.org/drawingml/2006/main">
               <a:ext uri="{FF2B5EF4-FFF2-40B4-BE49-F238E27FC236}">
-                <a16:creationId xmlns:a16="http://schemas.microsoft.com/office/drawing/2014/main" id="{F3C3C124-CE45-48FA-9458-6491E975664D}"/>
+                <a16:creationId xmlns:a16="http://schemas.microsoft.com/office/drawing/2014/main" id="{DBCA69BB-21C2-48F5-81BF-03C970A8FCE3}"/>
               </a:ext>
             </a:extLst>
           </p:cNvPr>
@@ -2958,7 +2958,7 @@
           <p:cNvPr id="4" name="text-3">
             <a:extLst xmlns:a="http://schemas.openxmlformats.org/drawingml/2006/main">
               <a:ext uri="{FF2B5EF4-FFF2-40B4-BE49-F238E27FC236}">
-                <a16:creationId xmlns:a16="http://schemas.microsoft.com/office/drawing/2014/main" id="{6CCDF058-1B8F-4B0F-898E-7FC15A0CA51F}"/>
+                <a16:creationId xmlns:a16="http://schemas.microsoft.com/office/drawing/2014/main" id="{DAB38AED-F427-46BC-AC2F-55698CA085A1}"/>
               </a:ext>
             </a:extLst>
           </p:cNvPr>
@@ -4423,7 +4423,7 @@
           <p:cNvPr id="7" name="text-4">
             <a:extLst xmlns:a="http://schemas.openxmlformats.org/drawingml/2006/main">
               <a:ext uri="{FF2B5EF4-FFF2-40B4-BE49-F238E27FC236}">
-                <a16:creationId xmlns:a16="http://schemas.microsoft.com/office/drawing/2014/main" id="{E62E6CA2-4F0C-4319-831A-59D9CA48382E}"/>
+                <a16:creationId xmlns:a16="http://schemas.microsoft.com/office/drawing/2014/main" id="{09E38D2C-8431-4C6F-9234-DF9475ECDAFC}"/>
               </a:ext>
             </a:extLst>
           </p:cNvPr>
@@ -4480,7 +4480,7 @@
           <p:cNvPr id="8" name="text-5">
             <a:extLst xmlns:a="http://schemas.openxmlformats.org/drawingml/2006/main">
               <a:ext uri="{FF2B5EF4-FFF2-40B4-BE49-F238E27FC236}">
-                <a16:creationId xmlns:a16="http://schemas.microsoft.com/office/drawing/2014/main" id="{820EDCAC-877E-4D75-9D31-5B3629E5D17F}"/>
+                <a16:creationId xmlns:a16="http://schemas.microsoft.com/office/drawing/2014/main" id="{D238E72D-B98E-45F0-93AC-9D06EAD674E7}"/>
               </a:ext>
             </a:extLst>
           </p:cNvPr>
@@ -4535,7 +4535,7 @@
     </p:spTree>
     <p:extLst>
       <p:ext uri="{BB962C8B-B14F-4D97-AF65-F5344CB8AC3E}">
-        <p14:creationId xmlns:p14="http://schemas.microsoft.com/office/powerpoint/2010/main" val="1108896360"/>
+        <p14:creationId xmlns:p14="http://schemas.microsoft.com/office/powerpoint/2010/main" val="1270173299"/>
       </p:ext>
     </p:extLst>
   </p:cSld>
@@ -4566,7 +4566,7 @@
           <p:cNvPr id="8" name="text-0">
             <a:extLst xmlns:a="http://schemas.openxmlformats.org/drawingml/2006/main">
               <a:ext uri="{FF2B5EF4-FFF2-40B4-BE49-F238E27FC236}">
-                <a16:creationId xmlns:a16="http://schemas.microsoft.com/office/drawing/2014/main" id="{69283974-B2E1-4397-9C01-29F3DCF95E71}"/>
+                <a16:creationId xmlns:a16="http://schemas.microsoft.com/office/drawing/2014/main" id="{1E4C742B-0210-4263-B395-DEF5B01FEA43}"/>
               </a:ext>
             </a:extLst>
           </p:cNvPr>
@@ -4623,7 +4623,7 @@
           <p:cNvPr id="2" name="text-1">
             <a:extLst xmlns:a="http://schemas.openxmlformats.org/drawingml/2006/main">
               <a:ext uri="{FF2B5EF4-FFF2-40B4-BE49-F238E27FC236}">
-                <a16:creationId xmlns:a16="http://schemas.microsoft.com/office/drawing/2014/main" id="{6DD18307-2B63-4A7B-AA85-CAE722D8255A}"/>
+                <a16:creationId xmlns:a16="http://schemas.microsoft.com/office/drawing/2014/main" id="{45192F97-680A-4E7F-98D9-D29EE83B7782}"/>
               </a:ext>
             </a:extLst>
           </p:cNvPr>
@@ -4850,7 +4850,7 @@
                           <a:ea typeface="Arial"/>
                           <a:cs typeface="Arial"/>
                         </a:rPr>
-                        <a:t>2.500,00 kr.</a:t>
+                        <a:t>4.000,00 kr.</a:t>
                       </a:r>
                     </a:p>
                   </a:txBody>
@@ -4960,7 +4960,7 @@
                           <a:ea typeface="Arial"/>
                           <a:cs typeface="Arial"/>
                         </a:rPr>
-                        <a:t>7.500,00 kr.</a:t>
+                        <a:t>12.000,00 kr.</a:t>
                       </a:r>
                     </a:p>
                   </a:txBody>
@@ -5070,7 +5070,7 @@
                           <a:ea typeface="Arial"/>
                           <a:cs typeface="Arial"/>
                         </a:rPr>
-                        <a:t>25.000,00 kr.</a:t>
+                        <a:t>40.000,00 kr.</a:t>
                       </a:r>
                     </a:p>
                   </a:txBody>
@@ -5180,7 +5180,7 @@
                           <a:ea typeface="Arial"/>
                           <a:cs typeface="Arial"/>
                         </a:rPr>
-                        <a:t>50.000,00 kr.</a:t>
+                        <a:t>80.000,00 kr.</a:t>
                       </a:r>
                     </a:p>
                   </a:txBody>
@@ -5290,7 +5290,7 @@
                           <a:ea typeface="Arial"/>
                           <a:cs typeface="Arial"/>
                         </a:rPr>
-                        <a:t>125.000,00 kr.</a:t>
+                        <a:t>200.000,00 kr.</a:t>
                       </a:r>
                     </a:p>
                   </a:txBody>
@@ -5400,7 +5400,7 @@
                           <a:ea typeface="Arial"/>
                           <a:cs typeface="Arial"/>
                         </a:rPr>
-                        <a:t>250.000,00 kr.</a:t>
+                        <a:t>400.000,00 kr.</a:t>
                       </a:r>
                     </a:p>
                   </a:txBody>
@@ -5474,7 +5474,7 @@
           <p:cNvPr id="4" name="text-2">
             <a:extLst xmlns:a="http://schemas.openxmlformats.org/drawingml/2006/main">
               <a:ext uri="{FF2B5EF4-FFF2-40B4-BE49-F238E27FC236}">
-                <a16:creationId xmlns:a16="http://schemas.microsoft.com/office/drawing/2014/main" id="{83C0514B-A0C2-4423-9F4F-42D07F3B036E}"/>
+                <a16:creationId xmlns:a16="http://schemas.microsoft.com/office/drawing/2014/main" id="{ED1205F4-F315-4902-BEE5-B4DADB22ED49}"/>
               </a:ext>
             </a:extLst>
           </p:cNvPr>
@@ -5531,7 +5531,7 @@
           <p:cNvPr id="5" name="text-3">
             <a:extLst xmlns:a="http://schemas.openxmlformats.org/drawingml/2006/main">
               <a:ext uri="{FF2B5EF4-FFF2-40B4-BE49-F238E27FC236}">
-                <a16:creationId xmlns:a16="http://schemas.microsoft.com/office/drawing/2014/main" id="{EF181585-A20E-4ED6-A167-A778BF813963}"/>
+                <a16:creationId xmlns:a16="http://schemas.microsoft.com/office/drawing/2014/main" id="{3F5738C2-E59A-43D6-A031-A4492FB1CB75}"/>
               </a:ext>
             </a:extLst>
           </p:cNvPr>
@@ -5588,7 +5588,7 @@
           <p:cNvPr id="6" name="text-4">
             <a:extLst xmlns:a="http://schemas.openxmlformats.org/drawingml/2006/main">
               <a:ext uri="{FF2B5EF4-FFF2-40B4-BE49-F238E27FC236}">
-                <a16:creationId xmlns:a16="http://schemas.microsoft.com/office/drawing/2014/main" id="{3DA3C859-D755-44D4-837F-1025CE3AF0D6}"/>
+                <a16:creationId xmlns:a16="http://schemas.microsoft.com/office/drawing/2014/main" id="{7AB02DB7-07B4-4978-BD40-9E238DAFDD9C}"/>
               </a:ext>
             </a:extLst>
           </p:cNvPr>
@@ -5635,7 +5635,7 @@
                 <a:ea typeface="Arial"/>
                 <a:cs typeface="Arial"/>
               </a:rPr>
-              <a:t>Server tælles én gang pr. installation. 1-20: nuværende server. 50/100: større server med backup. Kapacitet er et skøn og skal belastningstestes. Ejerløn er 0,00 kr.</a:t>
+              <a:t>Server pr. installation. Kapacitet er et skøn og skal testes. Særtilbud i prisnoterne: 20 for 60.000,00 kr./md. (ikke indregnet i tabellen).</a:t>
             </a:r>
           </a:p>
         </p:txBody>
@@ -5645,7 +5645,7 @@
           <p:cNvPr id="7" name="text-5">
             <a:extLst xmlns:a="http://schemas.openxmlformats.org/drawingml/2006/main">
               <a:ext uri="{FF2B5EF4-FFF2-40B4-BE49-F238E27FC236}">
-                <a16:creationId xmlns:a16="http://schemas.microsoft.com/office/drawing/2014/main" id="{A06BEE9C-F207-4C48-BCE5-CB4B8B96C88B}"/>
+                <a16:creationId xmlns:a16="http://schemas.microsoft.com/office/drawing/2014/main" id="{25D81EDC-B27C-455E-9723-3764539303F9}"/>
               </a:ext>
             </a:extLst>
           </p:cNvPr>
@@ -5700,7 +5700,7 @@
     </p:spTree>
     <p:extLst>
       <p:ext uri="{BB962C8B-B14F-4D97-AF65-F5344CB8AC3E}">
-        <p14:creationId xmlns:p14="http://schemas.microsoft.com/office/powerpoint/2010/main" val="1145806071"/>
+        <p14:creationId xmlns:p14="http://schemas.microsoft.com/office/powerpoint/2010/main" val="1687153296"/>
       </p:ext>
     </p:extLst>
   </p:cSld>
@@ -5731,7 +5731,7 @@
           <p:cNvPr id="11" name="text-0">
             <a:extLst xmlns:a="http://schemas.openxmlformats.org/drawingml/2006/main">
               <a:ext uri="{FF2B5EF4-FFF2-40B4-BE49-F238E27FC236}">
-                <a16:creationId xmlns:a16="http://schemas.microsoft.com/office/drawing/2014/main" id="{CE93D4F3-228E-462A-91D2-314D27D904BE}"/>
+                <a16:creationId xmlns:a16="http://schemas.microsoft.com/office/drawing/2014/main" id="{12A0B964-5802-48F5-A603-A5E1387022EE}"/>
               </a:ext>
             </a:extLst>
           </p:cNvPr>
@@ -5788,7 +5788,7 @@
           <p:cNvPr id="2" name="text-1">
             <a:extLst xmlns:a="http://schemas.openxmlformats.org/drawingml/2006/main">
               <a:ext uri="{FF2B5EF4-FFF2-40B4-BE49-F238E27FC236}">
-                <a16:creationId xmlns:a16="http://schemas.microsoft.com/office/drawing/2014/main" id="{012B25CE-BB95-4E68-A3D1-04EBF696F137}"/>
+                <a16:creationId xmlns:a16="http://schemas.microsoft.com/office/drawing/2014/main" id="{E1B8FD38-02DD-4011-9AFB-E6E33B3C7EF9}"/>
               </a:ext>
             </a:extLst>
           </p:cNvPr>
@@ -5845,7 +5845,7 @@
           <p:cNvPr id="3" name="text-2">
             <a:extLst xmlns:a="http://schemas.openxmlformats.org/drawingml/2006/main">
               <a:ext uri="{FF2B5EF4-FFF2-40B4-BE49-F238E27FC236}">
-                <a16:creationId xmlns:a16="http://schemas.microsoft.com/office/drawing/2014/main" id="{F91E8B30-1F72-4FE1-9CD5-AAA7E8719ABE}"/>
+                <a16:creationId xmlns:a16="http://schemas.microsoft.com/office/drawing/2014/main" id="{0BA39600-3471-4FC6-97BD-2570F82A86C3}"/>
               </a:ext>
             </a:extLst>
           </p:cNvPr>
@@ -5902,7 +5902,7 @@
           <p:cNvPr id="4" name="text-3">
             <a:extLst xmlns:a="http://schemas.openxmlformats.org/drawingml/2006/main">
               <a:ext uri="{FF2B5EF4-FFF2-40B4-BE49-F238E27FC236}">
-                <a16:creationId xmlns:a16="http://schemas.microsoft.com/office/drawing/2014/main" id="{E3B4616A-D4B4-4851-AA3A-34A734272084}"/>
+                <a16:creationId xmlns:a16="http://schemas.microsoft.com/office/drawing/2014/main" id="{E074D570-5C47-43DB-BF51-E6609AED8D2F}"/>
               </a:ext>
             </a:extLst>
           </p:cNvPr>
@@ -6997,7 +6997,7 @@
           <p:cNvPr id="7" name="text-4">
             <a:extLst xmlns:a="http://schemas.openxmlformats.org/drawingml/2006/main">
               <a:ext uri="{FF2B5EF4-FFF2-40B4-BE49-F238E27FC236}">
-                <a16:creationId xmlns:a16="http://schemas.microsoft.com/office/drawing/2014/main" id="{641919CF-32BF-4337-8721-53A2D2B9D036}"/>
+                <a16:creationId xmlns:a16="http://schemas.microsoft.com/office/drawing/2014/main" id="{3F71EF64-15E6-45BB-8D9B-1344614C4537}"/>
               </a:ext>
             </a:extLst>
           </p:cNvPr>
@@ -7054,7 +7054,7 @@
           <p:cNvPr id="8" name="text-5">
             <a:extLst xmlns:a="http://schemas.openxmlformats.org/drawingml/2006/main">
               <a:ext uri="{FF2B5EF4-FFF2-40B4-BE49-F238E27FC236}">
-                <a16:creationId xmlns:a16="http://schemas.microsoft.com/office/drawing/2014/main" id="{84B39A13-489F-475B-BD44-659464B980D5}"/>
+                <a16:creationId xmlns:a16="http://schemas.microsoft.com/office/drawing/2014/main" id="{483A4F18-F556-4580-AC52-E2B140127D38}"/>
               </a:ext>
             </a:extLst>
           </p:cNvPr>
@@ -7111,7 +7111,7 @@
           <p:cNvPr id="9" name="text-6">
             <a:extLst xmlns:a="http://schemas.openxmlformats.org/drawingml/2006/main">
               <a:ext uri="{FF2B5EF4-FFF2-40B4-BE49-F238E27FC236}">
-                <a16:creationId xmlns:a16="http://schemas.microsoft.com/office/drawing/2014/main" id="{6CE395B0-9EF3-4C7E-899B-195645589873}"/>
+                <a16:creationId xmlns:a16="http://schemas.microsoft.com/office/drawing/2014/main" id="{9077B65A-031F-46E7-B2DE-5C93640E703D}"/>
               </a:ext>
             </a:extLst>
           </p:cNvPr>
@@ -7168,7 +7168,7 @@
           <p:cNvPr id="10" name="text-7">
             <a:extLst xmlns:a="http://schemas.openxmlformats.org/drawingml/2006/main">
               <a:ext uri="{FF2B5EF4-FFF2-40B4-BE49-F238E27FC236}">
-                <a16:creationId xmlns:a16="http://schemas.microsoft.com/office/drawing/2014/main" id="{5B1D0A17-88C5-49F5-9749-1318966E55CE}"/>
+                <a16:creationId xmlns:a16="http://schemas.microsoft.com/office/drawing/2014/main" id="{3C5213B5-A4A8-45AB-BAC9-C394AF1DA0D6}"/>
               </a:ext>
             </a:extLst>
           </p:cNvPr>
@@ -7223,7 +7223,7 @@
     </p:spTree>
     <p:extLst>
       <p:ext uri="{BB962C8B-B14F-4D97-AF65-F5344CB8AC3E}">
-        <p14:creationId xmlns:p14="http://schemas.microsoft.com/office/powerpoint/2010/main" val="1599580337"/>
+        <p14:creationId xmlns:p14="http://schemas.microsoft.com/office/powerpoint/2010/main" val="650283283"/>
       </p:ext>
     </p:extLst>
   </p:cSld>
@@ -7254,7 +7254,7 @@
           <p:cNvPr id="12" name="text-0">
             <a:extLst xmlns:a="http://schemas.openxmlformats.org/drawingml/2006/main">
               <a:ext uri="{FF2B5EF4-FFF2-40B4-BE49-F238E27FC236}">
-                <a16:creationId xmlns:a16="http://schemas.microsoft.com/office/drawing/2014/main" id="{377AF0C9-25AB-4E2F-A79E-EF0030A13432}"/>
+                <a16:creationId xmlns:a16="http://schemas.microsoft.com/office/drawing/2014/main" id="{AA2B8C19-D484-4126-8DCD-B9DC6A358BF7}"/>
               </a:ext>
             </a:extLst>
           </p:cNvPr>
@@ -7311,7 +7311,7 @@
           <p:cNvPr id="2" name="text-1">
             <a:extLst xmlns:a="http://schemas.openxmlformats.org/drawingml/2006/main">
               <a:ext uri="{FF2B5EF4-FFF2-40B4-BE49-F238E27FC236}">
-                <a16:creationId xmlns:a16="http://schemas.microsoft.com/office/drawing/2014/main" id="{3FA6749B-9E52-4954-A86E-BBF4B7B5E11D}"/>
+                <a16:creationId xmlns:a16="http://schemas.microsoft.com/office/drawing/2014/main" id="{9C4D7A07-DC83-48D7-9166-9D79B128985E}"/>
               </a:ext>
             </a:extLst>
           </p:cNvPr>
@@ -7368,7 +7368,7 @@
           <p:cNvPr id="3" name="text-2">
             <a:extLst xmlns:a="http://schemas.openxmlformats.org/drawingml/2006/main">
               <a:ext uri="{FF2B5EF4-FFF2-40B4-BE49-F238E27FC236}">
-                <a16:creationId xmlns:a16="http://schemas.microsoft.com/office/drawing/2014/main" id="{DCEF0553-1E71-4123-BFB7-B5CC2A472DC8}"/>
+                <a16:creationId xmlns:a16="http://schemas.microsoft.com/office/drawing/2014/main" id="{AD8DFC92-420D-4520-A91F-2879F802D45D}"/>
               </a:ext>
             </a:extLst>
           </p:cNvPr>
@@ -7425,7 +7425,7 @@
           <p:cNvPr id="4" name="text-3">
             <a:extLst xmlns:a="http://schemas.openxmlformats.org/drawingml/2006/main">
               <a:ext uri="{FF2B5EF4-FFF2-40B4-BE49-F238E27FC236}">
-                <a16:creationId xmlns:a16="http://schemas.microsoft.com/office/drawing/2014/main" id="{B87E9EEE-F3C1-491D-9A04-C49EA4AD072A}"/>
+                <a16:creationId xmlns:a16="http://schemas.microsoft.com/office/drawing/2014/main" id="{27D9398D-2508-427E-A387-2B4ABD85C8F0}"/>
               </a:ext>
             </a:extLst>
           </p:cNvPr>
@@ -7946,7 +7946,7 @@
           <p:cNvPr id="6" name="text-4">
             <a:extLst xmlns:a="http://schemas.openxmlformats.org/drawingml/2006/main">
               <a:ext uri="{FF2B5EF4-FFF2-40B4-BE49-F238E27FC236}">
-                <a16:creationId xmlns:a16="http://schemas.microsoft.com/office/drawing/2014/main" id="{62FDDD47-A8ED-423E-8FF2-6AE639D508B7}"/>
+                <a16:creationId xmlns:a16="http://schemas.microsoft.com/office/drawing/2014/main" id="{2AFBA6BB-AC91-4CB0-9209-F3B286B8046B}"/>
               </a:ext>
             </a:extLst>
           </p:cNvPr>
@@ -8471,7 +8471,7 @@
                           <a:ea typeface="Arial"/>
                           <a:cs typeface="Arial"/>
                         </a:rPr>
-                        <a:t>24.400,00 kr.</a:t>
+                        <a:t>28.900,00 kr.</a:t>
                       </a:r>
                     </a:p>
                   </a:txBody>
@@ -8583,7 +8583,7 @@
                           <a:ea typeface="Arial"/>
                           <a:cs typeface="Arial"/>
                         </a:rPr>
-                        <a:t>14.215,19 kr.</a:t>
+                        <a:t>18.715,19 kr.</a:t>
                       </a:r>
                     </a:p>
                   </a:txBody>
@@ -8751,7 +8751,7 @@
                           <a:ea typeface="Arial"/>
                           <a:cs typeface="Arial"/>
                         </a:rPr>
-                        <a:t>13.640,59 kr.</a:t>
+                        <a:t>18.140,59 kr.</a:t>
                       </a:r>
                     </a:p>
                   </a:txBody>
@@ -8771,7 +8771,7 @@
           <p:cNvPr id="9" name="text-5">
             <a:extLst xmlns:a="http://schemas.openxmlformats.org/drawingml/2006/main">
               <a:ext uri="{FF2B5EF4-FFF2-40B4-BE49-F238E27FC236}">
-                <a16:creationId xmlns:a16="http://schemas.microsoft.com/office/drawing/2014/main" id="{0F26AA71-C065-449A-9363-E249EDB2BBA1}"/>
+                <a16:creationId xmlns:a16="http://schemas.microsoft.com/office/drawing/2014/main" id="{0EEDF52D-8DE9-423E-BC7C-85180A06011B}"/>
               </a:ext>
             </a:extLst>
           </p:cNvPr>
@@ -8818,7 +8818,7 @@
                 <a:ea typeface="Arial"/>
                 <a:cs typeface="Arial"/>
               </a:rPr>
-              <a:t>Dækningsgrad: 58,3 %</a:t>
+              <a:t>Dækningsgrad: 64,8 %</a:t>
             </a:r>
           </a:p>
         </p:txBody>
@@ -8828,7 +8828,7 @@
           <p:cNvPr id="10" name="text-6">
             <a:extLst xmlns:a="http://schemas.openxmlformats.org/drawingml/2006/main">
               <a:ext uri="{FF2B5EF4-FFF2-40B4-BE49-F238E27FC236}">
-                <a16:creationId xmlns:a16="http://schemas.microsoft.com/office/drawing/2014/main" id="{E9437AF3-077D-4AA5-8CE5-117F78537768}"/>
+                <a16:creationId xmlns:a16="http://schemas.microsoft.com/office/drawing/2014/main" id="{41B0E2AB-7AEB-435C-886D-70FBBBBEF7D3}"/>
               </a:ext>
             </a:extLst>
           </p:cNvPr>
@@ -8875,7 +8875,7 @@
                 <a:ea typeface="Arial"/>
                 <a:cs typeface="Arial"/>
               </a:rPr>
-              <a:t>Månedsindtægt: 7.500,00 kr. abonnement + 12.000,00 kr. AI + 4.900,00 kr. omstilling. Ingen SMS, partner eller gebyr. Resultat før skat er efter de viste budgetudgifter.</a:t>
+              <a:t>Månedsindtægt: 12.000,00 kr. abonnement + 12.000,00 kr. AI + 4.900,00 kr. omstilling. Ingen SMS, partner eller gebyr. Resultat før skat er efter de viste budgetudgifter.</a:t>
             </a:r>
           </a:p>
         </p:txBody>
@@ -8885,7 +8885,7 @@
           <p:cNvPr id="11" name="text-7">
             <a:extLst xmlns:a="http://schemas.openxmlformats.org/drawingml/2006/main">
               <a:ext uri="{FF2B5EF4-FFF2-40B4-BE49-F238E27FC236}">
-                <a16:creationId xmlns:a16="http://schemas.microsoft.com/office/drawing/2014/main" id="{0BD0C247-DE41-4F02-A2E7-B4D3116ED024}"/>
+                <a16:creationId xmlns:a16="http://schemas.microsoft.com/office/drawing/2014/main" id="{ACD45954-BADD-4E4E-BDCC-A8469B0FF8F6}"/>
               </a:ext>
             </a:extLst>
           </p:cNvPr>
@@ -8940,7 +8940,7 @@
     </p:spTree>
     <p:extLst>
       <p:ext uri="{BB962C8B-B14F-4D97-AF65-F5344CB8AC3E}">
-        <p14:creationId xmlns:p14="http://schemas.microsoft.com/office/powerpoint/2010/main" val="53765680"/>
+        <p14:creationId xmlns:p14="http://schemas.microsoft.com/office/powerpoint/2010/main" val="1805737555"/>
       </p:ext>
     </p:extLst>
   </p:cSld>
@@ -8971,7 +8971,7 @@
           <p:cNvPr id="8" name="text-0">
             <a:extLst xmlns:a="http://schemas.openxmlformats.org/drawingml/2006/main">
               <a:ext uri="{FF2B5EF4-FFF2-40B4-BE49-F238E27FC236}">
-                <a16:creationId xmlns:a16="http://schemas.microsoft.com/office/drawing/2014/main" id="{F2A893D9-B10A-4F3A-8720-011685B1BA86}"/>
+                <a16:creationId xmlns:a16="http://schemas.microsoft.com/office/drawing/2014/main" id="{4EAB44B4-EAE0-4457-B8F0-E9DDE7A30694}"/>
               </a:ext>
             </a:extLst>
           </p:cNvPr>
@@ -9028,7 +9028,7 @@
           <p:cNvPr id="2" name="text-1">
             <a:extLst xmlns:a="http://schemas.openxmlformats.org/drawingml/2006/main">
               <a:ext uri="{FF2B5EF4-FFF2-40B4-BE49-F238E27FC236}">
-                <a16:creationId xmlns:a16="http://schemas.microsoft.com/office/drawing/2014/main" id="{3987B66D-0F5D-4CB9-8824-78A4B83DDDD6}"/>
+                <a16:creationId xmlns:a16="http://schemas.microsoft.com/office/drawing/2014/main" id="{43BDA6A4-699E-4550-9EA1-7AF85C6B7A77}"/>
               </a:ext>
             </a:extLst>
           </p:cNvPr>
@@ -9283,7 +9283,7 @@
                           <a:ea typeface="Arial"/>
                           <a:cs typeface="Arial"/>
                         </a:rPr>
-                        <a:t>10.950,00 kr.</a:t>
+                        <a:t>12.450,00 kr.</a:t>
                       </a:r>
                     </a:p>
                   </a:txBody>
@@ -9337,7 +9337,7 @@
                           <a:ea typeface="Arial"/>
                           <a:cs typeface="Arial"/>
                         </a:rPr>
-                        <a:t>5.809,22 kr.</a:t>
+                        <a:t>7.309,22 kr.</a:t>
                       </a:r>
                     </a:p>
                   </a:txBody>
@@ -9364,7 +9364,7 @@
                           <a:ea typeface="Arial"/>
                           <a:cs typeface="Arial"/>
                         </a:rPr>
-                        <a:t>5.234,62 kr.</a:t>
+                        <a:t>6.734,62 kr.</a:t>
                       </a:r>
                     </a:p>
                   </a:txBody>
@@ -9420,7 +9420,7 @@
                           <a:ea typeface="Arial"/>
                           <a:cs typeface="Arial"/>
                         </a:rPr>
-                        <a:t>24.400,00 kr.</a:t>
+                        <a:t>28.900,00 kr.</a:t>
                       </a:r>
                     </a:p>
                   </a:txBody>
@@ -9474,7 +9474,7 @@
                           <a:ea typeface="Arial"/>
                           <a:cs typeface="Arial"/>
                         </a:rPr>
-                        <a:t>14.215,19 kr.</a:t>
+                        <a:t>18.715,19 kr.</a:t>
                       </a:r>
                     </a:p>
                   </a:txBody>
@@ -9501,7 +9501,7 @@
                           <a:ea typeface="Arial"/>
                           <a:cs typeface="Arial"/>
                         </a:rPr>
-                        <a:t>13.640,59 kr.</a:t>
+                        <a:t>18.140,59 kr.</a:t>
                       </a:r>
                     </a:p>
                   </a:txBody>
@@ -9557,7 +9557,7 @@
                           <a:ea typeface="Arial"/>
                           <a:cs typeface="Arial"/>
                         </a:rPr>
-                        <a:t>41.300,00 kr.</a:t>
+                        <a:t>45.800,00 kr.</a:t>
                       </a:r>
                     </a:p>
                   </a:txBody>
@@ -9611,7 +9611,7 @@
                           <a:ea typeface="Arial"/>
                           <a:cs typeface="Arial"/>
                         </a:rPr>
-                        <a:t>21.027,13 kr.</a:t>
+                        <a:t>25.527,13 kr.</a:t>
                       </a:r>
                     </a:p>
                   </a:txBody>
@@ -9638,7 +9638,7 @@
                           <a:ea typeface="Arial"/>
                           <a:cs typeface="Arial"/>
                         </a:rPr>
-                        <a:t>20.452,53 kr.</a:t>
+                        <a:t>24.952,53 kr.</a:t>
                       </a:r>
                     </a:p>
                   </a:txBody>
@@ -9694,7 +9694,7 @@
                           <a:ea typeface="Arial"/>
                           <a:cs typeface="Arial"/>
                         </a:rPr>
-                        <a:t>219.000,00 kr.</a:t>
+                        <a:t>249.000,00 kr.</a:t>
                       </a:r>
                     </a:p>
                   </a:txBody>
@@ -9748,7 +9748,7 @@
                           <a:ea typeface="Arial"/>
                           <a:cs typeface="Arial"/>
                         </a:rPr>
-                        <a:t>118.022,67 kr.</a:t>
+                        <a:t>148.022,67 kr.</a:t>
                       </a:r>
                     </a:p>
                   </a:txBody>
@@ -9775,7 +9775,7 @@
                           <a:ea typeface="Arial"/>
                           <a:cs typeface="Arial"/>
                         </a:rPr>
-                        <a:t>117.448,07 kr.</a:t>
+                        <a:t>147.448,07 kr.</a:t>
                       </a:r>
                     </a:p>
                   </a:txBody>
@@ -9795,7 +9795,7 @@
           <p:cNvPr id="4" name="text-2">
             <a:extLst xmlns:a="http://schemas.openxmlformats.org/drawingml/2006/main">
               <a:ext uri="{FF2B5EF4-FFF2-40B4-BE49-F238E27FC236}">
-                <a16:creationId xmlns:a16="http://schemas.microsoft.com/office/drawing/2014/main" id="{356CEAEC-CB01-4B95-8AE7-7298C3EA3989}"/>
+                <a16:creationId xmlns:a16="http://schemas.microsoft.com/office/drawing/2014/main" id="{DCAD3A6E-84FD-4BDE-9607-AEF606D5A0EB}"/>
               </a:ext>
             </a:extLst>
           </p:cNvPr>
@@ -10049,7 +10049,7 @@
                           <a:ea typeface="Arial"/>
                           <a:cs typeface="Arial"/>
                         </a:rPr>
-                        <a:t>14.215,19 kr.</a:t>
+                        <a:t>18.715,19 kr.</a:t>
                       </a:r>
                     </a:p>
                   </a:txBody>
@@ -10076,7 +10076,7 @@
                           <a:ea typeface="Arial"/>
                           <a:cs typeface="Arial"/>
                         </a:rPr>
-                        <a:t>13.640,59 kr.</a:t>
+                        <a:t>18.140,59 kr.</a:t>
                       </a:r>
                     </a:p>
                   </a:txBody>
@@ -10132,7 +10132,7 @@
                           <a:ea typeface="Arial"/>
                           <a:cs typeface="Arial"/>
                         </a:rPr>
-                        <a:t>750,00 kr.</a:t>
+                        <a:t>1.200,00 kr.</a:t>
                       </a:r>
                     </a:p>
                   </a:txBody>
@@ -10159,7 +10159,7 @@
                           <a:ea typeface="Arial"/>
                           <a:cs typeface="Arial"/>
                         </a:rPr>
-                        <a:t>13.465,19 kr.</a:t>
+                        <a:t>17.515,19 kr.</a:t>
                       </a:r>
                     </a:p>
                   </a:txBody>
@@ -10186,7 +10186,7 @@
                           <a:ea typeface="Arial"/>
                           <a:cs typeface="Arial"/>
                         </a:rPr>
-                        <a:t>12.890,59 kr.</a:t>
+                        <a:t>16.940,59 kr.</a:t>
                       </a:r>
                     </a:p>
                   </a:txBody>
@@ -10242,7 +10242,7 @@
                           <a:ea typeface="Arial"/>
                           <a:cs typeface="Arial"/>
                         </a:rPr>
-                        <a:t>1.500,00 kr.</a:t>
+                        <a:t>2.400,00 kr.</a:t>
                       </a:r>
                     </a:p>
                   </a:txBody>
@@ -10269,7 +10269,7 @@
                           <a:ea typeface="Arial"/>
                           <a:cs typeface="Arial"/>
                         </a:rPr>
-                        <a:t>12.715,19 kr.</a:t>
+                        <a:t>16.315,19 kr.</a:t>
                       </a:r>
                     </a:p>
                   </a:txBody>
@@ -10296,7 +10296,7 @@
                           <a:ea typeface="Arial"/>
                           <a:cs typeface="Arial"/>
                         </a:rPr>
-                        <a:t>12.140,59 kr.</a:t>
+                        <a:t>15.740,59 kr.</a:t>
                       </a:r>
                     </a:p>
                   </a:txBody>
@@ -10352,7 +10352,7 @@
                           <a:ea typeface="Arial"/>
                           <a:cs typeface="Arial"/>
                         </a:rPr>
-                        <a:t>2.250,00 kr.</a:t>
+                        <a:t>3.600,00 kr.</a:t>
                       </a:r>
                     </a:p>
                   </a:txBody>
@@ -10379,7 +10379,7 @@
                           <a:ea typeface="Arial"/>
                           <a:cs typeface="Arial"/>
                         </a:rPr>
-                        <a:t>11.965,19 kr.</a:t>
+                        <a:t>15.115,19 kr.</a:t>
                       </a:r>
                     </a:p>
                   </a:txBody>
@@ -10406,7 +10406,7 @@
                           <a:ea typeface="Arial"/>
                           <a:cs typeface="Arial"/>
                         </a:rPr>
-                        <a:t>11.390,59 kr.</a:t>
+                        <a:t>14.540,59 kr.</a:t>
                       </a:r>
                     </a:p>
                   </a:txBody>
@@ -10426,7 +10426,7 @@
           <p:cNvPr id="6" name="text-3">
             <a:extLst xmlns:a="http://schemas.openxmlformats.org/drawingml/2006/main">
               <a:ext uri="{FF2B5EF4-FFF2-40B4-BE49-F238E27FC236}">
-                <a16:creationId xmlns:a16="http://schemas.microsoft.com/office/drawing/2014/main" id="{56EA876F-D53B-411E-84C5-FA836EF18E57}"/>
+                <a16:creationId xmlns:a16="http://schemas.microsoft.com/office/drawing/2014/main" id="{6803AD6A-FECE-451C-905A-DC4AF194992D}"/>
               </a:ext>
             </a:extLst>
           </p:cNvPr>
@@ -10483,7 +10483,7 @@
           <p:cNvPr id="7" name="text-4">
             <a:extLst xmlns:a="http://schemas.openxmlformats.org/drawingml/2006/main">
               <a:ext uri="{FF2B5EF4-FFF2-40B4-BE49-F238E27FC236}">
-                <a16:creationId xmlns:a16="http://schemas.microsoft.com/office/drawing/2014/main" id="{CCEFB067-83AD-4DD4-9956-2458CA6D5D1B}"/>
+                <a16:creationId xmlns:a16="http://schemas.microsoft.com/office/drawing/2014/main" id="{A48D90C0-F720-4CCA-8CCA-9AF2397353E9}"/>
               </a:ext>
             </a:extLst>
           </p:cNvPr>
@@ -10538,7 +10538,7 @@
     </p:spTree>
     <p:extLst>
       <p:ext uri="{BB962C8B-B14F-4D97-AF65-F5344CB8AC3E}">
-        <p14:creationId xmlns:p14="http://schemas.microsoft.com/office/powerpoint/2010/main" val="1990820436"/>
+        <p14:creationId xmlns:p14="http://schemas.microsoft.com/office/powerpoint/2010/main" val="2138203747"/>
       </p:ext>
     </p:extLst>
   </p:cSld>
@@ -10569,7 +10569,7 @@
           <p:cNvPr id="8" name="text-0">
             <a:extLst xmlns:a="http://schemas.openxmlformats.org/drawingml/2006/main">
               <a:ext uri="{FF2B5EF4-FFF2-40B4-BE49-F238E27FC236}">
-                <a16:creationId xmlns:a16="http://schemas.microsoft.com/office/drawing/2014/main" id="{B64FFECD-BA2D-40D1-A765-F711D2FA0A39}"/>
+                <a16:creationId xmlns:a16="http://schemas.microsoft.com/office/drawing/2014/main" id="{7260A2CA-FDC8-4443-84C1-4BE4B159348E}"/>
               </a:ext>
             </a:extLst>
           </p:cNvPr>
@@ -10626,7 +10626,7 @@
           <p:cNvPr id="2" name="text-1">
             <a:extLst xmlns:a="http://schemas.openxmlformats.org/drawingml/2006/main">
               <a:ext uri="{FF2B5EF4-FFF2-40B4-BE49-F238E27FC236}">
-                <a16:creationId xmlns:a16="http://schemas.microsoft.com/office/drawing/2014/main" id="{8C5A0F5F-AFFD-4DB7-BF4F-E54BD2B9969D}"/>
+                <a16:creationId xmlns:a16="http://schemas.microsoft.com/office/drawing/2014/main" id="{7F54E440-8D67-43F6-BA08-9FDF76DF5893}"/>
               </a:ext>
             </a:extLst>
           </p:cNvPr>
@@ -10929,7 +10929,7 @@
           <p:cNvPr id="4" name="text-2">
             <a:extLst xmlns:a="http://schemas.openxmlformats.org/drawingml/2006/main">
               <a:ext uri="{FF2B5EF4-FFF2-40B4-BE49-F238E27FC236}">
-                <a16:creationId xmlns:a16="http://schemas.microsoft.com/office/drawing/2014/main" id="{D2ED21D6-C45C-4960-863D-FA583969BA5F}"/>
+                <a16:creationId xmlns:a16="http://schemas.microsoft.com/office/drawing/2014/main" id="{2AAFD2DE-EBD9-4CF5-BAA8-B49325D5213B}"/>
               </a:ext>
             </a:extLst>
           </p:cNvPr>
@@ -10986,7 +10986,7 @@
           <p:cNvPr id="5" name="text-3">
             <a:extLst xmlns:a="http://schemas.openxmlformats.org/drawingml/2006/main">
               <a:ext uri="{FF2B5EF4-FFF2-40B4-BE49-F238E27FC236}">
-                <a16:creationId xmlns:a16="http://schemas.microsoft.com/office/drawing/2014/main" id="{73604ED0-98A3-489D-BDE2-D2964FDBFD50}"/>
+                <a16:creationId xmlns:a16="http://schemas.microsoft.com/office/drawing/2014/main" id="{309A6B1D-F587-482E-B6A2-A9E712F7ABB1}"/>
               </a:ext>
             </a:extLst>
           </p:cNvPr>
@@ -11043,7 +11043,7 @@
           <p:cNvPr id="6" name="text-4">
             <a:extLst xmlns:a="http://schemas.openxmlformats.org/drawingml/2006/main">
               <a:ext uri="{FF2B5EF4-FFF2-40B4-BE49-F238E27FC236}">
-                <a16:creationId xmlns:a16="http://schemas.microsoft.com/office/drawing/2014/main" id="{558ED535-0EE3-4E46-A3FA-F0F25AB3DA3A}"/>
+                <a16:creationId xmlns:a16="http://schemas.microsoft.com/office/drawing/2014/main" id="{41DBBBBC-4A08-4E63-BC42-90325C59EBDA}"/>
               </a:ext>
             </a:extLst>
           </p:cNvPr>
@@ -11100,7 +11100,7 @@
           <p:cNvPr id="7" name="text-5">
             <a:extLst xmlns:a="http://schemas.openxmlformats.org/drawingml/2006/main">
               <a:ext uri="{FF2B5EF4-FFF2-40B4-BE49-F238E27FC236}">
-                <a16:creationId xmlns:a16="http://schemas.microsoft.com/office/drawing/2014/main" id="{B87BDF39-6BB9-4513-B323-37594BDD9725}"/>
+                <a16:creationId xmlns:a16="http://schemas.microsoft.com/office/drawing/2014/main" id="{77A1E2FD-42AB-47A7-99C4-F4FEDDE88237}"/>
               </a:ext>
             </a:extLst>
           </p:cNvPr>
@@ -11155,7 +11155,7 @@
     </p:spTree>
     <p:extLst>
       <p:ext uri="{BB962C8B-B14F-4D97-AF65-F5344CB8AC3E}">
-        <p14:creationId xmlns:p14="http://schemas.microsoft.com/office/powerpoint/2010/main" val="1590230613"/>
+        <p14:creationId xmlns:p14="http://schemas.microsoft.com/office/powerpoint/2010/main" val="1566418322"/>
       </p:ext>
     </p:extLst>
   </p:cSld>

</xml_diff>

<commit_message>
Forkort tekster og vis delsummer i prisoverblikket
</commit_message>
<xml_diff>
--- a/INTELLI-prispraesentation.pptx
+++ b/INTELLI-prispraesentation.pptx
@@ -2,19 +2,19 @@
 <file path=ppt/presentation.xml><?xml version="1.0" encoding="utf-8"?>
 <p:presentation xmlns:p="http://schemas.openxmlformats.org/presentationml/2006/main">
   <p:sldMasterIdLst>
-    <p:sldMasterId xmlns:r="http://schemas.openxmlformats.org/officeDocument/2006/relationships" id="2147483648" r:id="Re6d7ada5152e4515"/>
+    <p:sldMasterId xmlns:r="http://schemas.openxmlformats.org/officeDocument/2006/relationships" id="2147483648" r:id="Rf03b35ddd93b42a5"/>
   </p:sldMasterIdLst>
   <p:notesMasterIdLst>
-    <p:notesMasterId xmlns:r="http://schemas.openxmlformats.org/officeDocument/2006/relationships" r:id="R1d48dfa83f4b4d0c"/>
+    <p:notesMasterId xmlns:r="http://schemas.openxmlformats.org/officeDocument/2006/relationships" r:id="R196100ddefac4f47"/>
   </p:notesMasterIdLst>
   <p:sldIdLst>
-    <p:sldId xmlns:r="http://schemas.openxmlformats.org/officeDocument/2006/relationships" id="256" r:id="R6e0fb86974c24b56"/>
-    <p:sldId xmlns:r="http://schemas.openxmlformats.org/officeDocument/2006/relationships" id="257" r:id="R14910541b5214c82"/>
-    <p:sldId xmlns:r="http://schemas.openxmlformats.org/officeDocument/2006/relationships" id="258" r:id="R42dabc04472e4d5b"/>
-    <p:sldId xmlns:r="http://schemas.openxmlformats.org/officeDocument/2006/relationships" id="259" r:id="R5a088be0462d494a"/>
-    <p:sldId xmlns:r="http://schemas.openxmlformats.org/officeDocument/2006/relationships" id="260" r:id="R101c42ff079f40c1"/>
-    <p:sldId xmlns:r="http://schemas.openxmlformats.org/officeDocument/2006/relationships" id="261" r:id="Rcd9f3ef3bfe941d5"/>
-    <p:sldId xmlns:r="http://schemas.openxmlformats.org/officeDocument/2006/relationships" id="262" r:id="Rf9026ff58684434d"/>
+    <p:sldId xmlns:r="http://schemas.openxmlformats.org/officeDocument/2006/relationships" id="256" r:id="R653ac8390bfc4a1a"/>
+    <p:sldId xmlns:r="http://schemas.openxmlformats.org/officeDocument/2006/relationships" id="257" r:id="R0d27069714cc47d6"/>
+    <p:sldId xmlns:r="http://schemas.openxmlformats.org/officeDocument/2006/relationships" id="258" r:id="R434a5e0ef9e5489c"/>
+    <p:sldId xmlns:r="http://schemas.openxmlformats.org/officeDocument/2006/relationships" id="259" r:id="Rdee70810185243dd"/>
+    <p:sldId xmlns:r="http://schemas.openxmlformats.org/officeDocument/2006/relationships" id="260" r:id="Rb32698d8086a42d1"/>
+    <p:sldId xmlns:r="http://schemas.openxmlformats.org/officeDocument/2006/relationships" id="261" r:id="R289d153a5e444c46"/>
+    <p:sldId xmlns:r="http://schemas.openxmlformats.org/officeDocument/2006/relationships" id="262" r:id="R9049923bc6024c88"/>
   </p:sldIdLst>
   <p:sldSz cx="12192000" cy="6858000"/>
   <p:notesSz cx="6858000" cy="9144000"/>
@@ -463,7 +463,7 @@
           </a:p>
           <a:p xmlns:a="http://schemas.openxmlformats.org/drawingml/2006/main">
             <a:r>
-              <a:t>AI-kost er inkl. 20 % reserve og indgående telefoni. Første minut: AI 0,22 kr. + SIP 0,04 kr. Hver fase afregnes pr. påbegyndt minut.</a:t>
+              <a:t>Første minut: AI 0,22 + telefoni 0,04 = 0,26 kr. (inkl. 20 % AI-reserve). DB = salg - kost, før fast drift. Påbegyndte minutter.</a:t>
             </a:r>
           </a:p>
           <a:p xmlns:a="http://schemas.openxmlformats.org/drawingml/2006/main">
@@ -573,7 +573,7 @@
           </a:p>
           <a:p xmlns:a="http://schemas.openxmlformats.org/drawingml/2006/main">
             <a:r>
-              <a:t>Samme budgetprofil: 3 svar/min., 40 % AI-tale, 4.000 prompttokens, fuldt streamet input og genlæst historik. 20 % reserve. Alle beregninger bruger uafrundede beløb.</a:t>
+              <a:t>Skøn: 3 svar/min., 40 % AI-tale, 4.000 prompttokens og fuld inputstream. Historik genlæses. Beløb beregnes før afrunding.</a:t>
             </a:r>
           </a:p>
           <a:p xmlns:a="http://schemas.openxmlformats.org/drawingml/2006/main">
@@ -683,7 +683,7 @@
           </a:p>
           <a:p xmlns:a="http://schemas.openxmlformats.org/drawingml/2006/main">
             <a:r>
-              <a:t>Server pr. installation. Kapacitet er et skøn og skal testes. Særtilbud i prisnoterne: 20 for 60.000,00 kr./md. (ikke indregnet i tabellen).</a:t>
+              <a:t>Server regnes én gang pr. installation. Kapacitet er skøn. Særtilbud: 20 for 60.000,00 kr./md. er ikke indregnet her.</a:t>
             </a:r>
           </a:p>
           <a:p xmlns:a="http://schemas.openxmlformats.org/drawingml/2006/main">
@@ -783,7 +783,7 @@
           </a:p>
           <a:p xmlns:a="http://schemas.openxmlformats.org/drawingml/2006/main">
             <a:r>
-              <a:t>SMS-robot: 299,00 kr./md. + 0,10 kr./AI-svar + SMS ind/ud. Eksemplet inkluderer 1.000 indgående og 1.000 udgående Twilio-segmenter. Pakkerne er separate fra telefoncases.</a:t>
+              <a:t>Kost summeres før afrunding. Ekstra AI-mail: 0,15 kr./behandling; webchat: 0,25 kr./svar. Pakkerne er tillæg til telefoni.</a:t>
             </a:r>
           </a:p>
           <a:p xmlns:a="http://schemas.openxmlformats.org/drawingml/2006/main">
@@ -893,7 +893,12 @@
           </a:p>
           <a:p xmlns:a="http://schemas.openxmlformats.org/drawingml/2006/main">
             <a:r>
-              <a:t>Månedsindtægt: 12.000,00 kr. abonnement + 12.000,00 kr. AI + 4.900,00 kr. omstilling. Ingen SMS, partner eller gebyr. Resultat før skat er efter de viste budgetudgifter.</a:t>
+              <a:t>Kost = AI 6.276,11 + omstilling 3.811,95 + nummer 96,75 = 10.184,81 kr.</a:t>
+            </a:r>
+          </a:p>
+          <a:p xmlns:a="http://schemas.openxmlformats.org/drawingml/2006/main">
+            <a:r>
+              <a:t>Månedstotaler beregnes før afrunding. Ingen SMS, partner eller gebyr.</a:t>
             </a:r>
           </a:p>
           <a:p xmlns:a="http://schemas.openxmlformats.org/drawingml/2006/main">
@@ -993,7 +998,7 @@
           </a:p>
           <a:p xmlns:a="http://schemas.openxmlformats.org/drawingml/2006/main">
             <a:r>
-              <a:t>Scenarier: ingen SMS, gebyr eller ejerløn. Resultat er efter server 74,60 kr. og support 500,00 kr. i hvert selvstændigt scenarie. Partnerprovision er endnu ikke aftalt.</a:t>
+              <a:t>Resultat = DB - server 74,60 kr. - supportreserve 500,00 kr. Ingen SMS, gebyr eller ejerløn. Partnerprovision er ikke aftalt.</a:t>
             </a:r>
           </a:p>
           <a:p xmlns:a="http://schemas.openxmlformats.org/drawingml/2006/main">
@@ -1088,7 +1093,7 @@
           </a:p>
           <a:p xmlns:a="http://schemas.openxmlformats.org/drawingml/2006/main">
             <a:r>
-              <a:t>Regnegrundlag og kilder: badlegion.github.io/intelli-prisark/gemini.html. Opstart, særlige integrationer, SLA, udvikling og ikke-oplyst arbejde er ikke prissat.</a:t>
+              <a:t>Kilder: badlegion.github.io/intelli-prisark/GRUNDLAG.md. Opstart, integrationer, SLA og udvikling er ikke prissat.</a:t>
             </a:r>
           </a:p>
           <a:p xmlns:a="http://schemas.openxmlformats.org/drawingml/2006/main">
@@ -1181,7 +1186,7 @@
   </p:cSld>
   <p:clrMap bg1="lt1" tx1="dk1" bg2="lt2" tx2="dk2" accent1="accent1" accent2="accent2" accent3="accent3" accent4="accent4" accent5="accent5" accent6="accent6" hlink="hlink" folHlink="folHlink"/>
   <p:sldLayoutIdLst>
-    <p:sldLayoutId xmlns:r="http://schemas.openxmlformats.org/officeDocument/2006/relationships" id="2147483649" r:id="R8f73cd9b09c0406b"/>
+    <p:sldLayoutId xmlns:r="http://schemas.openxmlformats.org/officeDocument/2006/relationships" id="2147483649" r:id="Rdabcc02d35004cb1"/>
   </p:sldLayoutIdLst>
   <p:txStyles>
     <p:titleStyle>
@@ -1732,7 +1737,7 @@
           <p:cNvPr id="8" name="text-0">
             <a:extLst xmlns:a="http://schemas.openxmlformats.org/drawingml/2006/main">
               <a:ext uri="{FF2B5EF4-FFF2-40B4-BE49-F238E27FC236}">
-                <a16:creationId xmlns:a16="http://schemas.microsoft.com/office/drawing/2014/main" id="{A1814253-FBC7-4319-ACEB-5783086C2EEA}"/>
+                <a16:creationId xmlns:a16="http://schemas.microsoft.com/office/drawing/2014/main" id="{61CA852B-717B-4B65-8D90-52BB43E5C1D7}"/>
               </a:ext>
             </a:extLst>
           </p:cNvPr>
@@ -1789,7 +1794,7 @@
           <p:cNvPr id="2" name="text-1">
             <a:extLst xmlns:a="http://schemas.openxmlformats.org/drawingml/2006/main">
               <a:ext uri="{FF2B5EF4-FFF2-40B4-BE49-F238E27FC236}">
-                <a16:creationId xmlns:a16="http://schemas.microsoft.com/office/drawing/2014/main" id="{EA94C800-8F3A-4811-BE79-93958D46D09F}"/>
+                <a16:creationId xmlns:a16="http://schemas.microsoft.com/office/drawing/2014/main" id="{4D4700D3-A82E-487E-AFA1-A329E4603F1B}"/>
               </a:ext>
             </a:extLst>
           </p:cNvPr>
@@ -1836,7 +1841,7 @@
                 <a:ea typeface="Arial"/>
                 <a:cs typeface="Arial"/>
               </a:rPr>
-              <a:t>Gemini. DKK ekskl. moms. Foreløbigt kostbudget og faste salgsforslag.</a:t>
+              <a:t>Gemini. DKK ekskl. moms. Kost er budget; salg er vores prisforslag.</a:t>
             </a:r>
           </a:p>
         </p:txBody>
@@ -2530,7 +2535,7 @@
           <p:cNvPr id="4" name="text-2">
             <a:extLst xmlns:a="http://schemas.openxmlformats.org/drawingml/2006/main">
               <a:ext uri="{FF2B5EF4-FFF2-40B4-BE49-F238E27FC236}">
-                <a16:creationId xmlns:a16="http://schemas.microsoft.com/office/drawing/2014/main" id="{F6AD6EC1-6247-470A-A4C0-0DFF0556AF74}"/>
+                <a16:creationId xmlns:a16="http://schemas.microsoft.com/office/drawing/2014/main" id="{553DA515-C73E-4F33-AF4D-4AECCE465319}"/>
               </a:ext>
             </a:extLst>
           </p:cNvPr>
@@ -2587,7 +2592,7 @@
           <p:cNvPr id="5" name="text-3">
             <a:extLst xmlns:a="http://schemas.openxmlformats.org/drawingml/2006/main">
               <a:ext uri="{FF2B5EF4-FFF2-40B4-BE49-F238E27FC236}">
-                <a16:creationId xmlns:a16="http://schemas.microsoft.com/office/drawing/2014/main" id="{B8AEA6C8-FF58-4C2D-B358-6F5F63E597E3}"/>
+                <a16:creationId xmlns:a16="http://schemas.microsoft.com/office/drawing/2014/main" id="{8F83680D-AC38-4765-9A90-48D38A5A0552}"/>
               </a:ext>
             </a:extLst>
           </p:cNvPr>
@@ -2634,7 +2639,7 @@
                 <a:ea typeface="Arial"/>
                 <a:cs typeface="Arial"/>
               </a:rPr>
-              <a:t>Højst 8 min. AI, derefter betalt omstilling. Ingen inkluderede minutter.</a:t>
+              <a:t>Maks. 8 min. AI, så betalt omstilling. Ingen inkluderede minutter.</a:t>
             </a:r>
           </a:p>
         </p:txBody>
@@ -2644,7 +2649,7 @@
           <p:cNvPr id="6" name="text-4">
             <a:extLst xmlns:a="http://schemas.openxmlformats.org/drawingml/2006/main">
               <a:ext uri="{FF2B5EF4-FFF2-40B4-BE49-F238E27FC236}">
-                <a16:creationId xmlns:a16="http://schemas.microsoft.com/office/drawing/2014/main" id="{9B540B75-8315-4E0D-B001-8AE2067E13B6}"/>
+                <a16:creationId xmlns:a16="http://schemas.microsoft.com/office/drawing/2014/main" id="{7CA13A54-213D-46D0-80CF-C0570FD3BFC4}"/>
               </a:ext>
             </a:extLst>
           </p:cNvPr>
@@ -2691,7 +2696,7 @@
                 <a:ea typeface="Arial"/>
                 <a:cs typeface="Arial"/>
               </a:rPr>
-              <a:t>AI-kost er inkl. 20 % reserve og indgående telefoni. Første minut: AI 0,22 kr. + SIP 0,04 kr. Hver fase afregnes pr. påbegyndt minut.</a:t>
+              <a:t>Første minut: AI 0,22 + telefoni 0,04 = 0,26 kr. (inkl. 20 % AI-reserve). DB = salg - kost, før fast drift. Påbegyndte minutter.</a:t>
             </a:r>
           </a:p>
         </p:txBody>
@@ -2701,7 +2706,7 @@
           <p:cNvPr id="7" name="text-5">
             <a:extLst xmlns:a="http://schemas.openxmlformats.org/drawingml/2006/main">
               <a:ext uri="{FF2B5EF4-FFF2-40B4-BE49-F238E27FC236}">
-                <a16:creationId xmlns:a16="http://schemas.microsoft.com/office/drawing/2014/main" id="{186EFC9C-8476-45C4-8D13-32D29D6A0E14}"/>
+                <a16:creationId xmlns:a16="http://schemas.microsoft.com/office/drawing/2014/main" id="{AEDEC147-DB13-4E64-B995-63BB8E172C92}"/>
               </a:ext>
             </a:extLst>
           </p:cNvPr>
@@ -2756,7 +2761,7 @@
     </p:spTree>
     <p:extLst>
       <p:ext uri="{BB962C8B-B14F-4D97-AF65-F5344CB8AC3E}">
-        <p14:creationId xmlns:p14="http://schemas.microsoft.com/office/powerpoint/2010/main" val="1743621669"/>
+        <p14:creationId xmlns:p14="http://schemas.microsoft.com/office/powerpoint/2010/main" val="654183626"/>
       </p:ext>
     </p:extLst>
   </p:cSld>
@@ -2784,10 +2789,10 @@
       </p:grpSpPr>
       <p:sp>
         <p:nvSpPr>
-          <p:cNvPr id="9" name="text-0">
+          <p:cNvPr id="11" name="text-0">
             <a:extLst xmlns:a="http://schemas.openxmlformats.org/drawingml/2006/main">
               <a:ext uri="{FF2B5EF4-FFF2-40B4-BE49-F238E27FC236}">
-                <a16:creationId xmlns:a16="http://schemas.microsoft.com/office/drawing/2014/main" id="{DC5738E2-26FE-4221-B148-5FABF293FB64}"/>
+                <a16:creationId xmlns:a16="http://schemas.microsoft.com/office/drawing/2014/main" id="{CCF8A2E0-A60C-47D9-A6D9-D9A36104E9D0}"/>
               </a:ext>
             </a:extLst>
           </p:cNvPr>
@@ -2834,7 +2839,7 @@
                 <a:ea typeface="Arial"/>
                 <a:cs typeface="Arial"/>
               </a:rPr>
-              <a:t>AI-kost og udvikling under samtalen</a:t>
+              <a:t>AI-kost fra første til sidste minut</a:t>
             </a:r>
           </a:p>
         </p:txBody>
@@ -2844,7 +2849,7 @@
           <p:cNvPr id="2" name="text-1">
             <a:extLst xmlns:a="http://schemas.openxmlformats.org/drawingml/2006/main">
               <a:ext uri="{FF2B5EF4-FFF2-40B4-BE49-F238E27FC236}">
-                <a16:creationId xmlns:a16="http://schemas.microsoft.com/office/drawing/2014/main" id="{1A41E0E5-DBDE-449B-A1EF-6C4B90B4A294}"/>
+                <a16:creationId xmlns:a16="http://schemas.microsoft.com/office/drawing/2014/main" id="{5EB76E09-F61E-41FF-8B66-8DE45F986FF6}"/>
               </a:ext>
             </a:extLst>
           </p:cNvPr>
@@ -2891,7 +2896,7 @@
                 <a:ea typeface="Arial"/>
                 <a:cs typeface="Arial"/>
               </a:rPr>
-              <a:t>8 minutter koster 6,28 kr. i alt. Gennemsnittet er 0,78 kr./min.</a:t>
+              <a:t>Hele AI-fasen: 6,28 kr. for 8 min. Gennemsnit: 0,78 kr./min.</a:t>
             </a:r>
           </a:p>
         </p:txBody>
@@ -2901,7 +2906,7 @@
           <p:cNvPr id="3" name="text-2">
             <a:extLst xmlns:a="http://schemas.openxmlformats.org/drawingml/2006/main">
               <a:ext uri="{FF2B5EF4-FFF2-40B4-BE49-F238E27FC236}">
-                <a16:creationId xmlns:a16="http://schemas.microsoft.com/office/drawing/2014/main" id="{DBCA69BB-21C2-48F5-81BF-03C970A8FCE3}"/>
+                <a16:creationId xmlns:a16="http://schemas.microsoft.com/office/drawing/2014/main" id="{264F539C-1F96-4F8B-9C2A-7C4A18274424}"/>
               </a:ext>
             </a:extLst>
           </p:cNvPr>
@@ -2948,7 +2953,7 @@
                 <a:ea typeface="Arial"/>
                 <a:cs typeface="Arial"/>
               </a:rPr>
-              <a:t>Kost for hele AI-fasen på 8 min.</a:t>
+              <a:t>Kost for 8 min. AI</a:t>
             </a:r>
           </a:p>
         </p:txBody>
@@ -2958,7 +2963,7 @@
           <p:cNvPr id="4" name="text-3">
             <a:extLst xmlns:a="http://schemas.openxmlformats.org/drawingml/2006/main">
               <a:ext uri="{FF2B5EF4-FFF2-40B4-BE49-F238E27FC236}">
-                <a16:creationId xmlns:a16="http://schemas.microsoft.com/office/drawing/2014/main" id="{DAB38AED-F427-46BC-AC2F-55698CA085A1}"/>
+                <a16:creationId xmlns:a16="http://schemas.microsoft.com/office/drawing/2014/main" id="{6ED5AE9B-9593-443C-9732-C4876F2350FA}"/>
               </a:ext>
             </a:extLst>
           </p:cNvPr>
@@ -3005,14 +3010,14 @@
                 <a:ea typeface="Arial"/>
                 <a:cs typeface="Arial"/>
               </a:rPr>
-              <a:t>Stigning i samme samtale</a:t>
+              <a:t>Kost minut for minut</a:t>
             </a:r>
           </a:p>
         </p:txBody>
       </p:sp>
       <p:graphicFrame>
         <p:nvGraphicFramePr>
-          <p:cNvPr id="13" name=""/>
+          <p:cNvPr id="15" name=""/>
           <p:cNvGraphicFramePr/>
           <p:nvPr/>
         </p:nvGraphicFramePr>
@@ -3102,7 +3107,7 @@
                           <a:ea typeface="Arial"/>
                           <a:cs typeface="Arial"/>
                         </a:rPr>
-                        <a:t>Ny lyd ind</a:t>
+                        <a:t>+ Ny lyd ind</a:t>
                       </a:r>
                     </a:p>
                   </a:txBody>
@@ -3158,7 +3163,7 @@
                           <a:ea typeface="Arial"/>
                           <a:cs typeface="Arial"/>
                         </a:rPr>
-                        <a:t>Lydhistorik læst igen</a:t>
+                        <a:t>+ Lydhistorik læst igen</a:t>
                       </a:r>
                     </a:p>
                   </a:txBody>
@@ -3214,7 +3219,7 @@
                           <a:ea typeface="Arial"/>
                           <a:cs typeface="Arial"/>
                         </a:rPr>
-                        <a:t>AI-stemme ud</a:t>
+                        <a:t>+ AI-stemme ud</a:t>
                       </a:r>
                     </a:p>
                   </a:txBody>
@@ -3270,7 +3275,7 @@
                           <a:ea typeface="Arial"/>
                           <a:cs typeface="Arial"/>
                         </a:rPr>
-                        <a:t>Prompt og værktøjer · første gang</a:t>
+                        <a:t>+ Prompt og værktøjer · første gang</a:t>
                       </a:r>
                     </a:p>
                   </a:txBody>
@@ -3326,7 +3331,7 @@
                           <a:ea typeface="Arial"/>
                           <a:cs typeface="Arial"/>
                         </a:rPr>
-                        <a:t>Prompt og teksthistorik læst igen</a:t>
+                        <a:t>+ Prompt og teksthistorik læst igen</a:t>
                       </a:r>
                     </a:p>
                   </a:txBody>
@@ -3382,7 +3387,7 @@
                           <a:ea typeface="Arial"/>
                           <a:cs typeface="Arial"/>
                         </a:rPr>
-                        <a:t>Tekst / transskription ud</a:t>
+                        <a:t>+ Tekst / transskription ud</a:t>
                       </a:r>
                     </a:p>
                   </a:txBody>
@@ -3430,34 +3435,34 @@
                     <a:p>
                       <a:pPr algn="l"/>
                       <a:r>
-                        <a:rPr sz="1500" b="0">
-                          <a:solidFill>
-                            <a:srgbClr val="173745"/>
-                          </a:solidFill>
-                          <a:latin typeface="Arial"/>
-                          <a:ea typeface="Arial"/>
-                          <a:cs typeface="Arial"/>
-                        </a:rPr>
-                        <a:t>AI før reserve (delsum)</a:t>
-                      </a:r>
-                    </a:p>
-                  </a:txBody>
-                  <a:tcPr marL="91440" marR="91440" marT="45720" marB="45720" anchor="ctr">
-                    <a:solidFill>
-                      <a:srgbClr val="FFFFFF"/>
-                    </a:solidFill>
-                  </a:tcPr>
-                </a:tc>
-                <a:tc>
-                  <a:txBody>
-                    <a:bodyPr lIns="123825" tIns="47625" rIns="123825" bIns="47625">
-                      <a:noAutofit/>
-                    </a:bodyPr>
-                    <a:lstStyle/>
-                    <a:p>
-                      <a:pPr algn="r"/>
-                      <a:r>
-                        <a:rPr sz="1500" b="0">
+                        <a:rPr sz="1500" b="1">
+                          <a:solidFill>
+                            <a:srgbClr val="173745"/>
+                          </a:solidFill>
+                          <a:latin typeface="Arial"/>
+                          <a:ea typeface="Arial"/>
+                          <a:cs typeface="Arial"/>
+                        </a:rPr>
+                        <a:t>= AI-delsum</a:t>
+                      </a:r>
+                    </a:p>
+                  </a:txBody>
+                  <a:tcPr marL="91440" marR="91440" marT="45720" marB="45720" anchor="ctr">
+                    <a:solidFill>
+                      <a:srgbClr val="EAF4F1"/>
+                    </a:solidFill>
+                  </a:tcPr>
+                </a:tc>
+                <a:tc>
+                  <a:txBody>
+                    <a:bodyPr lIns="123825" tIns="47625" rIns="123825" bIns="47625">
+                      <a:noAutofit/>
+                    </a:bodyPr>
+                    <a:lstStyle/>
+                    <a:p>
+                      <a:pPr algn="r"/>
+                      <a:r>
+                        <a:rPr sz="1500" b="1">
                           <a:solidFill>
                             <a:srgbClr val="173745"/>
                           </a:solidFill>
@@ -3471,7 +3476,7 @@
                   </a:txBody>
                   <a:tcPr marL="91440" marR="91440" marT="45720" marB="45720" anchor="ctr">
                     <a:solidFill>
-                      <a:srgbClr val="FFFFFF"/>
+                      <a:srgbClr val="EAF4F1"/>
                     </a:solidFill>
                   </a:tcPr>
                 </a:tc>
@@ -3494,7 +3499,7 @@
                           <a:ea typeface="Arial"/>
                           <a:cs typeface="Arial"/>
                         </a:rPr>
-                        <a:t>AI-reserve, 20 %</a:t>
+                        <a:t>+ Reserve, 20 %</a:t>
                       </a:r>
                     </a:p>
                   </a:txBody>
@@ -3550,7 +3555,7 @@
                           <a:ea typeface="Arial"/>
                           <a:cs typeface="Arial"/>
                         </a:rPr>
-                        <a:t>Indgående SIP, 8 min.</a:t>
+                        <a:t>+ Telefoni, 8 min.</a:t>
                       </a:r>
                     </a:p>
                   </a:txBody>
@@ -3606,7 +3611,7 @@
                           <a:ea typeface="Arial"/>
                           <a:cs typeface="Arial"/>
                         </a:rPr>
-                        <a:t>Samlet kost</a:t>
+                        <a:t>= Samlet kost</a:t>
                       </a:r>
                     </a:p>
                   </a:txBody>
@@ -3650,7 +3655,7 @@
       </p:graphicFrame>
       <p:graphicFrame>
         <p:nvGraphicFramePr>
-          <p:cNvPr id="14" name=""/>
+          <p:cNvPr id="16" name=""/>
           <p:cNvGraphicFramePr/>
           <p:nvPr/>
         </p:nvGraphicFramePr>
@@ -3712,7 +3717,7 @@
                           <a:ea typeface="Arial"/>
                           <a:cs typeface="Arial"/>
                         </a:rPr>
-                        <a:t>Seneste minut</a:t>
+                        <a:t>Dette minut</a:t>
                       </a:r>
                     </a:p>
                   </a:txBody>
@@ -3739,7 +3744,7 @@
                           <a:ea typeface="Arial"/>
                           <a:cs typeface="Arial"/>
                         </a:rPr>
-                        <a:t>Kost i alt</a:t>
+                        <a:t>Indtil nu</a:t>
                       </a:r>
                     </a:p>
                   </a:txBody>
@@ -4423,7 +4428,121 @@
           <p:cNvPr id="7" name="text-4">
             <a:extLst xmlns:a="http://schemas.openxmlformats.org/drawingml/2006/main">
               <a:ext uri="{FF2B5EF4-FFF2-40B4-BE49-F238E27FC236}">
-                <a16:creationId xmlns:a16="http://schemas.microsoft.com/office/drawing/2014/main" id="{09E38D2C-8431-4C6F-9234-DF9475ECDAFC}"/>
+                <a16:creationId xmlns:a16="http://schemas.microsoft.com/office/drawing/2014/main" id="{5DB7FDDA-05C0-4F60-95DC-AEC5A1FB29E4}"/>
+              </a:ext>
+            </a:extLst>
+          </p:cNvPr>
+          <p:cNvSpPr>
+            <a:spLocks xmlns:a="http://schemas.openxmlformats.org/drawingml/2006/main" noGrp="1"/>
+          </p:cNvSpPr>
+          <p:nvPr/>
+        </p:nvSpPr>
+        <p:spPr>
+          <a:xfrm xmlns:a="http://schemas.openxmlformats.org/drawingml/2006/main">
+            <a:off x="6753225" y="5591175"/>
+            <a:ext cx="4829175" cy="285750"/>
+          </a:xfrm>
+          <a:prstGeom xmlns:a="http://schemas.openxmlformats.org/drawingml/2006/main" prst="rect">
+            <a:avLst/>
+          </a:prstGeom>
+          <a:noFill xmlns:a="http://schemas.openxmlformats.org/drawingml/2006/main"/>
+          <a:ln xmlns:a="http://schemas.openxmlformats.org/drawingml/2006/main" w="0">
+            <a:noFill/>
+          </a:ln>
+        </p:spPr>
+        <p:txBody>
+          <a:bodyPr xmlns:a="http://schemas.openxmlformats.org/drawingml/2006/main" lIns="0" tIns="0" rIns="0" bIns="0" anchor="t">
+            <a:noAutofit/>
+          </a:bodyPr>
+          <a:lstStyle xmlns:a="http://schemas.openxmlformats.org/drawingml/2006/main"/>
+          <a:p xmlns:a="http://schemas.openxmlformats.org/drawingml/2006/main">
+            <a:pPr algn="l">
+              <a:defRPr sz="1350" b="0">
+                <a:solidFill>
+                  <a:srgbClr val="173745"/>
+                </a:solidFill>
+                <a:latin typeface="Arial"/>
+                <a:ea typeface="Arial"/>
+                <a:cs typeface="Arial"/>
+              </a:defRPr>
+            </a:pPr>
+            <a:r>
+              <a:rPr sz="1350" b="0">
+                <a:solidFill>
+                  <a:srgbClr val="173745"/>
+                </a:solidFill>
+                <a:latin typeface="Arial"/>
+                <a:ea typeface="Arial"/>
+                <a:cs typeface="Arial"/>
+              </a:rPr>
+              <a:t>Indtil nu = summen af minutterne</a:t>
+            </a:r>
+          </a:p>
+        </p:txBody>
+      </p:sp>
+      <p:sp>
+        <p:nvSpPr>
+          <p:cNvPr id="8" name="text-5">
+            <a:extLst xmlns:a="http://schemas.openxmlformats.org/drawingml/2006/main">
+              <a:ext uri="{FF2B5EF4-FFF2-40B4-BE49-F238E27FC236}">
+                <a16:creationId xmlns:a16="http://schemas.microsoft.com/office/drawing/2014/main" id="{ED18F613-61CD-4245-91EA-9E992692167F}"/>
+              </a:ext>
+            </a:extLst>
+          </p:cNvPr>
+          <p:cNvSpPr>
+            <a:spLocks xmlns:a="http://schemas.openxmlformats.org/drawingml/2006/main" noGrp="1"/>
+          </p:cNvSpPr>
+          <p:nvPr/>
+        </p:nvSpPr>
+        <p:spPr>
+          <a:xfrm xmlns:a="http://schemas.openxmlformats.org/drawingml/2006/main">
+            <a:off x="609600" y="5772150"/>
+            <a:ext cx="5857875" cy="247650"/>
+          </a:xfrm>
+          <a:prstGeom xmlns:a="http://schemas.openxmlformats.org/drawingml/2006/main" prst="rect">
+            <a:avLst/>
+          </a:prstGeom>
+          <a:noFill xmlns:a="http://schemas.openxmlformats.org/drawingml/2006/main"/>
+          <a:ln xmlns:a="http://schemas.openxmlformats.org/drawingml/2006/main" w="0">
+            <a:noFill/>
+          </a:ln>
+        </p:spPr>
+        <p:txBody>
+          <a:bodyPr xmlns:a="http://schemas.openxmlformats.org/drawingml/2006/main" lIns="0" tIns="0" rIns="0" bIns="0" anchor="t">
+            <a:noAutofit/>
+          </a:bodyPr>
+          <a:lstStyle xmlns:a="http://schemas.openxmlformats.org/drawingml/2006/main"/>
+          <a:p xmlns:a="http://schemas.openxmlformats.org/drawingml/2006/main">
+            <a:pPr algn="l">
+              <a:defRPr sz="1350" b="1">
+                <a:solidFill>
+                  <a:srgbClr val="173745"/>
+                </a:solidFill>
+                <a:latin typeface="Arial"/>
+                <a:ea typeface="Arial"/>
+                <a:cs typeface="Arial"/>
+              </a:defRPr>
+            </a:pPr>
+            <a:r>
+              <a:rPr sz="1350" b="1">
+                <a:solidFill>
+                  <a:srgbClr val="173745"/>
+                </a:solidFill>
+                <a:latin typeface="Arial"/>
+                <a:ea typeface="Arial"/>
+                <a:cs typeface="Arial"/>
+              </a:rPr>
+              <a:t>4,94 + 0,99 + 0,35 = 6,28 kr.</a:t>
+            </a:r>
+          </a:p>
+        </p:txBody>
+      </p:sp>
+      <p:sp>
+        <p:nvSpPr>
+          <p:cNvPr id="9" name="text-6">
+            <a:extLst xmlns:a="http://schemas.openxmlformats.org/drawingml/2006/main">
+              <a:ext uri="{FF2B5EF4-FFF2-40B4-BE49-F238E27FC236}">
+                <a16:creationId xmlns:a16="http://schemas.microsoft.com/office/drawing/2014/main" id="{D48E9C33-C6F6-4C01-A86E-815DE9DD6B55}"/>
               </a:ext>
             </a:extLst>
           </p:cNvPr>
@@ -4470,17 +4589,17 @@
                 <a:ea typeface="Arial"/>
                 <a:cs typeface="Arial"/>
               </a:rPr>
-              <a:t>Samme budgetprofil: 3 svar/min., 40 % AI-tale, 4.000 prompttokens, fuldt streamet input og genlæst historik. 20 % reserve. Alle beregninger bruger uafrundede beløb.</a:t>
+              <a:t>Skøn: 3 svar/min., 40 % AI-tale, 4.000 prompttokens og fuld inputstream. Historik genlæses. Beløb beregnes før afrunding.</a:t>
             </a:r>
           </a:p>
         </p:txBody>
       </p:sp>
       <p:sp>
         <p:nvSpPr>
-          <p:cNvPr id="8" name="text-5">
+          <p:cNvPr id="10" name="text-7">
             <a:extLst xmlns:a="http://schemas.openxmlformats.org/drawingml/2006/main">
               <a:ext uri="{FF2B5EF4-FFF2-40B4-BE49-F238E27FC236}">
-                <a16:creationId xmlns:a16="http://schemas.microsoft.com/office/drawing/2014/main" id="{D238E72D-B98E-45F0-93AC-9D06EAD674E7}"/>
+                <a16:creationId xmlns:a16="http://schemas.microsoft.com/office/drawing/2014/main" id="{D573E0EE-39DA-43B8-A8B3-8E368951BA7F}"/>
               </a:ext>
             </a:extLst>
           </p:cNvPr>
@@ -4535,7 +4654,7 @@
     </p:spTree>
     <p:extLst>
       <p:ext uri="{BB962C8B-B14F-4D97-AF65-F5344CB8AC3E}">
-        <p14:creationId xmlns:p14="http://schemas.microsoft.com/office/powerpoint/2010/main" val="1270173299"/>
+        <p14:creationId xmlns:p14="http://schemas.microsoft.com/office/powerpoint/2010/main" val="885359281"/>
       </p:ext>
     </p:extLst>
   </p:cSld>
@@ -4566,7 +4685,7 @@
           <p:cNvPr id="8" name="text-0">
             <a:extLst xmlns:a="http://schemas.openxmlformats.org/drawingml/2006/main">
               <a:ext uri="{FF2B5EF4-FFF2-40B4-BE49-F238E27FC236}">
-                <a16:creationId xmlns:a16="http://schemas.microsoft.com/office/drawing/2014/main" id="{1E4C742B-0210-4263-B395-DEF5B01FEA43}"/>
+                <a16:creationId xmlns:a16="http://schemas.microsoft.com/office/drawing/2014/main" id="{859D4DE5-885C-4420-8361-516A2F7C7890}"/>
               </a:ext>
             </a:extLst>
           </p:cNvPr>
@@ -4613,7 +4732,7 @@
                 <a:ea typeface="Arial"/>
                 <a:cs typeface="Arial"/>
               </a:rPr>
-              <a:t>Digitale medarbejdere og fast drift</a:t>
+              <a:t>Abonnement og faste udgifter</a:t>
             </a:r>
           </a:p>
         </p:txBody>
@@ -4623,7 +4742,7 @@
           <p:cNvPr id="2" name="text-1">
             <a:extLst xmlns:a="http://schemas.openxmlformats.org/drawingml/2006/main">
               <a:ext uri="{FF2B5EF4-FFF2-40B4-BE49-F238E27FC236}">
-                <a16:creationId xmlns:a16="http://schemas.microsoft.com/office/drawing/2014/main" id="{45192F97-680A-4E7F-98D9-D29EE83B7782}"/>
+                <a16:creationId xmlns:a16="http://schemas.microsoft.com/office/drawing/2014/main" id="{59D72BDF-9F7A-43CC-A8EE-612C63C13C66}"/>
               </a:ext>
             </a:extLst>
           </p:cNvPr>
@@ -4670,7 +4789,7 @@
                 <a:ea typeface="Arial"/>
                 <a:cs typeface="Arial"/>
               </a:rPr>
-              <a:t>Én digital medarbejder giver plads til én samtidig kundesamtale, også under omstilling.</a:t>
+              <a:t>Abonnement = antal × 4.000,00 kr./md. Én medarbejder = én samtidig samtale, også ved omstilling.</a:t>
             </a:r>
           </a:p>
         </p:txBody>
@@ -4740,7 +4859,7 @@
                           <a:ea typeface="Arial"/>
                           <a:cs typeface="Arial"/>
                         </a:rPr>
-                        <a:t>Kundens abonnement / md.</a:t>
+                        <a:t>Abonnement / md.</a:t>
                       </a:r>
                     </a:p>
                   </a:txBody>
@@ -5474,7 +5593,7 @@
           <p:cNvPr id="4" name="text-2">
             <a:extLst xmlns:a="http://schemas.openxmlformats.org/drawingml/2006/main">
               <a:ext uri="{FF2B5EF4-FFF2-40B4-BE49-F238E27FC236}">
-                <a16:creationId xmlns:a16="http://schemas.microsoft.com/office/drawing/2014/main" id="{ED1205F4-F315-4902-BEE5-B4DADB22ED49}"/>
+                <a16:creationId xmlns:a16="http://schemas.microsoft.com/office/drawing/2014/main" id="{D6A6578F-FC22-4A4B-A081-93160F2FEAFA}"/>
               </a:ext>
             </a:extLst>
           </p:cNvPr>
@@ -5521,7 +5640,7 @@
                 <a:ea typeface="Arial"/>
                 <a:cs typeface="Arial"/>
               </a:rPr>
-              <a:t>Pr. kunde: mobilnummer 96,75 kr. / md. + supportreserve 500,00 kr. / md.</a:t>
+              <a:t>Nummer 96,75 kr. + supportreserve 500,00 kr. = 596,75 kr. / kunde / md.</a:t>
             </a:r>
           </a:p>
         </p:txBody>
@@ -5531,7 +5650,7 @@
           <p:cNvPr id="5" name="text-3">
             <a:extLst xmlns:a="http://schemas.openxmlformats.org/drawingml/2006/main">
               <a:ext uri="{FF2B5EF4-FFF2-40B4-BE49-F238E27FC236}">
-                <a16:creationId xmlns:a16="http://schemas.microsoft.com/office/drawing/2014/main" id="{3F5738C2-E59A-43D6-A031-A4492FB1CB75}"/>
+                <a16:creationId xmlns:a16="http://schemas.microsoft.com/office/drawing/2014/main" id="{5C8E83C5-6899-4654-8B7B-4A783A039CA7}"/>
               </a:ext>
             </a:extLst>
           </p:cNvPr>
@@ -5578,7 +5697,7 @@
                 <a:ea typeface="Arial"/>
                 <a:cs typeface="Arial"/>
               </a:rPr>
-              <a:t>Ét nummer er inkluderet i abonnementet. 24/7-tilgængelighed. Minutter betales separat.</a:t>
+              <a:t>Kunden får 24/7 og ét nummer; minutter betales separat. Server og kanalleje kommer oveni vores kost.</a:t>
             </a:r>
           </a:p>
         </p:txBody>
@@ -5588,7 +5707,7 @@
           <p:cNvPr id="6" name="text-4">
             <a:extLst xmlns:a="http://schemas.openxmlformats.org/drawingml/2006/main">
               <a:ext uri="{FF2B5EF4-FFF2-40B4-BE49-F238E27FC236}">
-                <a16:creationId xmlns:a16="http://schemas.microsoft.com/office/drawing/2014/main" id="{7AB02DB7-07B4-4978-BD40-9E238DAFDD9C}"/>
+                <a16:creationId xmlns:a16="http://schemas.microsoft.com/office/drawing/2014/main" id="{CCAEA86C-DDF0-4647-AF5A-CE5C862EFF8A}"/>
               </a:ext>
             </a:extLst>
           </p:cNvPr>
@@ -5635,7 +5754,7 @@
                 <a:ea typeface="Arial"/>
                 <a:cs typeface="Arial"/>
               </a:rPr>
-              <a:t>Server pr. installation. Kapacitet er et skøn og skal testes. Særtilbud i prisnoterne: 20 for 60.000,00 kr./md. (ikke indregnet i tabellen).</a:t>
+              <a:t>Server regnes én gang pr. installation. Kapacitet er skøn. Særtilbud: 20 for 60.000,00 kr./md. er ikke indregnet her.</a:t>
             </a:r>
           </a:p>
         </p:txBody>
@@ -5645,7 +5764,7 @@
           <p:cNvPr id="7" name="text-5">
             <a:extLst xmlns:a="http://schemas.openxmlformats.org/drawingml/2006/main">
               <a:ext uri="{FF2B5EF4-FFF2-40B4-BE49-F238E27FC236}">
-                <a16:creationId xmlns:a16="http://schemas.microsoft.com/office/drawing/2014/main" id="{25D81EDC-B27C-455E-9723-3764539303F9}"/>
+                <a16:creationId xmlns:a16="http://schemas.microsoft.com/office/drawing/2014/main" id="{C9714AD0-5046-4104-A484-8846EF8ABA24}"/>
               </a:ext>
             </a:extLst>
           </p:cNvPr>
@@ -5700,7 +5819,7 @@
     </p:spTree>
     <p:extLst>
       <p:ext uri="{BB962C8B-B14F-4D97-AF65-F5344CB8AC3E}">
-        <p14:creationId xmlns:p14="http://schemas.microsoft.com/office/powerpoint/2010/main" val="1687153296"/>
+        <p14:creationId xmlns:p14="http://schemas.microsoft.com/office/powerpoint/2010/main" val="1357786501"/>
       </p:ext>
     </p:extLst>
   </p:cSld>
@@ -5731,7 +5850,7 @@
           <p:cNvPr id="11" name="text-0">
             <a:extLst xmlns:a="http://schemas.openxmlformats.org/drawingml/2006/main">
               <a:ext uri="{FF2B5EF4-FFF2-40B4-BE49-F238E27FC236}">
-                <a16:creationId xmlns:a16="http://schemas.microsoft.com/office/drawing/2014/main" id="{12A0B964-5802-48F5-A603-A5E1387022EE}"/>
+                <a16:creationId xmlns:a16="http://schemas.microsoft.com/office/drawing/2014/main" id="{A8E47FC6-79D3-48CB-B676-FCC9F96A7EE7}"/>
               </a:ext>
             </a:extLst>
           </p:cNvPr>
@@ -5788,7 +5907,7 @@
           <p:cNvPr id="2" name="text-1">
             <a:extLst xmlns:a="http://schemas.openxmlformats.org/drawingml/2006/main">
               <a:ext uri="{FF2B5EF4-FFF2-40B4-BE49-F238E27FC236}">
-                <a16:creationId xmlns:a16="http://schemas.microsoft.com/office/drawing/2014/main" id="{E1B8FD38-02DD-4011-9AFB-E6E33B3C7EF9}"/>
+                <a16:creationId xmlns:a16="http://schemas.microsoft.com/office/drawing/2014/main" id="{1A18C3DF-E86D-428F-9FF4-7CAB39B9C19C}"/>
               </a:ext>
             </a:extLst>
           </p:cNvPr>
@@ -5835,7 +5954,7 @@
                 <a:ea typeface="Arial"/>
                 <a:cs typeface="Arial"/>
               </a:rPr>
-              <a:t>Transport afregnes pr. segment eller mail. Pakkeeksemplerne gælder 1.000 AI-behandlinger/svar.</a:t>
+              <a:t>Pakker: 1.000 AI-svar/md. SMS-robot: 1.000 SMS ind + 1.000 ud. SMS afregnes pr. segment.</a:t>
             </a:r>
           </a:p>
         </p:txBody>
@@ -5845,7 +5964,7 @@
           <p:cNvPr id="3" name="text-2">
             <a:extLst xmlns:a="http://schemas.openxmlformats.org/drawingml/2006/main">
               <a:ext uri="{FF2B5EF4-FFF2-40B4-BE49-F238E27FC236}">
-                <a16:creationId xmlns:a16="http://schemas.microsoft.com/office/drawing/2014/main" id="{0BA39600-3471-4FC6-97BD-2570F82A86C3}"/>
+                <a16:creationId xmlns:a16="http://schemas.microsoft.com/office/drawing/2014/main" id="{9DB41003-28B3-46BB-AED1-4A476CB03053}"/>
               </a:ext>
             </a:extLst>
           </p:cNvPr>
@@ -5902,7 +6021,7 @@
           <p:cNvPr id="4" name="text-3">
             <a:extLst xmlns:a="http://schemas.openxmlformats.org/drawingml/2006/main">
               <a:ext uri="{FF2B5EF4-FFF2-40B4-BE49-F238E27FC236}">
-                <a16:creationId xmlns:a16="http://schemas.microsoft.com/office/drawing/2014/main" id="{E074D570-5C47-43DB-BF51-E6609AED8D2F}"/>
+                <a16:creationId xmlns:a16="http://schemas.microsoft.com/office/drawing/2014/main" id="{CDA899BC-2282-4D2B-AC5E-520E0D09F696}"/>
               </a:ext>
             </a:extLst>
           </p:cNvPr>
@@ -6997,7 +7116,7 @@
           <p:cNvPr id="7" name="text-4">
             <a:extLst xmlns:a="http://schemas.openxmlformats.org/drawingml/2006/main">
               <a:ext uri="{FF2B5EF4-FFF2-40B4-BE49-F238E27FC236}">
-                <a16:creationId xmlns:a16="http://schemas.microsoft.com/office/drawing/2014/main" id="{3F71EF64-15E6-45BB-8D9B-1344614C4537}"/>
+                <a16:creationId xmlns:a16="http://schemas.microsoft.com/office/drawing/2014/main" id="{C3A1C278-D9FB-4DEB-86BB-542CA3666C64}"/>
               </a:ext>
             </a:extLst>
           </p:cNvPr>
@@ -7008,8 +7127,8 @@
         </p:nvSpPr>
         <p:spPr>
           <a:xfrm xmlns:a="http://schemas.openxmlformats.org/drawingml/2006/main">
-            <a:off x="609600" y="5191125"/>
-            <a:ext cx="10972800" cy="333375"/>
+            <a:off x="609600" y="5162550"/>
+            <a:ext cx="10972800" cy="304800"/>
           </a:xfrm>
           <a:prstGeom xmlns:a="http://schemas.openxmlformats.org/drawingml/2006/main" prst="rect">
             <a:avLst/>
@@ -7044,7 +7163,7 @@
                 <a:ea typeface="Arial"/>
                 <a:cs typeface="Arial"/>
               </a:rPr>
-              <a:t>Mailtransport: 0,00 kr. ekstra i jeres opsætning.</a:t>
+              <a:t>SMS-robot: sådan bliver månedsbeløbet til</a:t>
             </a:r>
           </a:p>
         </p:txBody>
@@ -7054,7 +7173,7 @@
           <p:cNvPr id="8" name="text-5">
             <a:extLst xmlns:a="http://schemas.openxmlformats.org/drawingml/2006/main">
               <a:ext uri="{FF2B5EF4-FFF2-40B4-BE49-F238E27FC236}">
-                <a16:creationId xmlns:a16="http://schemas.microsoft.com/office/drawing/2014/main" id="{483A4F18-F556-4580-AC52-E2B140127D38}"/>
+                <a16:creationId xmlns:a16="http://schemas.microsoft.com/office/drawing/2014/main" id="{141F7E34-149B-4600-A076-7451865D06FA}"/>
               </a:ext>
             </a:extLst>
           </p:cNvPr>
@@ -7065,8 +7184,8 @@
         </p:nvSpPr>
         <p:spPr>
           <a:xfrm xmlns:a="http://schemas.openxmlformats.org/drawingml/2006/main">
-            <a:off x="609600" y="5619750"/>
-            <a:ext cx="10972800" cy="333375"/>
+            <a:off x="609600" y="5524500"/>
+            <a:ext cx="10972800" cy="485775"/>
           </a:xfrm>
           <a:prstGeom xmlns:a="http://schemas.openxmlformats.org/drawingml/2006/main" prst="rect">
             <a:avLst/>
@@ -7083,7 +7202,7 @@
           <a:lstStyle xmlns:a="http://schemas.openxmlformats.org/drawingml/2006/main"/>
           <a:p xmlns:a="http://schemas.openxmlformats.org/drawingml/2006/main">
             <a:pPr algn="l">
-              <a:defRPr sz="1575" b="0">
+              <a:defRPr sz="1500" b="0">
                 <a:solidFill>
                   <a:srgbClr val="173745"/>
                 </a:solidFill>
@@ -7093,7 +7212,7 @@
               </a:defRPr>
             </a:pPr>
             <a:r>
-              <a:rPr sz="1575" b="0">
+              <a:rPr sz="1500" b="0">
                 <a:solidFill>
                   <a:srgbClr val="173745"/>
                 </a:solidFill>
@@ -7101,7 +7220,30 @@
                 <a:ea typeface="Arial"/>
                 <a:cs typeface="Arial"/>
               </a:rPr>
-              <a:t>Ekstra AI-mail: 0,15 kr./behandling. Ekstra webchat: 0,25 kr./svar. DB før fælles drift.</a:t>
+              <a:t>Salg: 299,00 abonnement + 100,00 AI + 60,00 SMS ind + 450,00 SMS ud = 909,00 kr.</a:t>
+            </a:r>
+          </a:p>
+          <a:p xmlns:a="http://schemas.openxmlformats.org/drawingml/2006/main">
+            <a:pPr algn="l">
+              <a:defRPr sz="1500" b="0">
+                <a:solidFill>
+                  <a:srgbClr val="173745"/>
+                </a:solidFill>
+                <a:latin typeface="Arial"/>
+                <a:ea typeface="Arial"/>
+                <a:cs typeface="Arial"/>
+              </a:defRPr>
+            </a:pPr>
+            <a:r>
+              <a:rPr sz="1500" b="0">
+                <a:solidFill>
+                  <a:srgbClr val="173745"/>
+                </a:solidFill>
+                <a:latin typeface="Arial"/>
+                <a:ea typeface="Arial"/>
+                <a:cs typeface="Arial"/>
+              </a:rPr>
+              <a:t>Kost: 42,57 AI + 48,38 SMS ind + 381,84 SMS ud = 472,79 kr.</a:t>
             </a:r>
           </a:p>
         </p:txBody>
@@ -7111,7 +7253,7 @@
           <p:cNvPr id="9" name="text-6">
             <a:extLst xmlns:a="http://schemas.openxmlformats.org/drawingml/2006/main">
               <a:ext uri="{FF2B5EF4-FFF2-40B4-BE49-F238E27FC236}">
-                <a16:creationId xmlns:a16="http://schemas.microsoft.com/office/drawing/2014/main" id="{9077B65A-031F-46E7-B2DE-5C93640E703D}"/>
+                <a16:creationId xmlns:a16="http://schemas.microsoft.com/office/drawing/2014/main" id="{099D9D22-7F46-4ABA-BF97-DA0C9D1F1E91}"/>
               </a:ext>
             </a:extLst>
           </p:cNvPr>
@@ -7158,7 +7300,7 @@
                 <a:ea typeface="Arial"/>
                 <a:cs typeface="Arial"/>
               </a:rPr>
-              <a:t>SMS-robot: 299,00 kr./md. + 0,10 kr./AI-svar + SMS ind/ud. Eksemplet inkluderer 1.000 indgående og 1.000 udgående Twilio-segmenter. Pakkerne er separate fra telefoncases.</a:t>
+              <a:t>Kost summeres før afrunding. Ekstra AI-mail: 0,15 kr./behandling; webchat: 0,25 kr./svar. Pakkerne er tillæg til telefoni.</a:t>
             </a:r>
           </a:p>
         </p:txBody>
@@ -7168,7 +7310,7 @@
           <p:cNvPr id="10" name="text-7">
             <a:extLst xmlns:a="http://schemas.openxmlformats.org/drawingml/2006/main">
               <a:ext uri="{FF2B5EF4-FFF2-40B4-BE49-F238E27FC236}">
-                <a16:creationId xmlns:a16="http://schemas.microsoft.com/office/drawing/2014/main" id="{3C5213B5-A4A8-45AB-BAC9-C394AF1DA0D6}"/>
+                <a16:creationId xmlns:a16="http://schemas.microsoft.com/office/drawing/2014/main" id="{8181635D-715F-4218-B7C0-FC126692E5CB}"/>
               </a:ext>
             </a:extLst>
           </p:cNvPr>
@@ -7223,7 +7365,7 @@
     </p:spTree>
     <p:extLst>
       <p:ext uri="{BB962C8B-B14F-4D97-AF65-F5344CB8AC3E}">
-        <p14:creationId xmlns:p14="http://schemas.microsoft.com/office/powerpoint/2010/main" val="650283283"/>
+        <p14:creationId xmlns:p14="http://schemas.microsoft.com/office/powerpoint/2010/main" val="926123173"/>
       </p:ext>
     </p:extLst>
   </p:cSld>
@@ -7254,7 +7396,7 @@
           <p:cNvPr id="12" name="text-0">
             <a:extLst xmlns:a="http://schemas.openxmlformats.org/drawingml/2006/main">
               <a:ext uri="{FF2B5EF4-FFF2-40B4-BE49-F238E27FC236}">
-                <a16:creationId xmlns:a16="http://schemas.microsoft.com/office/drawing/2014/main" id="{AA2B8C19-D484-4126-8DCD-B9DC6A358BF7}"/>
+                <a16:creationId xmlns:a16="http://schemas.microsoft.com/office/drawing/2014/main" id="{1AA82A78-48AD-402F-ACDF-55300E89F595}"/>
               </a:ext>
             </a:extLst>
           </p:cNvPr>
@@ -7301,7 +7443,7 @@
                 <a:ea typeface="Arial"/>
                 <a:cs typeface="Arial"/>
               </a:rPr>
-              <a:t>Fra ét opkald til en kundes månedsresultat</a:t>
+              <a:t>Ét opkald og vores månedsregnskab</a:t>
             </a:r>
           </a:p>
         </p:txBody>
@@ -7311,7 +7453,7 @@
           <p:cNvPr id="2" name="text-1">
             <a:extLst xmlns:a="http://schemas.openxmlformats.org/drawingml/2006/main">
               <a:ext uri="{FF2B5EF4-FFF2-40B4-BE49-F238E27FC236}">
-                <a16:creationId xmlns:a16="http://schemas.microsoft.com/office/drawing/2014/main" id="{9C4D7A07-DC83-48D7-9166-9D79B128985E}"/>
+                <a16:creationId xmlns:a16="http://schemas.microsoft.com/office/drawing/2014/main" id="{EAD4A096-66FB-401C-8F4A-671A83B760D2}"/>
               </a:ext>
             </a:extLst>
           </p:cNvPr>
@@ -7358,7 +7500,7 @@
                 <a:ea typeface="Arial"/>
                 <a:cs typeface="Arial"/>
               </a:rPr>
-              <a:t>Månedseksempel: 3 medarbejdere, 1.000 opkald. Alle får 8 min. AI + 10 min. DK mobilomstilling.</a:t>
+              <a:t>3 medarbejdere. 1.000 opkald/md. Alle får 8 min. AI + 10 min. omstilling til DK mobil.</a:t>
             </a:r>
           </a:p>
         </p:txBody>
@@ -7368,7 +7510,7 @@
           <p:cNvPr id="3" name="text-2">
             <a:extLst xmlns:a="http://schemas.openxmlformats.org/drawingml/2006/main">
               <a:ext uri="{FF2B5EF4-FFF2-40B4-BE49-F238E27FC236}">
-                <a16:creationId xmlns:a16="http://schemas.microsoft.com/office/drawing/2014/main" id="{AD8DFC92-420D-4520-A91F-2879F802D45D}"/>
+                <a16:creationId xmlns:a16="http://schemas.microsoft.com/office/drawing/2014/main" id="{1B951217-70AD-4C75-9428-7381725CC7D1}"/>
               </a:ext>
             </a:extLst>
           </p:cNvPr>
@@ -7425,7 +7567,7 @@
           <p:cNvPr id="4" name="text-3">
             <a:extLst xmlns:a="http://schemas.openxmlformats.org/drawingml/2006/main">
               <a:ext uri="{FF2B5EF4-FFF2-40B4-BE49-F238E27FC236}">
-                <a16:creationId xmlns:a16="http://schemas.microsoft.com/office/drawing/2014/main" id="{27D9398D-2508-427E-A387-2B4ABD85C8F0}"/>
+                <a16:creationId xmlns:a16="http://schemas.microsoft.com/office/drawing/2014/main" id="{50256F70-6A9C-4504-85C9-9C09187D609C}"/>
               </a:ext>
             </a:extLst>
           </p:cNvPr>
@@ -7472,7 +7614,7 @@
                 <a:ea typeface="Arial"/>
                 <a:cs typeface="Arial"/>
               </a:rPr>
-              <a:t>Kundens månedsregnskab</a:t>
+              <a:t>Vores regnskab / måned</a:t>
             </a:r>
           </a:p>
         </p:txBody>
@@ -7625,7 +7767,7 @@
                           <a:ea typeface="Arial"/>
                           <a:cs typeface="Arial"/>
                         </a:rPr>
-                        <a:t>AI, 8 min.</a:t>
+                        <a:t>+ AI, 8 min.</a:t>
                       </a:r>
                     </a:p>
                   </a:txBody>
@@ -7735,7 +7877,7 @@
                           <a:ea typeface="Arial"/>
                           <a:cs typeface="Arial"/>
                         </a:rPr>
-                        <a:t>Omstilling, 10 min.</a:t>
+                        <a:t>+ Mobil, 10 min.</a:t>
                       </a:r>
                     </a:p>
                   </a:txBody>
@@ -7845,7 +7987,7 @@
                           <a:ea typeface="Arial"/>
                           <a:cs typeface="Arial"/>
                         </a:rPr>
-                        <a:t>Opkald i alt</a:t>
+                        <a:t>= Opkald i alt</a:t>
                       </a:r>
                     </a:p>
                   </a:txBody>
@@ -7946,7 +8088,7 @@
           <p:cNvPr id="6" name="text-4">
             <a:extLst xmlns:a="http://schemas.openxmlformats.org/drawingml/2006/main">
               <a:ext uri="{FF2B5EF4-FFF2-40B4-BE49-F238E27FC236}">
-                <a16:creationId xmlns:a16="http://schemas.microsoft.com/office/drawing/2014/main" id="{2AFBA6BB-AC91-4CB0-9209-F3B286B8046B}"/>
+                <a16:creationId xmlns:a16="http://schemas.microsoft.com/office/drawing/2014/main" id="{E5A09D97-84B2-4AC3-8401-918777A6BF1C}"/>
               </a:ext>
             </a:extLst>
           </p:cNvPr>
@@ -7993,7 +8135,7 @@
                 <a:ea typeface="Arial"/>
                 <a:cs typeface="Arial"/>
               </a:rPr>
-              <a:t>Hvis menneskefasen varer længere</a:t>
+              <a:t>Andre opkald med længere omstilling</a:t>
             </a:r>
           </a:p>
         </p:txBody>
@@ -8360,7 +8502,7 @@
         </p:nvGraphicFramePr>
         <p:xfrm>
           <a:off xmlns:a="http://schemas.openxmlformats.org/drawingml/2006/main" x="6734175" y="2047875"/>
-          <a:ext xmlns:a="http://schemas.openxmlformats.org/drawingml/2006/main" cx="4848225" cy="3267075"/>
+          <a:ext xmlns:a="http://schemas.openxmlformats.org/drawingml/2006/main" cx="4848225" cy="3429000"/>
         </p:xfrm>
         <a:graphic xmlns:a="http://schemas.openxmlformats.org/drawingml/2006/main">
           <a:graphicData uri="http://schemas.openxmlformats.org/drawingml/2006/table">
@@ -8370,7 +8512,7 @@
                 <a:gridCol w="2990850"/>
                 <a:gridCol w="1857375"/>
               </a:tblGrid>
-              <a:tr h="466725">
+              <a:tr h="342900">
                 <a:tc>
                   <a:txBody>
                     <a:bodyPr lIns="123825" tIns="47625" rIns="123825" bIns="47625">
@@ -8380,21 +8522,245 @@
                     <a:p>
                       <a:pPr algn="l"/>
                       <a:r>
+                        <a:rPr sz="1350" b="1">
+                          <a:solidFill>
+                            <a:srgbClr val="FFFFFF"/>
+                          </a:solidFill>
+                          <a:latin typeface="Arial"/>
+                          <a:ea typeface="Arial"/>
+                          <a:cs typeface="Arial"/>
+                        </a:rPr>
+                        <a:t>Post</a:t>
+                      </a:r>
+                    </a:p>
+                  </a:txBody>
+                  <a:tcPr marL="91440" marR="91440" marT="45720" marB="45720" anchor="ctr">
+                    <a:solidFill>
+                      <a:srgbClr val="173745"/>
+                    </a:solidFill>
+                  </a:tcPr>
+                </a:tc>
+                <a:tc>
+                  <a:txBody>
+                    <a:bodyPr lIns="123825" tIns="47625" rIns="123825" bIns="47625">
+                      <a:noAutofit/>
+                    </a:bodyPr>
+                    <a:lstStyle/>
+                    <a:p>
+                      <a:pPr algn="r"/>
+                      <a:r>
+                        <a:rPr sz="1350" b="1">
+                          <a:solidFill>
+                            <a:srgbClr val="FFFFFF"/>
+                          </a:solidFill>
+                          <a:latin typeface="Arial"/>
+                          <a:ea typeface="Arial"/>
+                          <a:cs typeface="Arial"/>
+                        </a:rPr>
+                        <a:t>Pr. måned</a:t>
+                      </a:r>
+                    </a:p>
+                  </a:txBody>
+                  <a:tcPr marL="91440" marR="91440" marT="45720" marB="45720" anchor="ctr">
+                    <a:solidFill>
+                      <a:srgbClr val="173745"/>
+                    </a:solidFill>
+                  </a:tcPr>
+                </a:tc>
+              </a:tr>
+              <a:tr h="342900">
+                <a:tc>
+                  <a:txBody>
+                    <a:bodyPr lIns="123825" tIns="47625" rIns="123825" bIns="47625">
+                      <a:noAutofit/>
+                    </a:bodyPr>
+                    <a:lstStyle/>
+                    <a:p>
+                      <a:pPr algn="l"/>
+                      <a:r>
+                        <a:rPr sz="1500" b="0">
+                          <a:solidFill>
+                            <a:srgbClr val="173745"/>
+                          </a:solidFill>
+                          <a:latin typeface="Arial"/>
+                          <a:ea typeface="Arial"/>
+                          <a:cs typeface="Arial"/>
+                        </a:rPr>
+                        <a:t>+ Abonnement (3 stk.)</a:t>
+                      </a:r>
+                    </a:p>
+                  </a:txBody>
+                  <a:tcPr marL="91440" marR="91440" marT="45720" marB="45720" anchor="ctr">
+                    <a:solidFill>
+                      <a:srgbClr val="FFFFFF"/>
+                    </a:solidFill>
+                  </a:tcPr>
+                </a:tc>
+                <a:tc>
+                  <a:txBody>
+                    <a:bodyPr lIns="123825" tIns="47625" rIns="123825" bIns="47625">
+                      <a:noAutofit/>
+                    </a:bodyPr>
+                    <a:lstStyle/>
+                    <a:p>
+                      <a:pPr algn="r"/>
+                      <a:r>
+                        <a:rPr sz="1500" b="0">
+                          <a:solidFill>
+                            <a:srgbClr val="173745"/>
+                          </a:solidFill>
+                          <a:latin typeface="Arial"/>
+                          <a:ea typeface="Arial"/>
+                          <a:cs typeface="Arial"/>
+                        </a:rPr>
+                        <a:t>12.000,00 kr.</a:t>
+                      </a:r>
+                    </a:p>
+                  </a:txBody>
+                  <a:tcPr marL="91440" marR="91440" marT="45720" marB="45720" anchor="ctr">
+                    <a:solidFill>
+                      <a:srgbClr val="FFFFFF"/>
+                    </a:solidFill>
+                  </a:tcPr>
+                </a:tc>
+              </a:tr>
+              <a:tr h="342900">
+                <a:tc>
+                  <a:txBody>
+                    <a:bodyPr lIns="123825" tIns="47625" rIns="123825" bIns="47625">
+                      <a:noAutofit/>
+                    </a:bodyPr>
+                    <a:lstStyle/>
+                    <a:p>
+                      <a:pPr algn="l"/>
+                      <a:r>
+                        <a:rPr sz="1500" b="0">
+                          <a:solidFill>
+                            <a:srgbClr val="173745"/>
+                          </a:solidFill>
+                          <a:latin typeface="Arial"/>
+                          <a:ea typeface="Arial"/>
+                          <a:cs typeface="Arial"/>
+                        </a:rPr>
+                        <a:t>+ AI (8.000 min.)</a:t>
+                      </a:r>
+                    </a:p>
+                  </a:txBody>
+                  <a:tcPr marL="91440" marR="91440" marT="45720" marB="45720" anchor="ctr">
+                    <a:solidFill>
+                      <a:srgbClr val="FFFFFF"/>
+                    </a:solidFill>
+                  </a:tcPr>
+                </a:tc>
+                <a:tc>
+                  <a:txBody>
+                    <a:bodyPr lIns="123825" tIns="47625" rIns="123825" bIns="47625">
+                      <a:noAutofit/>
+                    </a:bodyPr>
+                    <a:lstStyle/>
+                    <a:p>
+                      <a:pPr algn="r"/>
+                      <a:r>
+                        <a:rPr sz="1500" b="0">
+                          <a:solidFill>
+                            <a:srgbClr val="173745"/>
+                          </a:solidFill>
+                          <a:latin typeface="Arial"/>
+                          <a:ea typeface="Arial"/>
+                          <a:cs typeface="Arial"/>
+                        </a:rPr>
+                        <a:t>12.000,00 kr.</a:t>
+                      </a:r>
+                    </a:p>
+                  </a:txBody>
+                  <a:tcPr marL="91440" marR="91440" marT="45720" marB="45720" anchor="ctr">
+                    <a:solidFill>
+                      <a:srgbClr val="FFFFFF"/>
+                    </a:solidFill>
+                  </a:tcPr>
+                </a:tc>
+              </a:tr>
+              <a:tr h="342900">
+                <a:tc>
+                  <a:txBody>
+                    <a:bodyPr lIns="123825" tIns="47625" rIns="123825" bIns="47625">
+                      <a:noAutofit/>
+                    </a:bodyPr>
+                    <a:lstStyle/>
+                    <a:p>
+                      <a:pPr algn="l"/>
+                      <a:r>
+                        <a:rPr sz="1500" b="0">
+                          <a:solidFill>
+                            <a:srgbClr val="173745"/>
+                          </a:solidFill>
+                          <a:latin typeface="Arial"/>
+                          <a:ea typeface="Arial"/>
+                          <a:cs typeface="Arial"/>
+                        </a:rPr>
+                        <a:t>+ Omstilling (10.000 min.)</a:t>
+                      </a:r>
+                    </a:p>
+                  </a:txBody>
+                  <a:tcPr marL="91440" marR="91440" marT="45720" marB="45720" anchor="ctr">
+                    <a:solidFill>
+                      <a:srgbClr val="FFFFFF"/>
+                    </a:solidFill>
+                  </a:tcPr>
+                </a:tc>
+                <a:tc>
+                  <a:txBody>
+                    <a:bodyPr lIns="123825" tIns="47625" rIns="123825" bIns="47625">
+                      <a:noAutofit/>
+                    </a:bodyPr>
+                    <a:lstStyle/>
+                    <a:p>
+                      <a:pPr algn="r"/>
+                      <a:r>
+                        <a:rPr sz="1500" b="0">
+                          <a:solidFill>
+                            <a:srgbClr val="173745"/>
+                          </a:solidFill>
+                          <a:latin typeface="Arial"/>
+                          <a:ea typeface="Arial"/>
+                          <a:cs typeface="Arial"/>
+                        </a:rPr>
+                        <a:t>4.900,00 kr.</a:t>
+                      </a:r>
+                    </a:p>
+                  </a:txBody>
+                  <a:tcPr marL="91440" marR="91440" marT="45720" marB="45720" anchor="ctr">
+                    <a:solidFill>
+                      <a:srgbClr val="FFFFFF"/>
+                    </a:solidFill>
+                  </a:tcPr>
+                </a:tc>
+              </a:tr>
+              <a:tr h="342900">
+                <a:tc>
+                  <a:txBody>
+                    <a:bodyPr lIns="123825" tIns="47625" rIns="123825" bIns="47625">
+                      <a:noAutofit/>
+                    </a:bodyPr>
+                    <a:lstStyle/>
+                    <a:p>
+                      <a:pPr algn="l"/>
+                      <a:r>
                         <a:rPr sz="1500" b="1">
                           <a:solidFill>
-                            <a:srgbClr val="FFFFFF"/>
-                          </a:solidFill>
-                          <a:latin typeface="Arial"/>
-                          <a:ea typeface="Arial"/>
-                          <a:cs typeface="Arial"/>
-                        </a:rPr>
-                        <a:t>Post</a:t>
-                      </a:r>
-                    </a:p>
-                  </a:txBody>
-                  <a:tcPr marL="91440" marR="91440" marT="45720" marB="45720" anchor="ctr">
-                    <a:solidFill>
-                      <a:srgbClr val="173745"/>
+                            <a:srgbClr val="173745"/>
+                          </a:solidFill>
+                          <a:latin typeface="Arial"/>
+                          <a:ea typeface="Arial"/>
+                          <a:cs typeface="Arial"/>
+                        </a:rPr>
+                        <a:t>= Indtægt</a:t>
+                      </a:r>
+                    </a:p>
+                  </a:txBody>
+                  <a:tcPr marL="91440" marR="91440" marT="45720" marB="45720" anchor="ctr">
+                    <a:solidFill>
+                      <a:srgbClr val="EAF4F1"/>
                     </a:solidFill>
                   </a:tcPr>
                 </a:tc>
@@ -8409,24 +8775,24 @@
                       <a:r>
                         <a:rPr sz="1500" b="1">
                           <a:solidFill>
-                            <a:srgbClr val="FFFFFF"/>
-                          </a:solidFill>
-                          <a:latin typeface="Arial"/>
-                          <a:ea typeface="Arial"/>
-                          <a:cs typeface="Arial"/>
-                        </a:rPr>
-                        <a:t>Pr. måned</a:t>
-                      </a:r>
-                    </a:p>
-                  </a:txBody>
-                  <a:tcPr marL="91440" marR="91440" marT="45720" marB="45720" anchor="ctr">
-                    <a:solidFill>
-                      <a:srgbClr val="173745"/>
+                            <a:srgbClr val="173745"/>
+                          </a:solidFill>
+                          <a:latin typeface="Arial"/>
+                          <a:ea typeface="Arial"/>
+                          <a:cs typeface="Arial"/>
+                        </a:rPr>
+                        <a:t>28.900,00 kr.</a:t>
+                      </a:r>
+                    </a:p>
+                  </a:txBody>
+                  <a:tcPr marL="91440" marR="91440" marT="45720" marB="45720" anchor="ctr">
+                    <a:solidFill>
+                      <a:srgbClr val="EAF4F1"/>
                     </a:solidFill>
                   </a:tcPr>
                 </a:tc>
               </a:tr>
-              <a:tr h="466725">
+              <a:tr h="342900">
                 <a:tc>
                   <a:txBody>
                     <a:bodyPr lIns="123825" tIns="47625" rIns="123825" bIns="47625">
@@ -8436,42 +8802,42 @@
                     <a:p>
                       <a:pPr algn="l"/>
                       <a:r>
-                        <a:rPr sz="1650" b="0">
-                          <a:solidFill>
-                            <a:srgbClr val="173745"/>
-                          </a:solidFill>
-                          <a:latin typeface="Arial"/>
-                          <a:ea typeface="Arial"/>
-                          <a:cs typeface="Arial"/>
-                        </a:rPr>
-                        <a:t>Indtægt</a:t>
-                      </a:r>
-                    </a:p>
-                  </a:txBody>
-                  <a:tcPr marL="91440" marR="91440" marT="45720" marB="45720" anchor="ctr">
-                    <a:solidFill>
-                      <a:srgbClr val="FFFFFF"/>
-                    </a:solidFill>
-                  </a:tcPr>
-                </a:tc>
-                <a:tc>
-                  <a:txBody>
-                    <a:bodyPr lIns="123825" tIns="47625" rIns="123825" bIns="47625">
-                      <a:noAutofit/>
-                    </a:bodyPr>
-                    <a:lstStyle/>
-                    <a:p>
-                      <a:pPr algn="r"/>
-                      <a:r>
-                        <a:rPr sz="1650" b="0">
-                          <a:solidFill>
-                            <a:srgbClr val="173745"/>
-                          </a:solidFill>
-                          <a:latin typeface="Arial"/>
-                          <a:ea typeface="Arial"/>
-                          <a:cs typeface="Arial"/>
-                        </a:rPr>
-                        <a:t>28.900,00 kr.</a:t>
+                        <a:rPr sz="1500" b="0">
+                          <a:solidFill>
+                            <a:srgbClr val="173745"/>
+                          </a:solidFill>
+                          <a:latin typeface="Arial"/>
+                          <a:ea typeface="Arial"/>
+                          <a:cs typeface="Arial"/>
+                        </a:rPr>
+                        <a:t>- Opkald og nummer</a:t>
+                      </a:r>
+                    </a:p>
+                  </a:txBody>
+                  <a:tcPr marL="91440" marR="91440" marT="45720" marB="45720" anchor="ctr">
+                    <a:solidFill>
+                      <a:srgbClr val="FFFFFF"/>
+                    </a:solidFill>
+                  </a:tcPr>
+                </a:tc>
+                <a:tc>
+                  <a:txBody>
+                    <a:bodyPr lIns="123825" tIns="47625" rIns="123825" bIns="47625">
+                      <a:noAutofit/>
+                    </a:bodyPr>
+                    <a:lstStyle/>
+                    <a:p>
+                      <a:pPr algn="r"/>
+                      <a:r>
+                        <a:rPr sz="1500" b="0">
+                          <a:solidFill>
+                            <a:srgbClr val="173745"/>
+                          </a:solidFill>
+                          <a:latin typeface="Arial"/>
+                          <a:ea typeface="Arial"/>
+                          <a:cs typeface="Arial"/>
+                        </a:rPr>
+                        <a:t>10.184,81 kr.</a:t>
                       </a:r>
                     </a:p>
                   </a:txBody>
@@ -8482,7 +8848,7 @@
                   </a:tcPr>
                 </a:tc>
               </a:tr>
-              <a:tr h="466725">
+              <a:tr h="342900">
                 <a:tc>
                   <a:txBody>
                     <a:bodyPr lIns="123825" tIns="47625" rIns="123825" bIns="47625">
@@ -8492,53 +8858,53 @@
                     <a:p>
                       <a:pPr algn="l"/>
                       <a:r>
-                        <a:rPr sz="1650" b="0">
-                          <a:solidFill>
-                            <a:srgbClr val="173745"/>
-                          </a:solidFill>
-                          <a:latin typeface="Arial"/>
-                          <a:ea typeface="Arial"/>
-                          <a:cs typeface="Arial"/>
-                        </a:rPr>
-                        <a:t>Minus direkte kost</a:t>
-                      </a:r>
-                    </a:p>
-                  </a:txBody>
-                  <a:tcPr marL="91440" marR="91440" marT="45720" marB="45720" anchor="ctr">
-                    <a:solidFill>
-                      <a:srgbClr val="FFFFFF"/>
-                    </a:solidFill>
-                  </a:tcPr>
-                </a:tc>
-                <a:tc>
-                  <a:txBody>
-                    <a:bodyPr lIns="123825" tIns="47625" rIns="123825" bIns="47625">
-                      <a:noAutofit/>
-                    </a:bodyPr>
-                    <a:lstStyle/>
-                    <a:p>
-                      <a:pPr algn="r"/>
-                      <a:r>
-                        <a:rPr sz="1650" b="0">
-                          <a:solidFill>
-                            <a:srgbClr val="173745"/>
-                          </a:solidFill>
-                          <a:latin typeface="Arial"/>
-                          <a:ea typeface="Arial"/>
-                          <a:cs typeface="Arial"/>
-                        </a:rPr>
-                        <a:t>10.184,81 kr.</a:t>
-                      </a:r>
-                    </a:p>
-                  </a:txBody>
-                  <a:tcPr marL="91440" marR="91440" marT="45720" marB="45720" anchor="ctr">
-                    <a:solidFill>
-                      <a:srgbClr val="FFFFFF"/>
+                        <a:rPr sz="1500" b="1">
+                          <a:solidFill>
+                            <a:srgbClr val="173745"/>
+                          </a:solidFill>
+                          <a:latin typeface="Arial"/>
+                          <a:ea typeface="Arial"/>
+                          <a:cs typeface="Arial"/>
+                        </a:rPr>
+                        <a:t>= Dækningsbidrag</a:t>
+                      </a:r>
+                    </a:p>
+                  </a:txBody>
+                  <a:tcPr marL="91440" marR="91440" marT="45720" marB="45720" anchor="ctr">
+                    <a:solidFill>
+                      <a:srgbClr val="EAF4F1"/>
+                    </a:solidFill>
+                  </a:tcPr>
+                </a:tc>
+                <a:tc>
+                  <a:txBody>
+                    <a:bodyPr lIns="123825" tIns="47625" rIns="123825" bIns="47625">
+                      <a:noAutofit/>
+                    </a:bodyPr>
+                    <a:lstStyle/>
+                    <a:p>
+                      <a:pPr algn="r"/>
+                      <a:r>
+                        <a:rPr sz="1500" b="1">
+                          <a:solidFill>
+                            <a:srgbClr val="173745"/>
+                          </a:solidFill>
+                          <a:latin typeface="Arial"/>
+                          <a:ea typeface="Arial"/>
+                          <a:cs typeface="Arial"/>
+                        </a:rPr>
+                        <a:t>18.715,19 kr.</a:t>
+                      </a:r>
+                    </a:p>
+                  </a:txBody>
+                  <a:tcPr marL="91440" marR="91440" marT="45720" marB="45720" anchor="ctr">
+                    <a:solidFill>
+                      <a:srgbClr val="EAF4F1"/>
                     </a:solidFill>
                   </a:tcPr>
                 </a:tc>
               </a:tr>
-              <a:tr h="466725">
+              <a:tr h="342900">
                 <a:tc>
                   <a:txBody>
                     <a:bodyPr lIns="123825" tIns="47625" rIns="123825" bIns="47625">
@@ -8548,42 +8914,42 @@
                     <a:p>
                       <a:pPr algn="l"/>
                       <a:r>
-                        <a:rPr sz="1650" b="0">
-                          <a:solidFill>
-                            <a:srgbClr val="173745"/>
-                          </a:solidFill>
-                          <a:latin typeface="Arial"/>
-                          <a:ea typeface="Arial"/>
-                          <a:cs typeface="Arial"/>
-                        </a:rPr>
-                        <a:t>Dækningsbidrag</a:t>
-                      </a:r>
-                    </a:p>
-                  </a:txBody>
-                  <a:tcPr marL="91440" marR="91440" marT="45720" marB="45720" anchor="ctr">
-                    <a:solidFill>
-                      <a:srgbClr val="FFFFFF"/>
-                    </a:solidFill>
-                  </a:tcPr>
-                </a:tc>
-                <a:tc>
-                  <a:txBody>
-                    <a:bodyPr lIns="123825" tIns="47625" rIns="123825" bIns="47625">
-                      <a:noAutofit/>
-                    </a:bodyPr>
-                    <a:lstStyle/>
-                    <a:p>
-                      <a:pPr algn="r"/>
-                      <a:r>
-                        <a:rPr sz="1650" b="0">
-                          <a:solidFill>
-                            <a:srgbClr val="173745"/>
-                          </a:solidFill>
-                          <a:latin typeface="Arial"/>
-                          <a:ea typeface="Arial"/>
-                          <a:cs typeface="Arial"/>
-                        </a:rPr>
-                        <a:t>18.715,19 kr.</a:t>
+                        <a:rPr sz="1500" b="0">
+                          <a:solidFill>
+                            <a:srgbClr val="173745"/>
+                          </a:solidFill>
+                          <a:latin typeface="Arial"/>
+                          <a:ea typeface="Arial"/>
+                          <a:cs typeface="Arial"/>
+                        </a:rPr>
+                        <a:t>- Server</a:t>
+                      </a:r>
+                    </a:p>
+                  </a:txBody>
+                  <a:tcPr marL="91440" marR="91440" marT="45720" marB="45720" anchor="ctr">
+                    <a:solidFill>
+                      <a:srgbClr val="FFFFFF"/>
+                    </a:solidFill>
+                  </a:tcPr>
+                </a:tc>
+                <a:tc>
+                  <a:txBody>
+                    <a:bodyPr lIns="123825" tIns="47625" rIns="123825" bIns="47625">
+                      <a:noAutofit/>
+                    </a:bodyPr>
+                    <a:lstStyle/>
+                    <a:p>
+                      <a:pPr algn="r"/>
+                      <a:r>
+                        <a:rPr sz="1500" b="0">
+                          <a:solidFill>
+                            <a:srgbClr val="173745"/>
+                          </a:solidFill>
+                          <a:latin typeface="Arial"/>
+                          <a:ea typeface="Arial"/>
+                          <a:cs typeface="Arial"/>
+                        </a:rPr>
+                        <a:t>74,60 kr.</a:t>
                       </a:r>
                     </a:p>
                   </a:txBody>
@@ -8594,7 +8960,7 @@
                   </a:tcPr>
                 </a:tc>
               </a:tr>
-              <a:tr h="466725">
+              <a:tr h="342900">
                 <a:tc>
                   <a:txBody>
                     <a:bodyPr lIns="123825" tIns="47625" rIns="123825" bIns="47625">
@@ -8604,42 +8970,42 @@
                     <a:p>
                       <a:pPr algn="l"/>
                       <a:r>
-                        <a:rPr sz="1650" b="0">
-                          <a:solidFill>
-                            <a:srgbClr val="173745"/>
-                          </a:solidFill>
-                          <a:latin typeface="Arial"/>
-                          <a:ea typeface="Arial"/>
-                          <a:cs typeface="Arial"/>
-                        </a:rPr>
-                        <a:t>Minus server</a:t>
-                      </a:r>
-                    </a:p>
-                  </a:txBody>
-                  <a:tcPr marL="91440" marR="91440" marT="45720" marB="45720" anchor="ctr">
-                    <a:solidFill>
-                      <a:srgbClr val="FFFFFF"/>
-                    </a:solidFill>
-                  </a:tcPr>
-                </a:tc>
-                <a:tc>
-                  <a:txBody>
-                    <a:bodyPr lIns="123825" tIns="47625" rIns="123825" bIns="47625">
-                      <a:noAutofit/>
-                    </a:bodyPr>
-                    <a:lstStyle/>
-                    <a:p>
-                      <a:pPr algn="r"/>
-                      <a:r>
-                        <a:rPr sz="1650" b="0">
-                          <a:solidFill>
-                            <a:srgbClr val="173745"/>
-                          </a:solidFill>
-                          <a:latin typeface="Arial"/>
-                          <a:ea typeface="Arial"/>
-                          <a:cs typeface="Arial"/>
-                        </a:rPr>
-                        <a:t>74,60 kr.</a:t>
+                        <a:rPr sz="1500" b="0">
+                          <a:solidFill>
+                            <a:srgbClr val="173745"/>
+                          </a:solidFill>
+                          <a:latin typeface="Arial"/>
+                          <a:ea typeface="Arial"/>
+                          <a:cs typeface="Arial"/>
+                        </a:rPr>
+                        <a:t>- Supportreserve</a:t>
+                      </a:r>
+                    </a:p>
+                  </a:txBody>
+                  <a:tcPr marL="91440" marR="91440" marT="45720" marB="45720" anchor="ctr">
+                    <a:solidFill>
+                      <a:srgbClr val="FFFFFF"/>
+                    </a:solidFill>
+                  </a:tcPr>
+                </a:tc>
+                <a:tc>
+                  <a:txBody>
+                    <a:bodyPr lIns="123825" tIns="47625" rIns="123825" bIns="47625">
+                      <a:noAutofit/>
+                    </a:bodyPr>
+                    <a:lstStyle/>
+                    <a:p>
+                      <a:pPr algn="r"/>
+                      <a:r>
+                        <a:rPr sz="1500" b="0">
+                          <a:solidFill>
+                            <a:srgbClr val="173745"/>
+                          </a:solidFill>
+                          <a:latin typeface="Arial"/>
+                          <a:ea typeface="Arial"/>
+                          <a:cs typeface="Arial"/>
+                        </a:rPr>
+                        <a:t>500,00 kr.</a:t>
                       </a:r>
                     </a:p>
                   </a:txBody>
@@ -8650,7 +9016,7 @@
                   </a:tcPr>
                 </a:tc>
               </a:tr>
-              <a:tr h="466725">
+              <a:tr h="342900">
                 <a:tc>
                   <a:txBody>
                     <a:bodyPr lIns="123825" tIns="47625" rIns="123825" bIns="47625">
@@ -8660,71 +9026,15 @@
                     <a:p>
                       <a:pPr algn="l"/>
                       <a:r>
-                        <a:rPr sz="1650" b="0">
-                          <a:solidFill>
-                            <a:srgbClr val="173745"/>
-                          </a:solidFill>
-                          <a:latin typeface="Arial"/>
-                          <a:ea typeface="Arial"/>
-                          <a:cs typeface="Arial"/>
-                        </a:rPr>
-                        <a:t>Minus supportreserve</a:t>
-                      </a:r>
-                    </a:p>
-                  </a:txBody>
-                  <a:tcPr marL="91440" marR="91440" marT="45720" marB="45720" anchor="ctr">
-                    <a:solidFill>
-                      <a:srgbClr val="FFFFFF"/>
-                    </a:solidFill>
-                  </a:tcPr>
-                </a:tc>
-                <a:tc>
-                  <a:txBody>
-                    <a:bodyPr lIns="123825" tIns="47625" rIns="123825" bIns="47625">
-                      <a:noAutofit/>
-                    </a:bodyPr>
-                    <a:lstStyle/>
-                    <a:p>
-                      <a:pPr algn="r"/>
-                      <a:r>
-                        <a:rPr sz="1650" b="0">
-                          <a:solidFill>
-                            <a:srgbClr val="173745"/>
-                          </a:solidFill>
-                          <a:latin typeface="Arial"/>
-                          <a:ea typeface="Arial"/>
-                          <a:cs typeface="Arial"/>
-                        </a:rPr>
-                        <a:t>500,00 kr.</a:t>
-                      </a:r>
-                    </a:p>
-                  </a:txBody>
-                  <a:tcPr marL="91440" marR="91440" marT="45720" marB="45720" anchor="ctr">
-                    <a:solidFill>
-                      <a:srgbClr val="FFFFFF"/>
-                    </a:solidFill>
-                  </a:tcPr>
-                </a:tc>
-              </a:tr>
-              <a:tr h="466725">
-                <a:tc>
-                  <a:txBody>
-                    <a:bodyPr lIns="123825" tIns="47625" rIns="123825" bIns="47625">
-                      <a:noAutofit/>
-                    </a:bodyPr>
-                    <a:lstStyle/>
-                    <a:p>
-                      <a:pPr algn="l"/>
-                      <a:r>
-                        <a:rPr sz="1650" b="1">
-                          <a:solidFill>
-                            <a:srgbClr val="173745"/>
-                          </a:solidFill>
-                          <a:latin typeface="Arial"/>
-                          <a:ea typeface="Arial"/>
-                          <a:cs typeface="Arial"/>
-                        </a:rPr>
-                        <a:t>Resultat før skat</a:t>
+                        <a:rPr sz="1500" b="1">
+                          <a:solidFill>
+                            <a:srgbClr val="173745"/>
+                          </a:solidFill>
+                          <a:latin typeface="Arial"/>
+                          <a:ea typeface="Arial"/>
+                          <a:cs typeface="Arial"/>
+                        </a:rPr>
+                        <a:t>= Resultat før skat</a:t>
                       </a:r>
                     </a:p>
                   </a:txBody>
@@ -8743,7 +9053,7 @@
                     <a:p>
                       <a:pPr algn="r"/>
                       <a:r>
-                        <a:rPr sz="1650" b="1">
+                        <a:rPr sz="1500" b="1">
                           <a:solidFill>
                             <a:srgbClr val="173745"/>
                           </a:solidFill>
@@ -8771,7 +9081,7 @@
           <p:cNvPr id="9" name="text-5">
             <a:extLst xmlns:a="http://schemas.openxmlformats.org/drawingml/2006/main">
               <a:ext uri="{FF2B5EF4-FFF2-40B4-BE49-F238E27FC236}">
-                <a16:creationId xmlns:a16="http://schemas.microsoft.com/office/drawing/2014/main" id="{0EEDF52D-8DE9-423E-BC7C-85180A06011B}"/>
+                <a16:creationId xmlns:a16="http://schemas.microsoft.com/office/drawing/2014/main" id="{F1078352-0C2F-4AE9-B84B-88057256FE90}"/>
               </a:ext>
             </a:extLst>
           </p:cNvPr>
@@ -8828,7 +9138,7 @@
           <p:cNvPr id="10" name="text-6">
             <a:extLst xmlns:a="http://schemas.openxmlformats.org/drawingml/2006/main">
               <a:ext uri="{FF2B5EF4-FFF2-40B4-BE49-F238E27FC236}">
-                <a16:creationId xmlns:a16="http://schemas.microsoft.com/office/drawing/2014/main" id="{41B0E2AB-7AEB-435C-886D-70FBBBBEF7D3}"/>
+                <a16:creationId xmlns:a16="http://schemas.microsoft.com/office/drawing/2014/main" id="{E2CE0707-2B52-4107-B74F-89D969F05047}"/>
               </a:ext>
             </a:extLst>
           </p:cNvPr>
@@ -8875,7 +9185,30 @@
                 <a:ea typeface="Arial"/>
                 <a:cs typeface="Arial"/>
               </a:rPr>
-              <a:t>Månedsindtægt: 12.000,00 kr. abonnement + 12.000,00 kr. AI + 4.900,00 kr. omstilling. Ingen SMS, partner eller gebyr. Resultat før skat er efter de viste budgetudgifter.</a:t>
+              <a:t>Kost = AI 6.276,11 + omstilling 3.811,95 + nummer 96,75 = 10.184,81 kr.</a:t>
+            </a:r>
+          </a:p>
+          <a:p xmlns:a="http://schemas.openxmlformats.org/drawingml/2006/main">
+            <a:pPr algn="l">
+              <a:defRPr sz="1350" b="0">
+                <a:solidFill>
+                  <a:srgbClr val="586F7B"/>
+                </a:solidFill>
+                <a:latin typeface="Arial"/>
+                <a:ea typeface="Arial"/>
+                <a:cs typeface="Arial"/>
+              </a:defRPr>
+            </a:pPr>
+            <a:r>
+              <a:rPr sz="1350" b="0">
+                <a:solidFill>
+                  <a:srgbClr val="586F7B"/>
+                </a:solidFill>
+                <a:latin typeface="Arial"/>
+                <a:ea typeface="Arial"/>
+                <a:cs typeface="Arial"/>
+              </a:rPr>
+              <a:t>Månedstotaler beregnes før afrunding. Ingen SMS, partner eller gebyr.</a:t>
             </a:r>
           </a:p>
         </p:txBody>
@@ -8885,7 +9218,7 @@
           <p:cNvPr id="11" name="text-7">
             <a:extLst xmlns:a="http://schemas.openxmlformats.org/drawingml/2006/main">
               <a:ext uri="{FF2B5EF4-FFF2-40B4-BE49-F238E27FC236}">
-                <a16:creationId xmlns:a16="http://schemas.microsoft.com/office/drawing/2014/main" id="{ACD45954-BADD-4E4E-BDCC-A8469B0FF8F6}"/>
+                <a16:creationId xmlns:a16="http://schemas.microsoft.com/office/drawing/2014/main" id="{D6A7BB94-DCCA-4524-94C3-CD99AB1FC495}"/>
               </a:ext>
             </a:extLst>
           </p:cNvPr>
@@ -8940,7 +9273,7 @@
     </p:spTree>
     <p:extLst>
       <p:ext uri="{BB962C8B-B14F-4D97-AF65-F5344CB8AC3E}">
-        <p14:creationId xmlns:p14="http://schemas.microsoft.com/office/powerpoint/2010/main" val="1805737555"/>
+        <p14:creationId xmlns:p14="http://schemas.microsoft.com/office/powerpoint/2010/main" val="1620453645"/>
       </p:ext>
     </p:extLst>
   </p:cSld>
@@ -8971,7 +9304,7 @@
           <p:cNvPr id="8" name="text-0">
             <a:extLst xmlns:a="http://schemas.openxmlformats.org/drawingml/2006/main">
               <a:ext uri="{FF2B5EF4-FFF2-40B4-BE49-F238E27FC236}">
-                <a16:creationId xmlns:a16="http://schemas.microsoft.com/office/drawing/2014/main" id="{4EAB44B4-EAE0-4457-B8F0-E9DDE7A30694}"/>
+                <a16:creationId xmlns:a16="http://schemas.microsoft.com/office/drawing/2014/main" id="{FE02A8DA-DF47-4872-A7BC-0BC25F0E99BE}"/>
               </a:ext>
             </a:extLst>
           </p:cNvPr>
@@ -9028,7 +9361,7 @@
           <p:cNvPr id="2" name="text-1">
             <a:extLst xmlns:a="http://schemas.openxmlformats.org/drawingml/2006/main">
               <a:ext uri="{FF2B5EF4-FFF2-40B4-BE49-F238E27FC236}">
-                <a16:creationId xmlns:a16="http://schemas.microsoft.com/office/drawing/2014/main" id="{43BDA6A4-699E-4550-9EA1-7AF85C6B7A77}"/>
+                <a16:creationId xmlns:a16="http://schemas.microsoft.com/office/drawing/2014/main" id="{94B5CED8-AAA1-4318-8F08-3970226CE506}"/>
               </a:ext>
             </a:extLst>
           </p:cNvPr>
@@ -9075,7 +9408,7 @@
                 <a:ea typeface="Arial"/>
                 <a:cs typeface="Arial"/>
               </a:rPr>
-              <a:t>Alle telefoncases: 8 min. AI + 10 min. DK mobilomstilling pr. opkald. 100 % stilles videre.</a:t>
+              <a:t>Alle opkald: 8 min. AI + 10 min. DK mobil. Hver række er én separat kundecase.</a:t>
             </a:r>
           </a:p>
         </p:txBody>
@@ -9795,7 +10128,7 @@
           <p:cNvPr id="4" name="text-2">
             <a:extLst xmlns:a="http://schemas.openxmlformats.org/drawingml/2006/main">
               <a:ext uri="{FF2B5EF4-FFF2-40B4-BE49-F238E27FC236}">
-                <a16:creationId xmlns:a16="http://schemas.microsoft.com/office/drawing/2014/main" id="{DCAD3A6E-84FD-4BDE-9607-AEF606D5A0EB}"/>
+                <a16:creationId xmlns:a16="http://schemas.microsoft.com/office/drawing/2014/main" id="{183BC68B-52A6-45F5-AB65-6094BB76DD0A}"/>
               </a:ext>
             </a:extLst>
           </p:cNvPr>
@@ -9842,7 +10175,7 @@
                 <a:ea typeface="Arial"/>
                 <a:cs typeface="Arial"/>
               </a:rPr>
-              <a:t>Partner, samme kunde med 3 medarbejdere og 1.000 opkald</a:t>
+              <a:t>Partner: 0-30 % af abonnementet på 12.000,00 kr./md. Samme kunde med 1.000 opkald.</a:t>
             </a:r>
           </a:p>
         </p:txBody>
@@ -9939,7 +10272,7 @@
                           <a:ea typeface="Arial"/>
                           <a:cs typeface="Arial"/>
                         </a:rPr>
-                        <a:t>Vores DB</a:t>
+                        <a:t>DB efter partner</a:t>
                       </a:r>
                     </a:p>
                   </a:txBody>
@@ -9966,7 +10299,7 @@
                           <a:ea typeface="Arial"/>
                           <a:cs typeface="Arial"/>
                         </a:rPr>
-                        <a:t>Vores resultat</a:t>
+                        <a:t>Resultat</a:t>
                       </a:r>
                     </a:p>
                   </a:txBody>
@@ -10426,7 +10759,7 @@
           <p:cNvPr id="6" name="text-3">
             <a:extLst xmlns:a="http://schemas.openxmlformats.org/drawingml/2006/main">
               <a:ext uri="{FF2B5EF4-FFF2-40B4-BE49-F238E27FC236}">
-                <a16:creationId xmlns:a16="http://schemas.microsoft.com/office/drawing/2014/main" id="{6803AD6A-FECE-451C-905A-DC4AF194992D}"/>
+                <a16:creationId xmlns:a16="http://schemas.microsoft.com/office/drawing/2014/main" id="{BFC12649-54E2-47A6-8401-D597B3A0713A}"/>
               </a:ext>
             </a:extLst>
           </p:cNvPr>
@@ -10473,7 +10806,7 @@
                 <a:ea typeface="Arial"/>
                 <a:cs typeface="Arial"/>
               </a:rPr>
-              <a:t>Scenarier: ingen SMS, gebyr eller ejerløn. Resultat er efter server 74,60 kr. og support 500,00 kr. i hvert selvstændigt scenarie. Partnerprovision er endnu ikke aftalt.</a:t>
+              <a:t>Resultat = DB - server 74,60 kr. - supportreserve 500,00 kr. Ingen SMS, gebyr eller ejerløn. Partnerprovision er ikke aftalt.</a:t>
             </a:r>
           </a:p>
         </p:txBody>
@@ -10483,7 +10816,7 @@
           <p:cNvPr id="7" name="text-4">
             <a:extLst xmlns:a="http://schemas.openxmlformats.org/drawingml/2006/main">
               <a:ext uri="{FF2B5EF4-FFF2-40B4-BE49-F238E27FC236}">
-                <a16:creationId xmlns:a16="http://schemas.microsoft.com/office/drawing/2014/main" id="{A48D90C0-F720-4CCA-8CCA-9AF2397353E9}"/>
+                <a16:creationId xmlns:a16="http://schemas.microsoft.com/office/drawing/2014/main" id="{2B5AAA19-51F9-48D2-B502-F9CD2DDBB40D}"/>
               </a:ext>
             </a:extLst>
           </p:cNvPr>
@@ -10538,7 +10871,7 @@
     </p:spTree>
     <p:extLst>
       <p:ext uri="{BB962C8B-B14F-4D97-AF65-F5344CB8AC3E}">
-        <p14:creationId xmlns:p14="http://schemas.microsoft.com/office/powerpoint/2010/main" val="2138203747"/>
+        <p14:creationId xmlns:p14="http://schemas.microsoft.com/office/powerpoint/2010/main" val="277934478"/>
       </p:ext>
     </p:extLst>
   </p:cSld>
@@ -10569,7 +10902,7 @@
           <p:cNvPr id="8" name="text-0">
             <a:extLst xmlns:a="http://schemas.openxmlformats.org/drawingml/2006/main">
               <a:ext uri="{FF2B5EF4-FFF2-40B4-BE49-F238E27FC236}">
-                <a16:creationId xmlns:a16="http://schemas.microsoft.com/office/drawing/2014/main" id="{7260A2CA-FDC8-4443-84C1-4BE4B159348E}"/>
+                <a16:creationId xmlns:a16="http://schemas.microsoft.com/office/drawing/2014/main" id="{8812DE8B-49EE-4A67-98F3-A5A952E5AC20}"/>
               </a:ext>
             </a:extLst>
           </p:cNvPr>
@@ -10626,7 +10959,7 @@
           <p:cNvPr id="2" name="text-1">
             <a:extLst xmlns:a="http://schemas.openxmlformats.org/drawingml/2006/main">
               <a:ext uri="{FF2B5EF4-FFF2-40B4-BE49-F238E27FC236}">
-                <a16:creationId xmlns:a16="http://schemas.microsoft.com/office/drawing/2014/main" id="{7F54E440-8D67-43F6-BA08-9FDF76DF5893}"/>
+                <a16:creationId xmlns:a16="http://schemas.microsoft.com/office/drawing/2014/main" id="{75A3F718-9F2B-4C3C-BB73-18E7B00B959C}"/>
               </a:ext>
             </a:extLst>
           </p:cNvPr>
@@ -10673,7 +11006,7 @@
                 <a:ea typeface="Arial"/>
                 <a:cs typeface="Arial"/>
               </a:rPr>
-              <a:t>Budgetgrundlag pr. 9. september 2026. Gemini 3.1 Flash Live er målmodellen.</a:t>
+              <a:t>Budget pr. 9. september 2026. Krav før salg med fast pris.</a:t>
             </a:r>
           </a:p>
         </p:txBody>
@@ -10731,7 +11064,7 @@
                     </a:bodyPr>
                     <a:lstStyle/>
                     <a:p>
-                      <a:pPr algn="r"/>
+                      <a:pPr algn="l"/>
                       <a:r>
                         <a:rPr sz="1575" b="1">
                           <a:solidFill>
@@ -10787,7 +11120,7 @@
                     </a:bodyPr>
                     <a:lstStyle/>
                     <a:p>
-                      <a:pPr algn="r"/>
+                      <a:pPr algn="l"/>
                       <a:r>
                         <a:rPr sz="1725" b="0">
                           <a:solidFill>
@@ -10797,7 +11130,7 @@
                           <a:ea typeface="Arial"/>
                           <a:cs typeface="Arial"/>
                         </a:rPr>
-                        <a:t>Skøn for tokens og samtaleforløb inkl. 20 % reserve. Faktisk forbrug skal måles.</a:t>
+                        <a:t>Skøn med 20 % reserve. Faktisk forbrug skal måles.</a:t>
                       </a:r>
                     </a:p>
                   </a:txBody>
@@ -10843,7 +11176,7 @@
                     </a:bodyPr>
                     <a:lstStyle/>
                     <a:p>
-                      <a:pPr algn="r"/>
+                      <a:pPr algn="l"/>
                       <a:r>
                         <a:rPr sz="1725" b="0">
                           <a:solidFill>
@@ -10853,7 +11186,7 @@
                           <a:ea typeface="Arial"/>
                           <a:cs typeface="Arial"/>
                         </a:rPr>
-                        <a:t>8-minutters omstilling, separat faseafregning og tokenbaseret koststop skal implementeres. Lokal timeout er 10 min.</a:t>
+                        <a:t>Implementér omstilling efter 8 min., faseafregning og tokenbaseret koststop. Kodens timeout er 10 min.</a:t>
                       </a:r>
                     </a:p>
                   </a:txBody>
@@ -10899,7 +11232,7 @@
                     </a:bodyPr>
                     <a:lstStyle/>
                     <a:p>
-                      <a:pPr algn="r"/>
+                      <a:pPr algn="l"/>
                       <a:r>
                         <a:rPr sz="1725" b="0">
                           <a:solidFill>
@@ -10909,7 +11242,7 @@
                           <a:ea typeface="Arial"/>
                           <a:cs typeface="Arial"/>
                         </a:rPr>
-                        <a:t>Planlagt flersproget Gemini 3.1 Flash Live på Vertex, når tilgængelig dér. Pris, EU-region og hele datakæden skal bekræftes.</a:t>
+                        <a:t>Mål: flersproget Gemini 3.1 Flash Live på Vertex. Tilgængelighed, pris, EU-region og datakæde skal bekræftes.</a:t>
                       </a:r>
                     </a:p>
                   </a:txBody>
@@ -10929,7 +11262,7 @@
           <p:cNvPr id="4" name="text-2">
             <a:extLst xmlns:a="http://schemas.openxmlformats.org/drawingml/2006/main">
               <a:ext uri="{FF2B5EF4-FFF2-40B4-BE49-F238E27FC236}">
-                <a16:creationId xmlns:a16="http://schemas.microsoft.com/office/drawing/2014/main" id="{2AAFD2DE-EBD9-4CF5-BAA8-B49325D5213B}"/>
+                <a16:creationId xmlns:a16="http://schemas.microsoft.com/office/drawing/2014/main" id="{F75E2E0A-7230-44AA-B9C1-B8A1B274F3D0}"/>
               </a:ext>
             </a:extLst>
           </p:cNvPr>
@@ -10976,7 +11309,7 @@
                 <a:ea typeface="Arial"/>
                 <a:cs typeface="Arial"/>
               </a:rPr>
-              <a:t>Stresstest: 6 svar/min. og 60 % AI-tale giver 1,64 kr./min. ved 8 min. AI.</a:t>
+              <a:t>Stresstest: 6 svar/min., 60 % AI-tale og 8 min. AI.</a:t>
             </a:r>
           </a:p>
         </p:txBody>
@@ -10986,7 +11319,7 @@
           <p:cNvPr id="5" name="text-3">
             <a:extLst xmlns:a="http://schemas.openxmlformats.org/drawingml/2006/main">
               <a:ext uri="{FF2B5EF4-FFF2-40B4-BE49-F238E27FC236}">
-                <a16:creationId xmlns:a16="http://schemas.microsoft.com/office/drawing/2014/main" id="{309A6B1D-F587-482E-B6A2-A9E712F7ABB1}"/>
+                <a16:creationId xmlns:a16="http://schemas.microsoft.com/office/drawing/2014/main" id="{C2A2ED17-9471-43F4-B994-3906A6BFA58D}"/>
               </a:ext>
             </a:extLst>
           </p:cNvPr>
@@ -11033,7 +11366,7 @@
                 <a:ea typeface="Arial"/>
                 <a:cs typeface="Arial"/>
               </a:rPr>
-              <a:t>Fast 1,50 kr. giver her tab. Et tidsloft alene beskytter derfor ikke indtjeningen.</a:t>
+              <a:t>Salg 1,50 kr. - kost 1,64 kr. = tab 0,14 kr./min. Fast pris kræver et koststop.</a:t>
             </a:r>
           </a:p>
         </p:txBody>
@@ -11043,7 +11376,7 @@
           <p:cNvPr id="6" name="text-4">
             <a:extLst xmlns:a="http://schemas.openxmlformats.org/drawingml/2006/main">
               <a:ext uri="{FF2B5EF4-FFF2-40B4-BE49-F238E27FC236}">
-                <a16:creationId xmlns:a16="http://schemas.microsoft.com/office/drawing/2014/main" id="{41DBBBBC-4A08-4E63-BC42-90325C59EBDA}"/>
+                <a16:creationId xmlns:a16="http://schemas.microsoft.com/office/drawing/2014/main" id="{40C04FBF-C756-4E6B-A2D2-A892FE8E541A}"/>
               </a:ext>
             </a:extLst>
           </p:cNvPr>
@@ -11090,7 +11423,7 @@
                 <a:ea typeface="Arial"/>
                 <a:cs typeface="Arial"/>
               </a:rPr>
-              <a:t>Regnegrundlag og kilder: badlegion.github.io/intelli-prisark/gemini.html. Opstart, særlige integrationer, SLA, udvikling og ikke-oplyst arbejde er ikke prissat.</a:t>
+              <a:t>Kilder: badlegion.github.io/intelli-prisark/GRUNDLAG.md. Opstart, integrationer, SLA og udvikling er ikke prissat.</a:t>
             </a:r>
           </a:p>
         </p:txBody>
@@ -11100,7 +11433,7 @@
           <p:cNvPr id="7" name="text-5">
             <a:extLst xmlns:a="http://schemas.openxmlformats.org/drawingml/2006/main">
               <a:ext uri="{FF2B5EF4-FFF2-40B4-BE49-F238E27FC236}">
-                <a16:creationId xmlns:a16="http://schemas.microsoft.com/office/drawing/2014/main" id="{77A1E2FD-42AB-47A7-99C4-F4FEDDE88237}"/>
+                <a16:creationId xmlns:a16="http://schemas.microsoft.com/office/drawing/2014/main" id="{3A060059-4584-4D19-B756-932E84CB481A}"/>
               </a:ext>
             </a:extLst>
           </p:cNvPr>
@@ -11155,7 +11488,7 @@
     </p:spTree>
     <p:extLst>
       <p:ext uri="{BB962C8B-B14F-4D97-AF65-F5344CB8AC3E}">
-        <p14:creationId xmlns:p14="http://schemas.microsoft.com/office/powerpoint/2010/main" val="1566418322"/>
+        <p14:creationId xmlns:p14="http://schemas.microsoft.com/office/powerpoint/2010/main" val="1327045501"/>
       </p:ext>
     </p:extLst>
   </p:cSld>

</xml_diff>

<commit_message>
Tilpas INTELLI-prisforside til sort-hvid print og opdater omstilling
</commit_message>
<xml_diff>
--- a/INTELLI-prispraesentation.pptx
+++ b/INTELLI-prispraesentation.pptx
@@ -2,20 +2,20 @@
 <file path=ppt/presentation.xml><?xml version="1.0" encoding="utf-8"?>
 <p:presentation xmlns:p="http://schemas.openxmlformats.org/presentationml/2006/main">
   <p:sldMasterIdLst>
-    <p:sldMasterId xmlns:r="http://schemas.openxmlformats.org/officeDocument/2006/relationships" id="2147483648" r:id="Rce8d4f7238d542d5"/>
+    <p:sldMasterId xmlns:r="http://schemas.openxmlformats.org/officeDocument/2006/relationships" id="2147483648" r:id="Rb6b984afe4ba48bf"/>
   </p:sldMasterIdLst>
   <p:notesMasterIdLst>
-    <p:notesMasterId xmlns:r="http://schemas.openxmlformats.org/officeDocument/2006/relationships" r:id="R0f94b606f53f41f8"/>
+    <p:notesMasterId xmlns:r="http://schemas.openxmlformats.org/officeDocument/2006/relationships" r:id="R9d195bf80c604526"/>
   </p:notesMasterIdLst>
   <p:sldIdLst>
-    <p:sldId xmlns:r="http://schemas.openxmlformats.org/officeDocument/2006/relationships" id="256" r:id="R6f125485e1c64490"/>
-    <p:sldId xmlns:r="http://schemas.openxmlformats.org/officeDocument/2006/relationships" id="257" r:id="Rea71067ced6d4fda"/>
-    <p:sldId xmlns:r="http://schemas.openxmlformats.org/officeDocument/2006/relationships" id="258" r:id="Rc0d18f5d04dd4bfb"/>
-    <p:sldId xmlns:r="http://schemas.openxmlformats.org/officeDocument/2006/relationships" id="259" r:id="R807b6fd2f7d84238"/>
-    <p:sldId xmlns:r="http://schemas.openxmlformats.org/officeDocument/2006/relationships" id="260" r:id="R3713559fb34b44e5"/>
-    <p:sldId xmlns:r="http://schemas.openxmlformats.org/officeDocument/2006/relationships" id="261" r:id="R7346fc2e70a44c54"/>
-    <p:sldId xmlns:r="http://schemas.openxmlformats.org/officeDocument/2006/relationships" id="262" r:id="R4f39f28b24444b17"/>
-    <p:sldId xmlns:r="http://schemas.openxmlformats.org/officeDocument/2006/relationships" id="263" r:id="R02a9a9710fb040ed"/>
+    <p:sldId xmlns:r="http://schemas.openxmlformats.org/officeDocument/2006/relationships" id="256" r:id="Rae7b580199e84e73"/>
+    <p:sldId xmlns:r="http://schemas.openxmlformats.org/officeDocument/2006/relationships" id="257" r:id="Ra710373e88b54182"/>
+    <p:sldId xmlns:r="http://schemas.openxmlformats.org/officeDocument/2006/relationships" id="258" r:id="Rfd4746d44da04be2"/>
+    <p:sldId xmlns:r="http://schemas.openxmlformats.org/officeDocument/2006/relationships" id="259" r:id="R11209fa612b5407a"/>
+    <p:sldId xmlns:r="http://schemas.openxmlformats.org/officeDocument/2006/relationships" id="260" r:id="Re8dbaccef0fa4f7d"/>
+    <p:sldId xmlns:r="http://schemas.openxmlformats.org/officeDocument/2006/relationships" id="261" r:id="R28ae5671844149a8"/>
+    <p:sldId xmlns:r="http://schemas.openxmlformats.org/officeDocument/2006/relationships" id="262" r:id="R521946413545459e"/>
+    <p:sldId xmlns:r="http://schemas.openxmlformats.org/officeDocument/2006/relationships" id="263" r:id="R1c219c2c10454316"/>
   </p:sldIdLst>
   <p:sldSz cx="12192000" cy="6858000"/>
   <p:notesSz cx="6858000" cy="9144000"/>
@@ -464,7 +464,7 @@
           </a:p>
           <a:p xmlns:a="http://schemas.openxmlformats.org/drawingml/2006/main">
             <a:r>
-              <a:t>AI-fasen og omstillingen afregnes hver for sig. Fast AI-pris kræver koststop. Se forudsætninger på side 8.</a:t>
+              <a:t/>
             </a:r>
           </a:p>
           <a:p xmlns:a="http://schemas.openxmlformats.org/drawingml/2006/main">
@@ -1282,7 +1282,7 @@
   </p:cSld>
   <p:clrMap bg1="lt1" tx1="dk1" bg2="lt2" tx2="dk2" accent1="accent1" accent2="accent2" accent3="accent3" accent4="accent4" accent5="accent5" accent6="accent6" hlink="hlink" folHlink="folHlink"/>
   <p:sldLayoutIdLst>
-    <p:sldLayoutId xmlns:r="http://schemas.openxmlformats.org/officeDocument/2006/relationships" id="2147483649" r:id="Re08248d230724602"/>
+    <p:sldLayoutId xmlns:r="http://schemas.openxmlformats.org/officeDocument/2006/relationships" id="2147483649" r:id="Rc1edbdecda9b480c"/>
   </p:sldLayoutIdLst>
   <p:txStyles>
     <p:titleStyle>
@@ -1830,10 +1830,10 @@
       </p:grpSpPr>
       <p:sp>
         <p:nvSpPr>
-          <p:cNvPr id="23" name="text-0">
+          <p:cNvPr id="22" name="text-0">
             <a:extLst xmlns:a="http://schemas.openxmlformats.org/drawingml/2006/main">
               <a:ext uri="{FF2B5EF4-FFF2-40B4-BE49-F238E27FC236}">
-                <a16:creationId xmlns:a16="http://schemas.microsoft.com/office/drawing/2014/main" id="{08E6EA9A-6AAE-4349-9A28-37150BA67F74}"/>
+                <a16:creationId xmlns:a16="http://schemas.microsoft.com/office/drawing/2014/main" id="{3DE67346-10C2-4738-AFDF-8259A359B59A}"/>
               </a:ext>
             </a:extLst>
           </p:cNvPr>
@@ -1844,8 +1844,65 @@
         </p:nvSpPr>
         <p:spPr>
           <a:xfrm xmlns:a="http://schemas.openxmlformats.org/drawingml/2006/main">
-            <a:off x="609600" y="466725"/>
-            <a:ext cx="10972800" cy="628650"/>
+            <a:off x="7677150" y="638175"/>
+            <a:ext cx="3905250" cy="457200"/>
+          </a:xfrm>
+          <a:prstGeom xmlns:a="http://schemas.openxmlformats.org/drawingml/2006/main" prst="rect">
+            <a:avLst/>
+          </a:prstGeom>
+          <a:noFill xmlns:a="http://schemas.openxmlformats.org/drawingml/2006/main"/>
+          <a:ln xmlns:a="http://schemas.openxmlformats.org/drawingml/2006/main" w="0">
+            <a:noFill/>
+          </a:ln>
+        </p:spPr>
+        <p:txBody>
+          <a:bodyPr xmlns:a="http://schemas.openxmlformats.org/drawingml/2006/main" lIns="0" tIns="0" rIns="0" bIns="0" anchor="t">
+            <a:noAutofit/>
+          </a:bodyPr>
+          <a:lstStyle xmlns:a="http://schemas.openxmlformats.org/drawingml/2006/main"/>
+          <a:p xmlns:a="http://schemas.openxmlformats.org/drawingml/2006/main">
+            <a:pPr algn="r">
+              <a:defRPr sz="2400" b="0">
+                <a:solidFill>
+                  <a:srgbClr val="111111"/>
+                </a:solidFill>
+                <a:latin typeface="Arial"/>
+                <a:ea typeface="Arial"/>
+                <a:cs typeface="Arial"/>
+              </a:defRPr>
+            </a:pPr>
+            <a:r>
+              <a:rPr sz="2400" b="0">
+                <a:solidFill>
+                  <a:srgbClr val="111111"/>
+                </a:solidFill>
+                <a:latin typeface="Arial"/>
+                <a:ea typeface="Arial"/>
+                <a:cs typeface="Arial"/>
+              </a:rPr>
+              <a:t>Salgspriser</a:t>
+            </a:r>
+          </a:p>
+        </p:txBody>
+      </p:sp>
+      <p:sp>
+        <p:nvSpPr>
+          <p:cNvPr id="2" name="text-1">
+            <a:extLst xmlns:a="http://schemas.openxmlformats.org/drawingml/2006/main">
+              <a:ext uri="{FF2B5EF4-FFF2-40B4-BE49-F238E27FC236}">
+                <a16:creationId xmlns:a16="http://schemas.microsoft.com/office/drawing/2014/main" id="{801148A1-4B78-4EF2-AC18-FDEA3096CAB4}"/>
+              </a:ext>
+            </a:extLst>
+          </p:cNvPr>
+          <p:cNvSpPr>
+            <a:spLocks xmlns:a="http://schemas.openxmlformats.org/drawingml/2006/main" noGrp="1"/>
+          </p:cNvSpPr>
+          <p:nvPr/>
+        </p:nvSpPr>
+        <p:spPr>
+          <a:xfrm xmlns:a="http://schemas.openxmlformats.org/drawingml/2006/main">
+            <a:off x="609600" y="1724025"/>
+            <a:ext cx="10972800" cy="400050"/>
           </a:xfrm>
           <a:prstGeom xmlns:a="http://schemas.openxmlformats.org/drawingml/2006/main" prst="rect">
             <a:avLst/>
@@ -1862,9 +1919,9 @@
           <a:lstStyle xmlns:a="http://schemas.openxmlformats.org/drawingml/2006/main"/>
           <a:p xmlns:a="http://schemas.openxmlformats.org/drawingml/2006/main">
             <a:pPr algn="l">
-              <a:defRPr sz="2700" b="1">
-                <a:solidFill>
-                  <a:srgbClr val="173745"/>
+              <a:defRPr sz="1725" b="0">
+                <a:solidFill>
+                  <a:srgbClr val="333333"/>
                 </a:solidFill>
                 <a:latin typeface="Arial"/>
                 <a:ea typeface="Arial"/>
@@ -1872,25 +1929,25 @@
               </a:defRPr>
             </a:pPr>
             <a:r>
-              <a:rPr sz="2700" b="1">
-                <a:solidFill>
-                  <a:srgbClr val="173745"/>
+              <a:rPr sz="1725" b="0">
+                <a:solidFill>
+                  <a:srgbClr val="333333"/>
                 </a:solidFill>
                 <a:latin typeface="Arial"/>
                 <a:ea typeface="Arial"/>
                 <a:cs typeface="Arial"/>
               </a:rPr>
-              <a:t>Vores salgspriser</a:t>
+              <a:t>30 % rabat er medregnet. Alle priser er ekskl. moms.</a:t>
             </a:r>
           </a:p>
         </p:txBody>
       </p:sp>
       <p:sp>
         <p:nvSpPr>
-          <p:cNvPr id="2" name="text-1">
+          <p:cNvPr id="3" name="text-2">
             <a:extLst xmlns:a="http://schemas.openxmlformats.org/drawingml/2006/main">
               <a:ext uri="{FF2B5EF4-FFF2-40B4-BE49-F238E27FC236}">
-                <a16:creationId xmlns:a16="http://schemas.microsoft.com/office/drawing/2014/main" id="{001FCCB1-4702-48D6-BA3C-908C3C928C18}"/>
+                <a16:creationId xmlns:a16="http://schemas.microsoft.com/office/drawing/2014/main" id="{25C3707C-4D51-4C7C-B15A-06A9165997CB}"/>
               </a:ext>
             </a:extLst>
           </p:cNvPr>
@@ -1901,8 +1958,8 @@
         </p:nvSpPr>
         <p:spPr>
           <a:xfrm xmlns:a="http://schemas.openxmlformats.org/drawingml/2006/main">
-            <a:off x="609600" y="1104900"/>
-            <a:ext cx="10972800" cy="590550"/>
+            <a:off x="609600" y="466725"/>
+            <a:ext cx="3333750" cy="514350"/>
           </a:xfrm>
           <a:prstGeom xmlns:a="http://schemas.openxmlformats.org/drawingml/2006/main" prst="rect">
             <a:avLst/>
@@ -1919,9 +1976,9 @@
           <a:lstStyle xmlns:a="http://schemas.openxmlformats.org/drawingml/2006/main"/>
           <a:p xmlns:a="http://schemas.openxmlformats.org/drawingml/2006/main">
             <a:pPr algn="l">
-              <a:defRPr sz="1650" b="0">
-                <a:solidFill>
-                  <a:srgbClr val="586F7B"/>
+              <a:defRPr sz="3150" b="1">
+                <a:solidFill>
+                  <a:srgbClr val="111111"/>
                 </a:solidFill>
                 <a:latin typeface="Arial"/>
                 <a:ea typeface="Arial"/>
@@ -1929,25 +1986,25 @@
               </a:defRPr>
             </a:pPr>
             <a:r>
-              <a:rPr sz="1650" b="0">
-                <a:solidFill>
-                  <a:srgbClr val="586F7B"/>
+              <a:rPr sz="3150" b="1">
+                <a:solidFill>
+                  <a:srgbClr val="111111"/>
                 </a:solidFill>
                 <a:latin typeface="Arial"/>
                 <a:ea typeface="Arial"/>
                 <a:cs typeface="Arial"/>
               </a:rPr>
-              <a:t>Prisforslag. DKK ekskl. moms. Abonnement + forbrug.</a:t>
+              <a:t>INTELLI</a:t>
             </a:r>
           </a:p>
         </p:txBody>
       </p:sp>
       <p:sp>
         <p:nvSpPr>
-          <p:cNvPr id="3" name="price-box-2">
+          <p:cNvPr id="4" name="text-3">
             <a:extLst xmlns:a="http://schemas.openxmlformats.org/drawingml/2006/main">
               <a:ext uri="{FF2B5EF4-FFF2-40B4-BE49-F238E27FC236}">
-                <a16:creationId xmlns:a16="http://schemas.microsoft.com/office/drawing/2014/main" id="{5AED73AC-A594-4282-B205-277EC511EAA4}"/>
+                <a16:creationId xmlns:a16="http://schemas.microsoft.com/office/drawing/2014/main" id="{1C5F21D7-AA6F-45C9-AE30-57D0A5ABE52E}"/>
               </a:ext>
             </a:extLst>
           </p:cNvPr>
@@ -1958,26 +2015,53 @@
         </p:nvSpPr>
         <p:spPr>
           <a:xfrm xmlns:a="http://schemas.openxmlformats.org/drawingml/2006/main">
-            <a:off x="609600" y="2000250"/>
-            <a:ext cx="2571750" cy="2705100"/>
+            <a:off x="628650" y="1028700"/>
+            <a:ext cx="3333750" cy="228600"/>
           </a:xfrm>
           <a:prstGeom xmlns:a="http://schemas.openxmlformats.org/drawingml/2006/main" prst="rect">
             <a:avLst/>
           </a:prstGeom>
-          <a:solidFill xmlns:a="http://schemas.openxmlformats.org/drawingml/2006/main">
-            <a:srgbClr val="173745"/>
-          </a:solidFill>
+          <a:noFill xmlns:a="http://schemas.openxmlformats.org/drawingml/2006/main"/>
           <a:ln xmlns:a="http://schemas.openxmlformats.org/drawingml/2006/main" w="0">
             <a:noFill/>
           </a:ln>
         </p:spPr>
+        <p:txBody>
+          <a:bodyPr xmlns:a="http://schemas.openxmlformats.org/drawingml/2006/main" lIns="0" tIns="0" rIns="0" bIns="0" anchor="t">
+            <a:noAutofit/>
+          </a:bodyPr>
+          <a:lstStyle xmlns:a="http://schemas.openxmlformats.org/drawingml/2006/main"/>
+          <a:p xmlns:a="http://schemas.openxmlformats.org/drawingml/2006/main">
+            <a:pPr algn="l">
+              <a:defRPr sz="1050" b="1">
+                <a:solidFill>
+                  <a:srgbClr val="444444"/>
+                </a:solidFill>
+                <a:latin typeface="Arial"/>
+                <a:ea typeface="Arial"/>
+                <a:cs typeface="Arial"/>
+              </a:defRPr>
+            </a:pPr>
+            <a:r>
+              <a:rPr sz="1050" b="1">
+                <a:solidFill>
+                  <a:srgbClr val="444444"/>
+                </a:solidFill>
+                <a:latin typeface="Arial"/>
+                <a:ea typeface="Arial"/>
+                <a:cs typeface="Arial"/>
+              </a:rPr>
+              <a:t>S O L U T I O N S</a:t>
+            </a:r>
+          </a:p>
+        </p:txBody>
       </p:sp>
       <p:sp>
         <p:nvSpPr>
-          <p:cNvPr id="4" name="text-3">
+          <p:cNvPr id="5" name="price-box-4">
             <a:extLst xmlns:a="http://schemas.openxmlformats.org/drawingml/2006/main">
               <a:ext uri="{FF2B5EF4-FFF2-40B4-BE49-F238E27FC236}">
-                <a16:creationId xmlns:a16="http://schemas.microsoft.com/office/drawing/2014/main" id="{8481DE56-6FC8-4F0E-9926-263BBAC833B4}"/>
+                <a16:creationId xmlns:a16="http://schemas.microsoft.com/office/drawing/2014/main" id="{70AE0401-5BBB-40AB-95DB-7B6DAFC10F63}"/>
               </a:ext>
             </a:extLst>
           </p:cNvPr>
@@ -1988,7 +2072,69 @@
         </p:nvSpPr>
         <p:spPr>
           <a:xfrm xmlns:a="http://schemas.openxmlformats.org/drawingml/2006/main">
-            <a:off x="838200" y="2247900"/>
+            <a:off x="609600" y="1457325"/>
+            <a:ext cx="10972800" cy="19050"/>
+          </a:xfrm>
+          <a:prstGeom xmlns:a="http://schemas.openxmlformats.org/drawingml/2006/main" prst="rect">
+            <a:avLst/>
+          </a:prstGeom>
+          <a:solidFill xmlns:a="http://schemas.openxmlformats.org/drawingml/2006/main">
+            <a:srgbClr val="111111"/>
+          </a:solidFill>
+          <a:ln xmlns:a="http://schemas.openxmlformats.org/drawingml/2006/main" w="0">
+            <a:noFill/>
+          </a:ln>
+        </p:spPr>
+      </p:sp>
+      <p:sp>
+        <p:nvSpPr>
+          <p:cNvPr id="6" name="price-box-5">
+            <a:extLst xmlns:a="http://schemas.openxmlformats.org/drawingml/2006/main">
+              <a:ext uri="{FF2B5EF4-FFF2-40B4-BE49-F238E27FC236}">
+                <a16:creationId xmlns:a16="http://schemas.microsoft.com/office/drawing/2014/main" id="{E85C712F-4D38-4366-B175-AFB58E5D277A}"/>
+              </a:ext>
+            </a:extLst>
+          </p:cNvPr>
+          <p:cNvSpPr>
+            <a:spLocks xmlns:a="http://schemas.openxmlformats.org/drawingml/2006/main" noGrp="1"/>
+          </p:cNvSpPr>
+          <p:nvPr/>
+        </p:nvSpPr>
+        <p:spPr>
+          <a:xfrm xmlns:a="http://schemas.openxmlformats.org/drawingml/2006/main">
+            <a:off x="609600" y="2381250"/>
+            <a:ext cx="2571750" cy="2876550"/>
+          </a:xfrm>
+          <a:prstGeom xmlns:a="http://schemas.openxmlformats.org/drawingml/2006/main" prst="rect">
+            <a:avLst/>
+          </a:prstGeom>
+          <a:solidFill xmlns:a="http://schemas.openxmlformats.org/drawingml/2006/main">
+            <a:srgbClr val="FFFFFF"/>
+          </a:solidFill>
+          <a:ln xmlns:a="http://schemas.openxmlformats.org/drawingml/2006/main" w="11430">
+            <a:solidFill>
+              <a:srgbClr val="666666"/>
+            </a:solidFill>
+          </a:ln>
+        </p:spPr>
+      </p:sp>
+      <p:sp>
+        <p:nvSpPr>
+          <p:cNvPr id="7" name="text-6">
+            <a:extLst xmlns:a="http://schemas.openxmlformats.org/drawingml/2006/main">
+              <a:ext uri="{FF2B5EF4-FFF2-40B4-BE49-F238E27FC236}">
+                <a16:creationId xmlns:a16="http://schemas.microsoft.com/office/drawing/2014/main" id="{2B34C7B2-4C19-4769-99EA-0ED6D844DC25}"/>
+              </a:ext>
+            </a:extLst>
+          </p:cNvPr>
+          <p:cNvSpPr>
+            <a:spLocks xmlns:a="http://schemas.openxmlformats.org/drawingml/2006/main" noGrp="1"/>
+          </p:cNvSpPr>
+          <p:nvPr/>
+        </p:nvSpPr>
+        <p:spPr>
+          <a:xfrm xmlns:a="http://schemas.openxmlformats.org/drawingml/2006/main">
+            <a:off x="838200" y="2638425"/>
             <a:ext cx="2114550" cy="590550"/>
           </a:xfrm>
           <a:prstGeom xmlns:a="http://schemas.openxmlformats.org/drawingml/2006/main" prst="rect">
@@ -2008,7 +2154,7 @@
             <a:pPr algn="l">
               <a:defRPr sz="1725" b="1">
                 <a:solidFill>
-                  <a:srgbClr val="FFFFFF"/>
+                  <a:srgbClr val="111111"/>
                 </a:solidFill>
                 <a:latin typeface="Arial"/>
                 <a:ea typeface="Arial"/>
@@ -2018,23 +2164,46 @@
             <a:r>
               <a:rPr sz="1725" b="1">
                 <a:solidFill>
-                  <a:srgbClr val="FFFFFF"/>
+                  <a:srgbClr val="111111"/>
                 </a:solidFill>
                 <a:latin typeface="Arial"/>
                 <a:ea typeface="Arial"/>
                 <a:cs typeface="Arial"/>
               </a:rPr>
-              <a:t>AI-telefon</a:t>
+              <a:t>DIGITAL</a:t>
+            </a:r>
+          </a:p>
+          <a:p xmlns:a="http://schemas.openxmlformats.org/drawingml/2006/main">
+            <a:pPr algn="l">
+              <a:defRPr sz="1725" b="1">
+                <a:solidFill>
+                  <a:srgbClr val="111111"/>
+                </a:solidFill>
+                <a:latin typeface="Arial"/>
+                <a:ea typeface="Arial"/>
+                <a:cs typeface="Arial"/>
+              </a:defRPr>
+            </a:pPr>
+            <a:r>
+              <a:rPr sz="1725" b="1">
+                <a:solidFill>
+                  <a:srgbClr val="111111"/>
+                </a:solidFill>
+                <a:latin typeface="Arial"/>
+                <a:ea typeface="Arial"/>
+                <a:cs typeface="Arial"/>
+              </a:rPr>
+              <a:t>MEDARBEJDER</a:t>
             </a:r>
           </a:p>
         </p:txBody>
       </p:sp>
       <p:sp>
         <p:nvSpPr>
-          <p:cNvPr id="5" name="text-4">
+          <p:cNvPr id="8" name="text-7">
             <a:extLst xmlns:a="http://schemas.openxmlformats.org/drawingml/2006/main">
               <a:ext uri="{FF2B5EF4-FFF2-40B4-BE49-F238E27FC236}">
-                <a16:creationId xmlns:a16="http://schemas.microsoft.com/office/drawing/2014/main" id="{3EEE0AE0-DCFE-43AE-8DCF-A8D500807DA7}"/>
+                <a16:creationId xmlns:a16="http://schemas.microsoft.com/office/drawing/2014/main" id="{BA13072F-816D-4868-B5D7-9EC00ED04CA7}"/>
               </a:ext>
             </a:extLst>
           </p:cNvPr>
@@ -2045,7 +2214,7 @@
         </p:nvSpPr>
         <p:spPr>
           <a:xfrm xmlns:a="http://schemas.openxmlformats.org/drawingml/2006/main">
-            <a:off x="838200" y="3000375"/>
+            <a:off x="838200" y="3486150"/>
             <a:ext cx="2114550" cy="666750"/>
           </a:xfrm>
           <a:prstGeom xmlns:a="http://schemas.openxmlformats.org/drawingml/2006/main" prst="rect">
@@ -2065,7 +2234,7 @@
             <a:pPr algn="l">
               <a:defRPr sz="3900" b="1">
                 <a:solidFill>
-                  <a:srgbClr val="FFFFFF"/>
+                  <a:srgbClr val="111111"/>
                 </a:solidFill>
                 <a:latin typeface="Arial"/>
                 <a:ea typeface="Arial"/>
@@ -2075,23 +2244,23 @@
             <a:r>
               <a:rPr sz="3900" b="1">
                 <a:solidFill>
-                  <a:srgbClr val="FFFFFF"/>
+                  <a:srgbClr val="111111"/>
                 </a:solidFill>
                 <a:latin typeface="Arial"/>
                 <a:ea typeface="Arial"/>
                 <a:cs typeface="Arial"/>
               </a:rPr>
-              <a:t>1,50</a:t>
+              <a:t>4.000,00</a:t>
             </a:r>
           </a:p>
         </p:txBody>
       </p:sp>
       <p:sp>
         <p:nvSpPr>
-          <p:cNvPr id="6" name="text-5">
+          <p:cNvPr id="9" name="text-8">
             <a:extLst xmlns:a="http://schemas.openxmlformats.org/drawingml/2006/main">
               <a:ext uri="{FF2B5EF4-FFF2-40B4-BE49-F238E27FC236}">
-                <a16:creationId xmlns:a16="http://schemas.microsoft.com/office/drawing/2014/main" id="{A0F2C17E-9E99-49E9-ABB1-DACC29034BF8}"/>
+                <a16:creationId xmlns:a16="http://schemas.microsoft.com/office/drawing/2014/main" id="{E675F250-0009-4ABA-BF9A-0995331EB72A}"/>
               </a:ext>
             </a:extLst>
           </p:cNvPr>
@@ -2102,7 +2271,7 @@
         </p:nvSpPr>
         <p:spPr>
           <a:xfrm xmlns:a="http://schemas.openxmlformats.org/drawingml/2006/main">
-            <a:off x="838200" y="3876675"/>
+            <a:off x="838200" y="4457700"/>
             <a:ext cx="2114550" cy="609600"/>
           </a:xfrm>
           <a:prstGeom xmlns:a="http://schemas.openxmlformats.org/drawingml/2006/main" prst="rect">
@@ -2122,7 +2291,7 @@
             <a:pPr algn="l">
               <a:defRPr sz="1650" b="0">
                 <a:solidFill>
-                  <a:srgbClr val="FFFFFF"/>
+                  <a:srgbClr val="333333"/>
                 </a:solidFill>
                 <a:latin typeface="Arial"/>
                 <a:ea typeface="Arial"/>
@@ -2132,23 +2301,23 @@
             <a:r>
               <a:rPr sz="1650" b="0">
                 <a:solidFill>
-                  <a:srgbClr val="FFFFFF"/>
+                  <a:srgbClr val="333333"/>
                 </a:solidFill>
                 <a:latin typeface="Arial"/>
                 <a:ea typeface="Arial"/>
                 <a:cs typeface="Arial"/>
               </a:rPr>
-              <a:t>kr. pr. påbegyndt minut</a:t>
+              <a:t>kr. pr. kanal / måned</a:t>
             </a:r>
           </a:p>
         </p:txBody>
       </p:sp>
       <p:sp>
         <p:nvSpPr>
-          <p:cNvPr id="7" name="price-box-6">
+          <p:cNvPr id="10" name="price-box-9">
             <a:extLst xmlns:a="http://schemas.openxmlformats.org/drawingml/2006/main">
               <a:ext uri="{FF2B5EF4-FFF2-40B4-BE49-F238E27FC236}">
-                <a16:creationId xmlns:a16="http://schemas.microsoft.com/office/drawing/2014/main" id="{7F87160D-0301-4BE1-97C8-CA2BA1F99CA3}"/>
+                <a16:creationId xmlns:a16="http://schemas.microsoft.com/office/drawing/2014/main" id="{DD48B4D4-D6CD-417D-AA5B-01B17F2433D2}"/>
               </a:ext>
             </a:extLst>
           </p:cNvPr>
@@ -2159,26 +2328,28 @@
         </p:nvSpPr>
         <p:spPr>
           <a:xfrm xmlns:a="http://schemas.openxmlformats.org/drawingml/2006/main">
-            <a:off x="3409950" y="2000250"/>
-            <a:ext cx="2571750" cy="2705100"/>
+            <a:off x="3409950" y="2381250"/>
+            <a:ext cx="2571750" cy="2876550"/>
           </a:xfrm>
           <a:prstGeom xmlns:a="http://schemas.openxmlformats.org/drawingml/2006/main" prst="rect">
             <a:avLst/>
           </a:prstGeom>
           <a:solidFill xmlns:a="http://schemas.openxmlformats.org/drawingml/2006/main">
-            <a:srgbClr val="EAF4F1"/>
+            <a:srgbClr val="FFFFFF"/>
           </a:solidFill>
-          <a:ln xmlns:a="http://schemas.openxmlformats.org/drawingml/2006/main" w="0">
-            <a:noFill/>
+          <a:ln xmlns:a="http://schemas.openxmlformats.org/drawingml/2006/main" w="11430">
+            <a:solidFill>
+              <a:srgbClr val="666666"/>
+            </a:solidFill>
           </a:ln>
         </p:spPr>
       </p:sp>
       <p:sp>
         <p:nvSpPr>
-          <p:cNvPr id="8" name="text-7">
+          <p:cNvPr id="11" name="text-10">
             <a:extLst xmlns:a="http://schemas.openxmlformats.org/drawingml/2006/main">
               <a:ext uri="{FF2B5EF4-FFF2-40B4-BE49-F238E27FC236}">
-                <a16:creationId xmlns:a16="http://schemas.microsoft.com/office/drawing/2014/main" id="{F16CD135-BEF7-495A-90CC-827BA9ACC3AD}"/>
+                <a16:creationId xmlns:a16="http://schemas.microsoft.com/office/drawing/2014/main" id="{3B7D2350-C157-4CE1-A573-2E89F0D473BA}"/>
               </a:ext>
             </a:extLst>
           </p:cNvPr>
@@ -2189,7 +2360,7 @@
         </p:nvSpPr>
         <p:spPr>
           <a:xfrm xmlns:a="http://schemas.openxmlformats.org/drawingml/2006/main">
-            <a:off x="3638550" y="2247900"/>
+            <a:off x="3638550" y="2638425"/>
             <a:ext cx="2114550" cy="590550"/>
           </a:xfrm>
           <a:prstGeom xmlns:a="http://schemas.openxmlformats.org/drawingml/2006/main" prst="rect">
@@ -2209,7 +2380,7 @@
             <a:pPr algn="l">
               <a:defRPr sz="1725" b="1">
                 <a:solidFill>
-                  <a:srgbClr val="173745"/>
+                  <a:srgbClr val="111111"/>
                 </a:solidFill>
                 <a:latin typeface="Arial"/>
                 <a:ea typeface="Arial"/>
@@ -2219,23 +2390,23 @@
             <a:r>
               <a:rPr sz="1725" b="1">
                 <a:solidFill>
-                  <a:srgbClr val="173745"/>
+                  <a:srgbClr val="111111"/>
                 </a:solidFill>
                 <a:latin typeface="Arial"/>
                 <a:ea typeface="Arial"/>
                 <a:cs typeface="Arial"/>
               </a:rPr>
-              <a:t>Digital medarbejder</a:t>
+              <a:t>AI-TELEFON</a:t>
             </a:r>
           </a:p>
         </p:txBody>
       </p:sp>
       <p:sp>
         <p:nvSpPr>
-          <p:cNvPr id="9" name="text-8">
+          <p:cNvPr id="12" name="text-11">
             <a:extLst xmlns:a="http://schemas.openxmlformats.org/drawingml/2006/main">
               <a:ext uri="{FF2B5EF4-FFF2-40B4-BE49-F238E27FC236}">
-                <a16:creationId xmlns:a16="http://schemas.microsoft.com/office/drawing/2014/main" id="{5DFC09E6-2227-4D7E-BE98-C7ADF9E8A54B}"/>
+                <a16:creationId xmlns:a16="http://schemas.microsoft.com/office/drawing/2014/main" id="{B024EA47-6DC6-4D17-AFC0-77FF7F78C988}"/>
               </a:ext>
             </a:extLst>
           </p:cNvPr>
@@ -2246,7 +2417,7 @@
         </p:nvSpPr>
         <p:spPr>
           <a:xfrm xmlns:a="http://schemas.openxmlformats.org/drawingml/2006/main">
-            <a:off x="3638550" y="3000375"/>
+            <a:off x="3638550" y="3486150"/>
             <a:ext cx="2114550" cy="666750"/>
           </a:xfrm>
           <a:prstGeom xmlns:a="http://schemas.openxmlformats.org/drawingml/2006/main" prst="rect">
@@ -2266,7 +2437,7 @@
             <a:pPr algn="l">
               <a:defRPr sz="3900" b="1">
                 <a:solidFill>
-                  <a:srgbClr val="173745"/>
+                  <a:srgbClr val="111111"/>
                 </a:solidFill>
                 <a:latin typeface="Arial"/>
                 <a:ea typeface="Arial"/>
@@ -2276,23 +2447,23 @@
             <a:r>
               <a:rPr sz="3900" b="1">
                 <a:solidFill>
-                  <a:srgbClr val="173745"/>
+                  <a:srgbClr val="111111"/>
                 </a:solidFill>
                 <a:latin typeface="Arial"/>
                 <a:ea typeface="Arial"/>
                 <a:cs typeface="Arial"/>
               </a:rPr>
-              <a:t>4.000,00</a:t>
+              <a:t>1,50</a:t>
             </a:r>
           </a:p>
         </p:txBody>
       </p:sp>
       <p:sp>
         <p:nvSpPr>
-          <p:cNvPr id="10" name="text-9">
+          <p:cNvPr id="13" name="text-12">
             <a:extLst xmlns:a="http://schemas.openxmlformats.org/drawingml/2006/main">
               <a:ext uri="{FF2B5EF4-FFF2-40B4-BE49-F238E27FC236}">
-                <a16:creationId xmlns:a16="http://schemas.microsoft.com/office/drawing/2014/main" id="{479F459A-F4D7-4F40-B16C-C3B7E764794B}"/>
+                <a16:creationId xmlns:a16="http://schemas.microsoft.com/office/drawing/2014/main" id="{EDEF3CC3-C0D1-459F-9268-56B66A5C59B8}"/>
               </a:ext>
             </a:extLst>
           </p:cNvPr>
@@ -2303,7 +2474,7 @@
         </p:nvSpPr>
         <p:spPr>
           <a:xfrm xmlns:a="http://schemas.openxmlformats.org/drawingml/2006/main">
-            <a:off x="3638550" y="3876675"/>
+            <a:off x="3638550" y="4457700"/>
             <a:ext cx="2114550" cy="609600"/>
           </a:xfrm>
           <a:prstGeom xmlns:a="http://schemas.openxmlformats.org/drawingml/2006/main" prst="rect">
@@ -2323,7 +2494,7 @@
             <a:pPr algn="l">
               <a:defRPr sz="1650" b="0">
                 <a:solidFill>
-                  <a:srgbClr val="173745"/>
+                  <a:srgbClr val="333333"/>
                 </a:solidFill>
                 <a:latin typeface="Arial"/>
                 <a:ea typeface="Arial"/>
@@ -2333,23 +2504,23 @@
             <a:r>
               <a:rPr sz="1650" b="0">
                 <a:solidFill>
-                  <a:srgbClr val="173745"/>
+                  <a:srgbClr val="333333"/>
                 </a:solidFill>
                 <a:latin typeface="Arial"/>
                 <a:ea typeface="Arial"/>
                 <a:cs typeface="Arial"/>
               </a:rPr>
-              <a:t>kr. pr. kanal / måned</a:t>
+              <a:t>kr. pr. påbegyndt minut</a:t>
             </a:r>
           </a:p>
         </p:txBody>
       </p:sp>
       <p:sp>
         <p:nvSpPr>
-          <p:cNvPr id="11" name="price-box-10">
+          <p:cNvPr id="14" name="price-box-13">
             <a:extLst xmlns:a="http://schemas.openxmlformats.org/drawingml/2006/main">
               <a:ext uri="{FF2B5EF4-FFF2-40B4-BE49-F238E27FC236}">
-                <a16:creationId xmlns:a16="http://schemas.microsoft.com/office/drawing/2014/main" id="{AE538EB6-24B7-4A23-877C-C1CC7EA9EB83}"/>
+                <a16:creationId xmlns:a16="http://schemas.microsoft.com/office/drawing/2014/main" id="{16A48798-2146-4277-B473-6B4DACADDADB}"/>
               </a:ext>
             </a:extLst>
           </p:cNvPr>
@@ -2360,26 +2531,28 @@
         </p:nvSpPr>
         <p:spPr>
           <a:xfrm xmlns:a="http://schemas.openxmlformats.org/drawingml/2006/main">
-            <a:off x="6210300" y="2000250"/>
-            <a:ext cx="2571750" cy="2705100"/>
+            <a:off x="6210300" y="2381250"/>
+            <a:ext cx="2571750" cy="2876550"/>
           </a:xfrm>
           <a:prstGeom xmlns:a="http://schemas.openxmlformats.org/drawingml/2006/main" prst="rect">
             <a:avLst/>
           </a:prstGeom>
           <a:solidFill xmlns:a="http://schemas.openxmlformats.org/drawingml/2006/main">
-            <a:srgbClr val="EAF4F1"/>
+            <a:srgbClr val="FFFFFF"/>
           </a:solidFill>
-          <a:ln xmlns:a="http://schemas.openxmlformats.org/drawingml/2006/main" w="0">
-            <a:noFill/>
+          <a:ln xmlns:a="http://schemas.openxmlformats.org/drawingml/2006/main" w="11430">
+            <a:solidFill>
+              <a:srgbClr val="666666"/>
+            </a:solidFill>
           </a:ln>
         </p:spPr>
       </p:sp>
       <p:sp>
         <p:nvSpPr>
-          <p:cNvPr id="12" name="text-11">
+          <p:cNvPr id="15" name="text-14">
             <a:extLst xmlns:a="http://schemas.openxmlformats.org/drawingml/2006/main">
               <a:ext uri="{FF2B5EF4-FFF2-40B4-BE49-F238E27FC236}">
-                <a16:creationId xmlns:a16="http://schemas.microsoft.com/office/drawing/2014/main" id="{E70FEC0C-2828-4EDE-9739-DDA55D399220}"/>
+                <a16:creationId xmlns:a16="http://schemas.microsoft.com/office/drawing/2014/main" id="{50A46065-04AD-420A-BFEC-B021D1709988}"/>
               </a:ext>
             </a:extLst>
           </p:cNvPr>
@@ -2390,7 +2563,7 @@
         </p:nvSpPr>
         <p:spPr>
           <a:xfrm xmlns:a="http://schemas.openxmlformats.org/drawingml/2006/main">
-            <a:off x="6438900" y="2247900"/>
+            <a:off x="6438900" y="2638425"/>
             <a:ext cx="2114550" cy="590550"/>
           </a:xfrm>
           <a:prstGeom xmlns:a="http://schemas.openxmlformats.org/drawingml/2006/main" prst="rect">
@@ -2410,7 +2583,7 @@
             <a:pPr algn="l">
               <a:defRPr sz="1725" b="1">
                 <a:solidFill>
-                  <a:srgbClr val="173745"/>
+                  <a:srgbClr val="111111"/>
                 </a:solidFill>
                 <a:latin typeface="Arial"/>
                 <a:ea typeface="Arial"/>
@@ -2420,23 +2593,23 @@
             <a:r>
               <a:rPr sz="1725" b="1">
                 <a:solidFill>
-                  <a:srgbClr val="173745"/>
+                  <a:srgbClr val="111111"/>
                 </a:solidFill>
                 <a:latin typeface="Arial"/>
                 <a:ea typeface="Arial"/>
                 <a:cs typeface="Arial"/>
               </a:rPr>
-              <a:t>Omstilling til DK mobil</a:t>
+              <a:t>OMSTILLING I DK</a:t>
             </a:r>
           </a:p>
         </p:txBody>
       </p:sp>
       <p:sp>
         <p:nvSpPr>
-          <p:cNvPr id="13" name="text-12">
+          <p:cNvPr id="16" name="text-15">
             <a:extLst xmlns:a="http://schemas.openxmlformats.org/drawingml/2006/main">
               <a:ext uri="{FF2B5EF4-FFF2-40B4-BE49-F238E27FC236}">
-                <a16:creationId xmlns:a16="http://schemas.microsoft.com/office/drawing/2014/main" id="{34790400-F749-456B-8B07-BFBC01FF7561}"/>
+                <a16:creationId xmlns:a16="http://schemas.microsoft.com/office/drawing/2014/main" id="{36B22A8A-BE1E-4A91-97F3-DDC0B176B090}"/>
               </a:ext>
             </a:extLst>
           </p:cNvPr>
@@ -2447,7 +2620,7 @@
         </p:nvSpPr>
         <p:spPr>
           <a:xfrm xmlns:a="http://schemas.openxmlformats.org/drawingml/2006/main">
-            <a:off x="6438900" y="3000375"/>
+            <a:off x="6438900" y="3486150"/>
             <a:ext cx="2114550" cy="666750"/>
           </a:xfrm>
           <a:prstGeom xmlns:a="http://schemas.openxmlformats.org/drawingml/2006/main" prst="rect">
@@ -2467,7 +2640,7 @@
             <a:pPr algn="l">
               <a:defRPr sz="3900" b="1">
                 <a:solidFill>
-                  <a:srgbClr val="173745"/>
+                  <a:srgbClr val="111111"/>
                 </a:solidFill>
                 <a:latin typeface="Arial"/>
                 <a:ea typeface="Arial"/>
@@ -2477,23 +2650,23 @@
             <a:r>
               <a:rPr sz="3900" b="1">
                 <a:solidFill>
-                  <a:srgbClr val="173745"/>
+                  <a:srgbClr val="111111"/>
                 </a:solidFill>
                 <a:latin typeface="Arial"/>
                 <a:ea typeface="Arial"/>
                 <a:cs typeface="Arial"/>
               </a:rPr>
-              <a:t>0,49</a:t>
+              <a:t>0,50</a:t>
             </a:r>
           </a:p>
         </p:txBody>
       </p:sp>
       <p:sp>
         <p:nvSpPr>
-          <p:cNvPr id="14" name="text-13">
+          <p:cNvPr id="17" name="text-16">
             <a:extLst xmlns:a="http://schemas.openxmlformats.org/drawingml/2006/main">
               <a:ext uri="{FF2B5EF4-FFF2-40B4-BE49-F238E27FC236}">
-                <a16:creationId xmlns:a16="http://schemas.microsoft.com/office/drawing/2014/main" id="{0A16B7AD-309B-476D-8037-4AD59251D7F4}"/>
+                <a16:creationId xmlns:a16="http://schemas.microsoft.com/office/drawing/2014/main" id="{C22DAF60-549C-4CEE-8490-D05A7E7F6F3F}"/>
               </a:ext>
             </a:extLst>
           </p:cNvPr>
@@ -2504,7 +2677,7 @@
         </p:nvSpPr>
         <p:spPr>
           <a:xfrm xmlns:a="http://schemas.openxmlformats.org/drawingml/2006/main">
-            <a:off x="6438900" y="3876675"/>
+            <a:off x="6438900" y="4457700"/>
             <a:ext cx="2114550" cy="609600"/>
           </a:xfrm>
           <a:prstGeom xmlns:a="http://schemas.openxmlformats.org/drawingml/2006/main" prst="rect">
@@ -2524,7 +2697,7 @@
             <a:pPr algn="l">
               <a:defRPr sz="1650" b="0">
                 <a:solidFill>
-                  <a:srgbClr val="173745"/>
+                  <a:srgbClr val="333333"/>
                 </a:solidFill>
                 <a:latin typeface="Arial"/>
                 <a:ea typeface="Arial"/>
@@ -2534,7 +2707,7 @@
             <a:r>
               <a:rPr sz="1650" b="0">
                 <a:solidFill>
-                  <a:srgbClr val="173745"/>
+                  <a:srgbClr val="333333"/>
                 </a:solidFill>
                 <a:latin typeface="Arial"/>
                 <a:ea typeface="Arial"/>
@@ -2547,10 +2720,10 @@
       </p:sp>
       <p:sp>
         <p:nvSpPr>
-          <p:cNvPr id="15" name="price-box-14">
+          <p:cNvPr id="18" name="price-box-17">
             <a:extLst xmlns:a="http://schemas.openxmlformats.org/drawingml/2006/main">
               <a:ext uri="{FF2B5EF4-FFF2-40B4-BE49-F238E27FC236}">
-                <a16:creationId xmlns:a16="http://schemas.microsoft.com/office/drawing/2014/main" id="{8E54A096-9EC8-47DD-A101-2E1AC567CEC1}"/>
+                <a16:creationId xmlns:a16="http://schemas.microsoft.com/office/drawing/2014/main" id="{90EDEF4A-DAEF-4C6E-B9A9-B3A1BF8CFCEB}"/>
               </a:ext>
             </a:extLst>
           </p:cNvPr>
@@ -2561,26 +2734,28 @@
         </p:nvSpPr>
         <p:spPr>
           <a:xfrm xmlns:a="http://schemas.openxmlformats.org/drawingml/2006/main">
-            <a:off x="9010650" y="2000250"/>
-            <a:ext cx="2571750" cy="2705100"/>
+            <a:off x="9010650" y="2381250"/>
+            <a:ext cx="2571750" cy="2876550"/>
           </a:xfrm>
           <a:prstGeom xmlns:a="http://schemas.openxmlformats.org/drawingml/2006/main" prst="rect">
             <a:avLst/>
           </a:prstGeom>
           <a:solidFill xmlns:a="http://schemas.openxmlformats.org/drawingml/2006/main">
-            <a:srgbClr val="EAF4F1"/>
+            <a:srgbClr val="FFFFFF"/>
           </a:solidFill>
-          <a:ln xmlns:a="http://schemas.openxmlformats.org/drawingml/2006/main" w="0">
-            <a:noFill/>
+          <a:ln xmlns:a="http://schemas.openxmlformats.org/drawingml/2006/main" w="11430">
+            <a:solidFill>
+              <a:srgbClr val="666666"/>
+            </a:solidFill>
           </a:ln>
         </p:spPr>
       </p:sp>
       <p:sp>
         <p:nvSpPr>
-          <p:cNvPr id="16" name="text-15">
+          <p:cNvPr id="19" name="text-18">
             <a:extLst xmlns:a="http://schemas.openxmlformats.org/drawingml/2006/main">
               <a:ext uri="{FF2B5EF4-FFF2-40B4-BE49-F238E27FC236}">
-                <a16:creationId xmlns:a16="http://schemas.microsoft.com/office/drawing/2014/main" id="{7A2DE2B0-7766-4711-8714-7C0A63BF58CF}"/>
+                <a16:creationId xmlns:a16="http://schemas.microsoft.com/office/drawing/2014/main" id="{6DF22102-C840-44BB-8A63-533BC1C9EC25}"/>
               </a:ext>
             </a:extLst>
           </p:cNvPr>
@@ -2591,7 +2766,7 @@
         </p:nvSpPr>
         <p:spPr>
           <a:xfrm xmlns:a="http://schemas.openxmlformats.org/drawingml/2006/main">
-            <a:off x="9239250" y="2247900"/>
+            <a:off x="9239250" y="2638425"/>
             <a:ext cx="2114550" cy="590550"/>
           </a:xfrm>
           <a:prstGeom xmlns:a="http://schemas.openxmlformats.org/drawingml/2006/main" prst="rect">
@@ -2611,7 +2786,7 @@
             <a:pPr algn="l">
               <a:defRPr sz="1725" b="1">
                 <a:solidFill>
-                  <a:srgbClr val="173745"/>
+                  <a:srgbClr val="111111"/>
                 </a:solidFill>
                 <a:latin typeface="Arial"/>
                 <a:ea typeface="Arial"/>
@@ -2621,23 +2796,23 @@
             <a:r>
               <a:rPr sz="1725" b="1">
                 <a:solidFill>
-                  <a:srgbClr val="173745"/>
+                  <a:srgbClr val="111111"/>
                 </a:solidFill>
                 <a:latin typeface="Arial"/>
                 <a:ea typeface="Arial"/>
                 <a:cs typeface="Arial"/>
               </a:rPr>
-              <a:t>Omstilling til DK fastnet</a:t>
+              <a:t>SMS UD</a:t>
             </a:r>
           </a:p>
         </p:txBody>
       </p:sp>
       <p:sp>
         <p:nvSpPr>
-          <p:cNvPr id="17" name="text-16">
+          <p:cNvPr id="20" name="text-19">
             <a:extLst xmlns:a="http://schemas.openxmlformats.org/drawingml/2006/main">
               <a:ext uri="{FF2B5EF4-FFF2-40B4-BE49-F238E27FC236}">
-                <a16:creationId xmlns:a16="http://schemas.microsoft.com/office/drawing/2014/main" id="{F9C960B6-2CF2-4182-AD26-AFB7CF5FBADF}"/>
+                <a16:creationId xmlns:a16="http://schemas.microsoft.com/office/drawing/2014/main" id="{393C2B8C-BF40-472C-9962-CF92F245357B}"/>
               </a:ext>
             </a:extLst>
           </p:cNvPr>
@@ -2648,7 +2823,7 @@
         </p:nvSpPr>
         <p:spPr>
           <a:xfrm xmlns:a="http://schemas.openxmlformats.org/drawingml/2006/main">
-            <a:off x="9239250" y="3000375"/>
+            <a:off x="9239250" y="3486150"/>
             <a:ext cx="2114550" cy="666750"/>
           </a:xfrm>
           <a:prstGeom xmlns:a="http://schemas.openxmlformats.org/drawingml/2006/main" prst="rect">
@@ -2668,7 +2843,7 @@
             <a:pPr algn="l">
               <a:defRPr sz="3900" b="1">
                 <a:solidFill>
-                  <a:srgbClr val="173745"/>
+                  <a:srgbClr val="111111"/>
                 </a:solidFill>
                 <a:latin typeface="Arial"/>
                 <a:ea typeface="Arial"/>
@@ -2678,23 +2853,23 @@
             <a:r>
               <a:rPr sz="3900" b="1">
                 <a:solidFill>
-                  <a:srgbClr val="173745"/>
+                  <a:srgbClr val="111111"/>
                 </a:solidFill>
                 <a:latin typeface="Arial"/>
                 <a:ea typeface="Arial"/>
                 <a:cs typeface="Arial"/>
               </a:rPr>
-              <a:t>0,29</a:t>
+              <a:t>0,35</a:t>
             </a:r>
           </a:p>
         </p:txBody>
       </p:sp>
       <p:sp>
         <p:nvSpPr>
-          <p:cNvPr id="18" name="text-17">
+          <p:cNvPr id="21" name="text-20">
             <a:extLst xmlns:a="http://schemas.openxmlformats.org/drawingml/2006/main">
               <a:ext uri="{FF2B5EF4-FFF2-40B4-BE49-F238E27FC236}">
-                <a16:creationId xmlns:a16="http://schemas.microsoft.com/office/drawing/2014/main" id="{E9916443-D76A-42F0-81BE-E1BF79A94D96}"/>
+                <a16:creationId xmlns:a16="http://schemas.microsoft.com/office/drawing/2014/main" id="{32C314D9-7AC9-4930-898D-0F67A2E351EC}"/>
               </a:ext>
             </a:extLst>
           </p:cNvPr>
@@ -2705,7 +2880,7 @@
         </p:nvSpPr>
         <p:spPr>
           <a:xfrm xmlns:a="http://schemas.openxmlformats.org/drawingml/2006/main">
-            <a:off x="9239250" y="3876675"/>
+            <a:off x="9239250" y="4457700"/>
             <a:ext cx="2114550" cy="609600"/>
           </a:xfrm>
           <a:prstGeom xmlns:a="http://schemas.openxmlformats.org/drawingml/2006/main" prst="rect">
@@ -2725,7 +2900,7 @@
             <a:pPr algn="l">
               <a:defRPr sz="1650" b="0">
                 <a:solidFill>
-                  <a:srgbClr val="173745"/>
+                  <a:srgbClr val="333333"/>
                 </a:solidFill>
                 <a:latin typeface="Arial"/>
                 <a:ea typeface="Arial"/>
@@ -2735,241 +2910,13 @@
             <a:r>
               <a:rPr sz="1650" b="0">
                 <a:solidFill>
-                  <a:srgbClr val="173745"/>
+                  <a:srgbClr val="333333"/>
                 </a:solidFill>
                 <a:latin typeface="Arial"/>
                 <a:ea typeface="Arial"/>
                 <a:cs typeface="Arial"/>
               </a:rPr>
-              <a:t>kr. pr. påbegyndt minut</a:t>
-            </a:r>
-          </a:p>
-        </p:txBody>
-      </p:sp>
-      <p:sp>
-        <p:nvSpPr>
-          <p:cNvPr id="19" name="text-18">
-            <a:extLst xmlns:a="http://schemas.openxmlformats.org/drawingml/2006/main">
-              <a:ext uri="{FF2B5EF4-FFF2-40B4-BE49-F238E27FC236}">
-                <a16:creationId xmlns:a16="http://schemas.microsoft.com/office/drawing/2014/main" id="{F8782298-4837-4B7B-B864-D5F43844783E}"/>
-              </a:ext>
-            </a:extLst>
-          </p:cNvPr>
-          <p:cNvSpPr>
-            <a:spLocks xmlns:a="http://schemas.openxmlformats.org/drawingml/2006/main" noGrp="1"/>
-          </p:cNvSpPr>
-          <p:nvPr/>
-        </p:nvSpPr>
-        <p:spPr>
-          <a:xfrm xmlns:a="http://schemas.openxmlformats.org/drawingml/2006/main">
-            <a:off x="609600" y="5095875"/>
-            <a:ext cx="10972800" cy="400050"/>
-          </a:xfrm>
-          <a:prstGeom xmlns:a="http://schemas.openxmlformats.org/drawingml/2006/main" prst="rect">
-            <a:avLst/>
-          </a:prstGeom>
-          <a:noFill xmlns:a="http://schemas.openxmlformats.org/drawingml/2006/main"/>
-          <a:ln xmlns:a="http://schemas.openxmlformats.org/drawingml/2006/main" w="0">
-            <a:noFill/>
-          </a:ln>
-        </p:spPr>
-        <p:txBody>
-          <a:bodyPr xmlns:a="http://schemas.openxmlformats.org/drawingml/2006/main" lIns="0" tIns="0" rIns="0" bIns="0" anchor="t">
-            <a:noAutofit/>
-          </a:bodyPr>
-          <a:lstStyle xmlns:a="http://schemas.openxmlformats.org/drawingml/2006/main"/>
-          <a:p xmlns:a="http://schemas.openxmlformats.org/drawingml/2006/main">
-            <a:pPr algn="l">
-              <a:defRPr sz="2175" b="1">
-                <a:solidFill>
-                  <a:srgbClr val="173745"/>
-                </a:solidFill>
-                <a:latin typeface="Arial"/>
-                <a:ea typeface="Arial"/>
-                <a:cs typeface="Arial"/>
-              </a:defRPr>
-            </a:pPr>
-            <a:r>
-              <a:rPr sz="2175" b="1">
-                <a:solidFill>
-                  <a:srgbClr val="173745"/>
-                </a:solidFill>
-                <a:latin typeface="Arial"/>
-                <a:ea typeface="Arial"/>
-                <a:cs typeface="Arial"/>
-              </a:rPr>
-              <a:t>Månedspris = abonnement + AI-minutter + omstilling</a:t>
-            </a:r>
-          </a:p>
-        </p:txBody>
-      </p:sp>
-      <p:sp>
-        <p:nvSpPr>
-          <p:cNvPr id="20" name="text-19">
-            <a:extLst xmlns:a="http://schemas.openxmlformats.org/drawingml/2006/main">
-              <a:ext uri="{FF2B5EF4-FFF2-40B4-BE49-F238E27FC236}">
-                <a16:creationId xmlns:a16="http://schemas.microsoft.com/office/drawing/2014/main" id="{D4015E78-E306-48F1-BA36-0A47B8EFFDD8}"/>
-              </a:ext>
-            </a:extLst>
-          </p:cNvPr>
-          <p:cNvSpPr>
-            <a:spLocks xmlns:a="http://schemas.openxmlformats.org/drawingml/2006/main" noGrp="1"/>
-          </p:cNvSpPr>
-          <p:nvPr/>
-        </p:nvSpPr>
-        <p:spPr>
-          <a:xfrm xmlns:a="http://schemas.openxmlformats.org/drawingml/2006/main">
-            <a:off x="609600" y="5619750"/>
-            <a:ext cx="10972800" cy="323850"/>
-          </a:xfrm>
-          <a:prstGeom xmlns:a="http://schemas.openxmlformats.org/drawingml/2006/main" prst="rect">
-            <a:avLst/>
-          </a:prstGeom>
-          <a:noFill xmlns:a="http://schemas.openxmlformats.org/drawingml/2006/main"/>
-          <a:ln xmlns:a="http://schemas.openxmlformats.org/drawingml/2006/main" w="0">
-            <a:noFill/>
-          </a:ln>
-        </p:spPr>
-        <p:txBody>
-          <a:bodyPr xmlns:a="http://schemas.openxmlformats.org/drawingml/2006/main" lIns="0" tIns="0" rIns="0" bIns="0" anchor="t">
-            <a:noAutofit/>
-          </a:bodyPr>
-          <a:lstStyle xmlns:a="http://schemas.openxmlformats.org/drawingml/2006/main"/>
-          <a:p xmlns:a="http://schemas.openxmlformats.org/drawingml/2006/main">
-            <a:pPr algn="l">
-              <a:defRPr sz="1575" b="0">
-                <a:solidFill>
-                  <a:srgbClr val="173745"/>
-                </a:solidFill>
-                <a:latin typeface="Arial"/>
-                <a:ea typeface="Arial"/>
-                <a:cs typeface="Arial"/>
-              </a:defRPr>
-            </a:pPr>
-            <a:r>
-              <a:rPr sz="1575" b="0">
-                <a:solidFill>
-                  <a:srgbClr val="173745"/>
-                </a:solidFill>
-                <a:latin typeface="Arial"/>
-                <a:ea typeface="Arial"/>
-                <a:cs typeface="Arial"/>
-              </a:rPr>
-              <a:t>Én kanal = én samtidig samtale. Maks. 8 min. AI, så betalt omstilling. Ingen inkluderede minutter.</a:t>
-            </a:r>
-          </a:p>
-        </p:txBody>
-      </p:sp>
-      <p:sp>
-        <p:nvSpPr>
-          <p:cNvPr id="21" name="text-20">
-            <a:extLst xmlns:a="http://schemas.openxmlformats.org/drawingml/2006/main">
-              <a:ext uri="{FF2B5EF4-FFF2-40B4-BE49-F238E27FC236}">
-                <a16:creationId xmlns:a16="http://schemas.microsoft.com/office/drawing/2014/main" id="{5B4857E3-D966-40D4-85BD-CD2A808DB246}"/>
-              </a:ext>
-            </a:extLst>
-          </p:cNvPr>
-          <p:cNvSpPr>
-            <a:spLocks xmlns:a="http://schemas.openxmlformats.org/drawingml/2006/main" noGrp="1"/>
-          </p:cNvSpPr>
-          <p:nvPr/>
-        </p:nvSpPr>
-        <p:spPr>
-          <a:xfrm xmlns:a="http://schemas.openxmlformats.org/drawingml/2006/main">
-            <a:off x="609600" y="6057900"/>
-            <a:ext cx="10382250" cy="571500"/>
-          </a:xfrm>
-          <a:prstGeom xmlns:a="http://schemas.openxmlformats.org/drawingml/2006/main" prst="rect">
-            <a:avLst/>
-          </a:prstGeom>
-          <a:noFill xmlns:a="http://schemas.openxmlformats.org/drawingml/2006/main"/>
-          <a:ln xmlns:a="http://schemas.openxmlformats.org/drawingml/2006/main" w="0">
-            <a:noFill/>
-          </a:ln>
-        </p:spPr>
-        <p:txBody>
-          <a:bodyPr xmlns:a="http://schemas.openxmlformats.org/drawingml/2006/main" lIns="0" tIns="0" rIns="0" bIns="0" anchor="t">
-            <a:noAutofit/>
-          </a:bodyPr>
-          <a:lstStyle xmlns:a="http://schemas.openxmlformats.org/drawingml/2006/main"/>
-          <a:p xmlns:a="http://schemas.openxmlformats.org/drawingml/2006/main">
-            <a:pPr algn="l">
-              <a:defRPr sz="1350" b="0">
-                <a:solidFill>
-                  <a:srgbClr val="586F7B"/>
-                </a:solidFill>
-                <a:latin typeface="Arial"/>
-                <a:ea typeface="Arial"/>
-                <a:cs typeface="Arial"/>
-              </a:defRPr>
-            </a:pPr>
-            <a:r>
-              <a:rPr sz="1350" b="0">
-                <a:solidFill>
-                  <a:srgbClr val="586F7B"/>
-                </a:solidFill>
-                <a:latin typeface="Arial"/>
-                <a:ea typeface="Arial"/>
-                <a:cs typeface="Arial"/>
-              </a:rPr>
-              <a:t>AI-fasen og omstillingen afregnes hver for sig. Fast AI-pris kræver koststop. Se forudsætninger på side 8.</a:t>
-            </a:r>
-          </a:p>
-        </p:txBody>
-      </p:sp>
-      <p:sp>
-        <p:nvSpPr>
-          <p:cNvPr id="22" name="text-21">
-            <a:extLst xmlns:a="http://schemas.openxmlformats.org/drawingml/2006/main">
-              <a:ext uri="{FF2B5EF4-FFF2-40B4-BE49-F238E27FC236}">
-                <a16:creationId xmlns:a16="http://schemas.microsoft.com/office/drawing/2014/main" id="{4EC97957-D628-400D-A758-2389FB3D5007}"/>
-              </a:ext>
-            </a:extLst>
-          </p:cNvPr>
-          <p:cNvSpPr>
-            <a:spLocks xmlns:a="http://schemas.openxmlformats.org/drawingml/2006/main" noGrp="1"/>
-          </p:cNvSpPr>
-          <p:nvPr/>
-        </p:nvSpPr>
-        <p:spPr>
-          <a:xfrm xmlns:a="http://schemas.openxmlformats.org/drawingml/2006/main">
-            <a:off x="11163300" y="6486525"/>
-            <a:ext cx="685800" cy="209550"/>
-          </a:xfrm>
-          <a:prstGeom xmlns:a="http://schemas.openxmlformats.org/drawingml/2006/main" prst="rect">
-            <a:avLst/>
-          </a:prstGeom>
-          <a:noFill xmlns:a="http://schemas.openxmlformats.org/drawingml/2006/main"/>
-          <a:ln xmlns:a="http://schemas.openxmlformats.org/drawingml/2006/main" w="0">
-            <a:noFill/>
-          </a:ln>
-        </p:spPr>
-        <p:txBody>
-          <a:bodyPr xmlns:a="http://schemas.openxmlformats.org/drawingml/2006/main" lIns="0" tIns="0" rIns="0" bIns="0" anchor="t">
-            <a:noAutofit/>
-          </a:bodyPr>
-          <a:lstStyle xmlns:a="http://schemas.openxmlformats.org/drawingml/2006/main"/>
-          <a:p xmlns:a="http://schemas.openxmlformats.org/drawingml/2006/main">
-            <a:pPr algn="r">
-              <a:defRPr sz="1125" b="0">
-                <a:solidFill>
-                  <a:srgbClr val="586F7B"/>
-                </a:solidFill>
-                <a:latin typeface="Arial"/>
-                <a:ea typeface="Arial"/>
-                <a:cs typeface="Arial"/>
-              </a:defRPr>
-            </a:pPr>
-            <a:r>
-              <a:rPr sz="1125" b="0">
-                <a:solidFill>
-                  <a:srgbClr val="586F7B"/>
-                </a:solidFill>
-                <a:latin typeface="Arial"/>
-                <a:ea typeface="Arial"/>
-                <a:cs typeface="Arial"/>
-              </a:rPr>
-              <a:t>01 / 8</a:t>
+              <a:t>kr. pr. SMS-segment</a:t>
             </a:r>
           </a:p>
         </p:txBody>
@@ -2977,7 +2924,7 @@
     </p:spTree>
     <p:extLst>
       <p:ext uri="{BB962C8B-B14F-4D97-AF65-F5344CB8AC3E}">
-        <p14:creationId xmlns:p14="http://schemas.microsoft.com/office/powerpoint/2010/main" val="383682352"/>
+        <p14:creationId xmlns:p14="http://schemas.microsoft.com/office/powerpoint/2010/main" val="447989198"/>
       </p:ext>
     </p:extLst>
   </p:cSld>
@@ -3008,7 +2955,7 @@
           <p:cNvPr id="8" name="text-0">
             <a:extLst xmlns:a="http://schemas.openxmlformats.org/drawingml/2006/main">
               <a:ext uri="{FF2B5EF4-FFF2-40B4-BE49-F238E27FC236}">
-                <a16:creationId xmlns:a16="http://schemas.microsoft.com/office/drawing/2014/main" id="{0C609801-C30D-4B3D-8C49-4F77264C3767}"/>
+                <a16:creationId xmlns:a16="http://schemas.microsoft.com/office/drawing/2014/main" id="{9E9C8BEB-0A1E-4991-8FAA-88C939695CD8}"/>
               </a:ext>
             </a:extLst>
           </p:cNvPr>
@@ -3065,7 +3012,7 @@
           <p:cNvPr id="2" name="text-1">
             <a:extLst xmlns:a="http://schemas.openxmlformats.org/drawingml/2006/main">
               <a:ext uri="{FF2B5EF4-FFF2-40B4-BE49-F238E27FC236}">
-                <a16:creationId xmlns:a16="http://schemas.microsoft.com/office/drawing/2014/main" id="{7CDAA48C-188B-4938-829A-1B6EEE70A12F}"/>
+                <a16:creationId xmlns:a16="http://schemas.microsoft.com/office/drawing/2014/main" id="{EC861B35-BA11-456C-AA68-394C475F70E5}"/>
               </a:ext>
             </a:extLst>
           </p:cNvPr>
@@ -3649,7 +3596,7 @@
                           <a:ea typeface="Arial"/>
                           <a:cs typeface="Arial"/>
                         </a:rPr>
-                        <a:t>0,49 kr.</a:t>
+                        <a:t>0,50 kr.</a:t>
                       </a:r>
                     </a:p>
                   </a:txBody>
@@ -3676,7 +3623,7 @@
                           <a:ea typeface="Arial"/>
                           <a:cs typeface="Arial"/>
                         </a:rPr>
-                        <a:t>0,11 kr.</a:t>
+                        <a:t>0,12 kr.</a:t>
                       </a:r>
                     </a:p>
                   </a:txBody>
@@ -3759,7 +3706,7 @@
                           <a:ea typeface="Arial"/>
                           <a:cs typeface="Arial"/>
                         </a:rPr>
-                        <a:t>0,29 kr.</a:t>
+                        <a:t>0,50 kr.</a:t>
                       </a:r>
                     </a:p>
                   </a:txBody>
@@ -3786,7 +3733,7 @@
                           <a:ea typeface="Arial"/>
                           <a:cs typeface="Arial"/>
                         </a:rPr>
-                        <a:t>0,12 kr.</a:t>
+                        <a:t>0,33 kr.</a:t>
                       </a:r>
                     </a:p>
                   </a:txBody>
@@ -3806,7 +3753,7 @@
           <p:cNvPr id="4" name="text-2">
             <a:extLst xmlns:a="http://schemas.openxmlformats.org/drawingml/2006/main">
               <a:ext uri="{FF2B5EF4-FFF2-40B4-BE49-F238E27FC236}">
-                <a16:creationId xmlns:a16="http://schemas.microsoft.com/office/drawing/2014/main" id="{D22A1C4B-20FB-4A85-B020-4A2A6F942E7A}"/>
+                <a16:creationId xmlns:a16="http://schemas.microsoft.com/office/drawing/2014/main" id="{23F7B0C8-AD93-474E-B456-A0457D7ADB33}"/>
               </a:ext>
             </a:extLst>
           </p:cNvPr>
@@ -3863,7 +3810,7 @@
           <p:cNvPr id="5" name="text-3">
             <a:extLst xmlns:a="http://schemas.openxmlformats.org/drawingml/2006/main">
               <a:ext uri="{FF2B5EF4-FFF2-40B4-BE49-F238E27FC236}">
-                <a16:creationId xmlns:a16="http://schemas.microsoft.com/office/drawing/2014/main" id="{3A2A5AB4-4771-4097-A14E-EDF5593F437B}"/>
+                <a16:creationId xmlns:a16="http://schemas.microsoft.com/office/drawing/2014/main" id="{E967C291-659E-4211-86B4-DB99BFC4FBAC}"/>
               </a:ext>
             </a:extLst>
           </p:cNvPr>
@@ -3920,7 +3867,7 @@
           <p:cNvPr id="6" name="text-4">
             <a:extLst xmlns:a="http://schemas.openxmlformats.org/drawingml/2006/main">
               <a:ext uri="{FF2B5EF4-FFF2-40B4-BE49-F238E27FC236}">
-                <a16:creationId xmlns:a16="http://schemas.microsoft.com/office/drawing/2014/main" id="{A6DDD106-EAD5-4B88-A11C-76E6E1A3E30F}"/>
+                <a16:creationId xmlns:a16="http://schemas.microsoft.com/office/drawing/2014/main" id="{781ACE1F-CD06-4123-8A13-B3F2FAC4F314}"/>
               </a:ext>
             </a:extLst>
           </p:cNvPr>
@@ -3977,7 +3924,7 @@
           <p:cNvPr id="7" name="text-5">
             <a:extLst xmlns:a="http://schemas.openxmlformats.org/drawingml/2006/main">
               <a:ext uri="{FF2B5EF4-FFF2-40B4-BE49-F238E27FC236}">
-                <a16:creationId xmlns:a16="http://schemas.microsoft.com/office/drawing/2014/main" id="{9C084FA9-CFD2-49B7-A188-C2D7DD034535}"/>
+                <a16:creationId xmlns:a16="http://schemas.microsoft.com/office/drawing/2014/main" id="{AD46C3EB-668C-4186-BEFD-FC93489CAD38}"/>
               </a:ext>
             </a:extLst>
           </p:cNvPr>
@@ -4032,7 +3979,7 @@
     </p:spTree>
     <p:extLst>
       <p:ext uri="{BB962C8B-B14F-4D97-AF65-F5344CB8AC3E}">
-        <p14:creationId xmlns:p14="http://schemas.microsoft.com/office/powerpoint/2010/main" val="760426495"/>
+        <p14:creationId xmlns:p14="http://schemas.microsoft.com/office/powerpoint/2010/main" val="1388864689"/>
       </p:ext>
     </p:extLst>
   </p:cSld>
@@ -4063,7 +4010,7 @@
           <p:cNvPr id="11" name="text-0">
             <a:extLst xmlns:a="http://schemas.openxmlformats.org/drawingml/2006/main">
               <a:ext uri="{FF2B5EF4-FFF2-40B4-BE49-F238E27FC236}">
-                <a16:creationId xmlns:a16="http://schemas.microsoft.com/office/drawing/2014/main" id="{9FF11953-548C-4D55-A58E-A6EA175AC4E5}"/>
+                <a16:creationId xmlns:a16="http://schemas.microsoft.com/office/drawing/2014/main" id="{3700089B-E3F7-4A73-B6D3-A148C5529EF9}"/>
               </a:ext>
             </a:extLst>
           </p:cNvPr>
@@ -4120,7 +4067,7 @@
           <p:cNvPr id="2" name="text-1">
             <a:extLst xmlns:a="http://schemas.openxmlformats.org/drawingml/2006/main">
               <a:ext uri="{FF2B5EF4-FFF2-40B4-BE49-F238E27FC236}">
-                <a16:creationId xmlns:a16="http://schemas.microsoft.com/office/drawing/2014/main" id="{E9AE1EC9-F8A5-41E5-9769-761B14431612}"/>
+                <a16:creationId xmlns:a16="http://schemas.microsoft.com/office/drawing/2014/main" id="{DEDA0AAB-8E9B-47F7-857D-B9BD7380C61E}"/>
               </a:ext>
             </a:extLst>
           </p:cNvPr>
@@ -4177,7 +4124,7 @@
           <p:cNvPr id="3" name="text-2">
             <a:extLst xmlns:a="http://schemas.openxmlformats.org/drawingml/2006/main">
               <a:ext uri="{FF2B5EF4-FFF2-40B4-BE49-F238E27FC236}">
-                <a16:creationId xmlns:a16="http://schemas.microsoft.com/office/drawing/2014/main" id="{978BBF65-572E-45B8-88F1-37F78AAAC31F}"/>
+                <a16:creationId xmlns:a16="http://schemas.microsoft.com/office/drawing/2014/main" id="{70945DA5-277E-4AB6-BC23-05B6681A8EBE}"/>
               </a:ext>
             </a:extLst>
           </p:cNvPr>
@@ -4234,7 +4181,7 @@
           <p:cNvPr id="4" name="text-3">
             <a:extLst xmlns:a="http://schemas.openxmlformats.org/drawingml/2006/main">
               <a:ext uri="{FF2B5EF4-FFF2-40B4-BE49-F238E27FC236}">
-                <a16:creationId xmlns:a16="http://schemas.microsoft.com/office/drawing/2014/main" id="{5A37F715-AB2C-4B7B-9E2B-BF8807981078}"/>
+                <a16:creationId xmlns:a16="http://schemas.microsoft.com/office/drawing/2014/main" id="{A1C11A9C-5C41-46E7-B654-486E830618E8}"/>
               </a:ext>
             </a:extLst>
           </p:cNvPr>
@@ -5699,7 +5646,7 @@
           <p:cNvPr id="7" name="text-4">
             <a:extLst xmlns:a="http://schemas.openxmlformats.org/drawingml/2006/main">
               <a:ext uri="{FF2B5EF4-FFF2-40B4-BE49-F238E27FC236}">
-                <a16:creationId xmlns:a16="http://schemas.microsoft.com/office/drawing/2014/main" id="{9631CDF0-F1B8-4B3F-90C1-3A512D3775F4}"/>
+                <a16:creationId xmlns:a16="http://schemas.microsoft.com/office/drawing/2014/main" id="{1D856517-32AF-4032-AAC6-8E103E6B947C}"/>
               </a:ext>
             </a:extLst>
           </p:cNvPr>
@@ -5756,7 +5703,7 @@
           <p:cNvPr id="8" name="text-5">
             <a:extLst xmlns:a="http://schemas.openxmlformats.org/drawingml/2006/main">
               <a:ext uri="{FF2B5EF4-FFF2-40B4-BE49-F238E27FC236}">
-                <a16:creationId xmlns:a16="http://schemas.microsoft.com/office/drawing/2014/main" id="{502C3AF5-279C-4179-83B6-43908A4CE1C0}"/>
+                <a16:creationId xmlns:a16="http://schemas.microsoft.com/office/drawing/2014/main" id="{1A09927D-B50B-41B1-9681-0FB0C0C3F58B}"/>
               </a:ext>
             </a:extLst>
           </p:cNvPr>
@@ -5813,7 +5760,7 @@
           <p:cNvPr id="9" name="text-6">
             <a:extLst xmlns:a="http://schemas.openxmlformats.org/drawingml/2006/main">
               <a:ext uri="{FF2B5EF4-FFF2-40B4-BE49-F238E27FC236}">
-                <a16:creationId xmlns:a16="http://schemas.microsoft.com/office/drawing/2014/main" id="{7EEAFB2C-7F16-49BD-8003-FCEFF7761BEC}"/>
+                <a16:creationId xmlns:a16="http://schemas.microsoft.com/office/drawing/2014/main" id="{619C39D9-F36D-4B63-BAB0-071D03662B22}"/>
               </a:ext>
             </a:extLst>
           </p:cNvPr>
@@ -5870,7 +5817,7 @@
           <p:cNvPr id="10" name="text-7">
             <a:extLst xmlns:a="http://schemas.openxmlformats.org/drawingml/2006/main">
               <a:ext uri="{FF2B5EF4-FFF2-40B4-BE49-F238E27FC236}">
-                <a16:creationId xmlns:a16="http://schemas.microsoft.com/office/drawing/2014/main" id="{170D7F38-6EB8-43D4-9B8F-6216C913CF0A}"/>
+                <a16:creationId xmlns:a16="http://schemas.microsoft.com/office/drawing/2014/main" id="{CDF8FD0F-F031-4609-AEE2-5C23FE4A5F24}"/>
               </a:ext>
             </a:extLst>
           </p:cNvPr>
@@ -5925,7 +5872,7 @@
     </p:spTree>
     <p:extLst>
       <p:ext uri="{BB962C8B-B14F-4D97-AF65-F5344CB8AC3E}">
-        <p14:creationId xmlns:p14="http://schemas.microsoft.com/office/powerpoint/2010/main" val="885672222"/>
+        <p14:creationId xmlns:p14="http://schemas.microsoft.com/office/powerpoint/2010/main" val="453333414"/>
       </p:ext>
     </p:extLst>
   </p:cSld>
@@ -5956,7 +5903,7 @@
           <p:cNvPr id="8" name="text-0">
             <a:extLst xmlns:a="http://schemas.openxmlformats.org/drawingml/2006/main">
               <a:ext uri="{FF2B5EF4-FFF2-40B4-BE49-F238E27FC236}">
-                <a16:creationId xmlns:a16="http://schemas.microsoft.com/office/drawing/2014/main" id="{E6A99970-D96E-4BE0-A933-64273C4278A6}"/>
+                <a16:creationId xmlns:a16="http://schemas.microsoft.com/office/drawing/2014/main" id="{577E42FD-09A4-4CDF-AB1D-B160B962DC67}"/>
               </a:ext>
             </a:extLst>
           </p:cNvPr>
@@ -6013,7 +5960,7 @@
           <p:cNvPr id="2" name="text-1">
             <a:extLst xmlns:a="http://schemas.openxmlformats.org/drawingml/2006/main">
               <a:ext uri="{FF2B5EF4-FFF2-40B4-BE49-F238E27FC236}">
-                <a16:creationId xmlns:a16="http://schemas.microsoft.com/office/drawing/2014/main" id="{205FA4E5-3DAD-4870-BE5B-D975F639FE50}"/>
+                <a16:creationId xmlns:a16="http://schemas.microsoft.com/office/drawing/2014/main" id="{1516957C-01E8-4FE4-81A6-DEA803828B14}"/>
               </a:ext>
             </a:extLst>
           </p:cNvPr>
@@ -6864,7 +6811,7 @@
           <p:cNvPr id="4" name="text-2">
             <a:extLst xmlns:a="http://schemas.openxmlformats.org/drawingml/2006/main">
               <a:ext uri="{FF2B5EF4-FFF2-40B4-BE49-F238E27FC236}">
-                <a16:creationId xmlns:a16="http://schemas.microsoft.com/office/drawing/2014/main" id="{96CD282C-C2AC-4F85-97D6-46D761DDCBCC}"/>
+                <a16:creationId xmlns:a16="http://schemas.microsoft.com/office/drawing/2014/main" id="{748B561D-0742-4695-830C-8A577BF512D3}"/>
               </a:ext>
             </a:extLst>
           </p:cNvPr>
@@ -6921,7 +6868,7 @@
           <p:cNvPr id="5" name="text-3">
             <a:extLst xmlns:a="http://schemas.openxmlformats.org/drawingml/2006/main">
               <a:ext uri="{FF2B5EF4-FFF2-40B4-BE49-F238E27FC236}">
-                <a16:creationId xmlns:a16="http://schemas.microsoft.com/office/drawing/2014/main" id="{ACA06114-F597-4A3D-90BE-F72ECFE411D7}"/>
+                <a16:creationId xmlns:a16="http://schemas.microsoft.com/office/drawing/2014/main" id="{6DB2321F-0512-428E-A57F-481FD21F79F7}"/>
               </a:ext>
             </a:extLst>
           </p:cNvPr>
@@ -6978,7 +6925,7 @@
           <p:cNvPr id="6" name="text-4">
             <a:extLst xmlns:a="http://schemas.openxmlformats.org/drawingml/2006/main">
               <a:ext uri="{FF2B5EF4-FFF2-40B4-BE49-F238E27FC236}">
-                <a16:creationId xmlns:a16="http://schemas.microsoft.com/office/drawing/2014/main" id="{02FE5578-BCC4-40CB-BD04-130CFEAF8061}"/>
+                <a16:creationId xmlns:a16="http://schemas.microsoft.com/office/drawing/2014/main" id="{9D4A109B-4520-409D-B8FF-CBD66ECEA140}"/>
               </a:ext>
             </a:extLst>
           </p:cNvPr>
@@ -7035,7 +6982,7 @@
           <p:cNvPr id="7" name="text-5">
             <a:extLst xmlns:a="http://schemas.openxmlformats.org/drawingml/2006/main">
               <a:ext uri="{FF2B5EF4-FFF2-40B4-BE49-F238E27FC236}">
-                <a16:creationId xmlns:a16="http://schemas.microsoft.com/office/drawing/2014/main" id="{D53B32E2-FE33-40B1-BE90-268F1A004582}"/>
+                <a16:creationId xmlns:a16="http://schemas.microsoft.com/office/drawing/2014/main" id="{5F684191-4A39-452B-B413-2B14660C8353}"/>
               </a:ext>
             </a:extLst>
           </p:cNvPr>
@@ -7090,7 +7037,7 @@
     </p:spTree>
     <p:extLst>
       <p:ext uri="{BB962C8B-B14F-4D97-AF65-F5344CB8AC3E}">
-        <p14:creationId xmlns:p14="http://schemas.microsoft.com/office/powerpoint/2010/main" val="188053285"/>
+        <p14:creationId xmlns:p14="http://schemas.microsoft.com/office/powerpoint/2010/main" val="721259462"/>
       </p:ext>
     </p:extLst>
   </p:cSld>
@@ -7121,7 +7068,7 @@
           <p:cNvPr id="11" name="text-0">
             <a:extLst xmlns:a="http://schemas.openxmlformats.org/drawingml/2006/main">
               <a:ext uri="{FF2B5EF4-FFF2-40B4-BE49-F238E27FC236}">
-                <a16:creationId xmlns:a16="http://schemas.microsoft.com/office/drawing/2014/main" id="{33A4F2F3-888F-46C9-BF7E-944A1A019478}"/>
+                <a16:creationId xmlns:a16="http://schemas.microsoft.com/office/drawing/2014/main" id="{587326FC-6744-44A2-9D6F-EDFCD4ABDB05}"/>
               </a:ext>
             </a:extLst>
           </p:cNvPr>
@@ -7178,7 +7125,7 @@
           <p:cNvPr id="2" name="text-1">
             <a:extLst xmlns:a="http://schemas.openxmlformats.org/drawingml/2006/main">
               <a:ext uri="{FF2B5EF4-FFF2-40B4-BE49-F238E27FC236}">
-                <a16:creationId xmlns:a16="http://schemas.microsoft.com/office/drawing/2014/main" id="{00069CCC-0BA2-4AC0-B37A-AA0330C564CF}"/>
+                <a16:creationId xmlns:a16="http://schemas.microsoft.com/office/drawing/2014/main" id="{0F3238C1-2CFE-49F7-AE02-23B392D61B2D}"/>
               </a:ext>
             </a:extLst>
           </p:cNvPr>
@@ -7235,7 +7182,7 @@
           <p:cNvPr id="3" name="text-2">
             <a:extLst xmlns:a="http://schemas.openxmlformats.org/drawingml/2006/main">
               <a:ext uri="{FF2B5EF4-FFF2-40B4-BE49-F238E27FC236}">
-                <a16:creationId xmlns:a16="http://schemas.microsoft.com/office/drawing/2014/main" id="{FAE06FB1-14D7-4828-8979-01E222D4EBEA}"/>
+                <a16:creationId xmlns:a16="http://schemas.microsoft.com/office/drawing/2014/main" id="{EFD39AE6-C4DB-4F48-868A-25B58300B32B}"/>
               </a:ext>
             </a:extLst>
           </p:cNvPr>
@@ -7292,7 +7239,7 @@
           <p:cNvPr id="4" name="text-3">
             <a:extLst xmlns:a="http://schemas.openxmlformats.org/drawingml/2006/main">
               <a:ext uri="{FF2B5EF4-FFF2-40B4-BE49-F238E27FC236}">
-                <a16:creationId xmlns:a16="http://schemas.microsoft.com/office/drawing/2014/main" id="{ACAECB91-438D-47DA-8590-2CC372A33E18}"/>
+                <a16:creationId xmlns:a16="http://schemas.microsoft.com/office/drawing/2014/main" id="{E50576F2-0390-41D2-A2E4-43AF8CFF3984}"/>
               </a:ext>
             </a:extLst>
           </p:cNvPr>
@@ -8387,7 +8334,7 @@
           <p:cNvPr id="7" name="text-4">
             <a:extLst xmlns:a="http://schemas.openxmlformats.org/drawingml/2006/main">
               <a:ext uri="{FF2B5EF4-FFF2-40B4-BE49-F238E27FC236}">
-                <a16:creationId xmlns:a16="http://schemas.microsoft.com/office/drawing/2014/main" id="{673F7B27-3DE8-4103-9356-B4D327AE3E88}"/>
+                <a16:creationId xmlns:a16="http://schemas.microsoft.com/office/drawing/2014/main" id="{679A7A42-4619-42C8-9A98-003D9CD86167}"/>
               </a:ext>
             </a:extLst>
           </p:cNvPr>
@@ -8444,7 +8391,7 @@
           <p:cNvPr id="8" name="text-5">
             <a:extLst xmlns:a="http://schemas.openxmlformats.org/drawingml/2006/main">
               <a:ext uri="{FF2B5EF4-FFF2-40B4-BE49-F238E27FC236}">
-                <a16:creationId xmlns:a16="http://schemas.microsoft.com/office/drawing/2014/main" id="{8A5B7968-3334-44E2-AED3-68CEC0252B9D}"/>
+                <a16:creationId xmlns:a16="http://schemas.microsoft.com/office/drawing/2014/main" id="{C99A1830-DFC8-4CA5-B69F-5A03BB56940F}"/>
               </a:ext>
             </a:extLst>
           </p:cNvPr>
@@ -8524,7 +8471,7 @@
           <p:cNvPr id="9" name="text-6">
             <a:extLst xmlns:a="http://schemas.openxmlformats.org/drawingml/2006/main">
               <a:ext uri="{FF2B5EF4-FFF2-40B4-BE49-F238E27FC236}">
-                <a16:creationId xmlns:a16="http://schemas.microsoft.com/office/drawing/2014/main" id="{CF1F7733-A21A-48A3-A9E9-D687DFA8512D}"/>
+                <a16:creationId xmlns:a16="http://schemas.microsoft.com/office/drawing/2014/main" id="{62D7D837-D73C-4E64-8217-ACBA2A6FA34A}"/>
               </a:ext>
             </a:extLst>
           </p:cNvPr>
@@ -8581,7 +8528,7 @@
           <p:cNvPr id="10" name="text-7">
             <a:extLst xmlns:a="http://schemas.openxmlformats.org/drawingml/2006/main">
               <a:ext uri="{FF2B5EF4-FFF2-40B4-BE49-F238E27FC236}">
-                <a16:creationId xmlns:a16="http://schemas.microsoft.com/office/drawing/2014/main" id="{4EF16284-1EF0-4AAB-8240-96758343F515}"/>
+                <a16:creationId xmlns:a16="http://schemas.microsoft.com/office/drawing/2014/main" id="{B5E352C6-CC65-45A6-8730-DB3C15AC5A30}"/>
               </a:ext>
             </a:extLst>
           </p:cNvPr>
@@ -8636,7 +8583,7 @@
     </p:spTree>
     <p:extLst>
       <p:ext uri="{BB962C8B-B14F-4D97-AF65-F5344CB8AC3E}">
-        <p14:creationId xmlns:p14="http://schemas.microsoft.com/office/powerpoint/2010/main" val="1936080792"/>
+        <p14:creationId xmlns:p14="http://schemas.microsoft.com/office/powerpoint/2010/main" val="1858648253"/>
       </p:ext>
     </p:extLst>
   </p:cSld>
@@ -8667,7 +8614,7 @@
           <p:cNvPr id="12" name="text-0">
             <a:extLst xmlns:a="http://schemas.openxmlformats.org/drawingml/2006/main">
               <a:ext uri="{FF2B5EF4-FFF2-40B4-BE49-F238E27FC236}">
-                <a16:creationId xmlns:a16="http://schemas.microsoft.com/office/drawing/2014/main" id="{873BF963-E5B6-4519-B52C-F14DAE3A8612}"/>
+                <a16:creationId xmlns:a16="http://schemas.microsoft.com/office/drawing/2014/main" id="{7888FD9A-79A7-4C0F-8743-AEE0F9D41CB1}"/>
               </a:ext>
             </a:extLst>
           </p:cNvPr>
@@ -8724,7 +8671,7 @@
           <p:cNvPr id="2" name="text-1">
             <a:extLst xmlns:a="http://schemas.openxmlformats.org/drawingml/2006/main">
               <a:ext uri="{FF2B5EF4-FFF2-40B4-BE49-F238E27FC236}">
-                <a16:creationId xmlns:a16="http://schemas.microsoft.com/office/drawing/2014/main" id="{6E5DFBCA-7EEF-4940-8203-3F02B15A7410}"/>
+                <a16:creationId xmlns:a16="http://schemas.microsoft.com/office/drawing/2014/main" id="{20EB39B1-CF59-436D-AE51-080A9B39EDBD}"/>
               </a:ext>
             </a:extLst>
           </p:cNvPr>
@@ -8781,7 +8728,7 @@
           <p:cNvPr id="3" name="text-2">
             <a:extLst xmlns:a="http://schemas.openxmlformats.org/drawingml/2006/main">
               <a:ext uri="{FF2B5EF4-FFF2-40B4-BE49-F238E27FC236}">
-                <a16:creationId xmlns:a16="http://schemas.microsoft.com/office/drawing/2014/main" id="{27D71288-42D6-4A90-B17C-DFFBCE72DE1C}"/>
+                <a16:creationId xmlns:a16="http://schemas.microsoft.com/office/drawing/2014/main" id="{BF4CA183-B0D3-43BA-BDE2-73B187F8FA1E}"/>
               </a:ext>
             </a:extLst>
           </p:cNvPr>
@@ -8838,7 +8785,7 @@
           <p:cNvPr id="4" name="text-3">
             <a:extLst xmlns:a="http://schemas.openxmlformats.org/drawingml/2006/main">
               <a:ext uri="{FF2B5EF4-FFF2-40B4-BE49-F238E27FC236}">
-                <a16:creationId xmlns:a16="http://schemas.microsoft.com/office/drawing/2014/main" id="{385A0920-3092-45DC-B012-95E450480DFB}"/>
+                <a16:creationId xmlns:a16="http://schemas.microsoft.com/office/drawing/2014/main" id="{FE3F5DDC-866A-43C9-9631-5AA7E8B05396}"/>
               </a:ext>
             </a:extLst>
           </p:cNvPr>
@@ -9202,7 +9149,7 @@
                           <a:ea typeface="Arial"/>
                           <a:cs typeface="Arial"/>
                         </a:rPr>
-                        <a:t>4,90 kr.</a:t>
+                        <a:t>5,00 kr.</a:t>
                       </a:r>
                     </a:p>
                   </a:txBody>
@@ -9229,7 +9176,7 @@
                           <a:ea typeface="Arial"/>
                           <a:cs typeface="Arial"/>
                         </a:rPr>
-                        <a:t>1,09 kr.</a:t>
+                        <a:t>1,19 kr.</a:t>
                       </a:r>
                     </a:p>
                   </a:txBody>
@@ -9312,7 +9259,7 @@
                           <a:ea typeface="Arial"/>
                           <a:cs typeface="Arial"/>
                         </a:rPr>
-                        <a:t>16,90 kr.</a:t>
+                        <a:t>17,00 kr.</a:t>
                       </a:r>
                     </a:p>
                   </a:txBody>
@@ -9339,7 +9286,7 @@
                           <a:ea typeface="Arial"/>
                           <a:cs typeface="Arial"/>
                         </a:rPr>
-                        <a:t>6,81 kr.</a:t>
+                        <a:t>6,91 kr.</a:t>
                       </a:r>
                     </a:p>
                   </a:txBody>
@@ -9359,7 +9306,7 @@
           <p:cNvPr id="6" name="text-4">
             <a:extLst xmlns:a="http://schemas.openxmlformats.org/drawingml/2006/main">
               <a:ext uri="{FF2B5EF4-FFF2-40B4-BE49-F238E27FC236}">
-                <a16:creationId xmlns:a16="http://schemas.microsoft.com/office/drawing/2014/main" id="{77BC1AEE-3566-440D-8365-4AD0FE0C6D33}"/>
+                <a16:creationId xmlns:a16="http://schemas.microsoft.com/office/drawing/2014/main" id="{4614B381-85D1-4ECC-81EB-8F5B118471DB}"/>
               </a:ext>
             </a:extLst>
           </p:cNvPr>
@@ -9613,7 +9560,7 @@
                           <a:ea typeface="Arial"/>
                           <a:cs typeface="Arial"/>
                         </a:rPr>
-                        <a:t>26,70 kr.</a:t>
+                        <a:t>27,00 kr.</a:t>
                       </a:r>
                     </a:p>
                   </a:txBody>
@@ -9640,7 +9587,7 @@
                           <a:ea typeface="Arial"/>
                           <a:cs typeface="Arial"/>
                         </a:rPr>
-                        <a:t>8,99 kr.</a:t>
+                        <a:t>9,29 kr.</a:t>
                       </a:r>
                     </a:p>
                   </a:txBody>
@@ -9723,7 +9670,7 @@
                           <a:ea typeface="Arial"/>
                           <a:cs typeface="Arial"/>
                         </a:rPr>
-                        <a:t>41,40 kr.</a:t>
+                        <a:t>42,00 kr.</a:t>
                       </a:r>
                     </a:p>
                   </a:txBody>
@@ -9750,7 +9697,7 @@
                           <a:ea typeface="Arial"/>
                           <a:cs typeface="Arial"/>
                         </a:rPr>
-                        <a:t>12,25 kr.</a:t>
+                        <a:t>12,85 kr.</a:t>
                       </a:r>
                     </a:p>
                   </a:txBody>
@@ -9996,7 +9943,7 @@
                           <a:ea typeface="Arial"/>
                           <a:cs typeface="Arial"/>
                         </a:rPr>
-                        <a:t>4.900,00 kr.</a:t>
+                        <a:t>5.000,00 kr.</a:t>
                       </a:r>
                     </a:p>
                   </a:txBody>
@@ -10052,7 +9999,7 @@
                           <a:ea typeface="Arial"/>
                           <a:cs typeface="Arial"/>
                         </a:rPr>
-                        <a:t>28.900,00 kr.</a:t>
+                        <a:t>29.000,00 kr.</a:t>
                       </a:r>
                     </a:p>
                   </a:txBody>
@@ -10164,7 +10111,7 @@
                           <a:ea typeface="Arial"/>
                           <a:cs typeface="Arial"/>
                         </a:rPr>
-                        <a:t>18.715,19 kr.</a:t>
+                        <a:t>18.815,19 kr.</a:t>
                       </a:r>
                     </a:p>
                   </a:txBody>
@@ -10332,7 +10279,7 @@
                           <a:ea typeface="Arial"/>
                           <a:cs typeface="Arial"/>
                         </a:rPr>
-                        <a:t>18.140,59 kr.</a:t>
+                        <a:t>18.240,59 kr.</a:t>
                       </a:r>
                     </a:p>
                   </a:txBody>
@@ -10352,7 +10299,7 @@
           <p:cNvPr id="9" name="text-5">
             <a:extLst xmlns:a="http://schemas.openxmlformats.org/drawingml/2006/main">
               <a:ext uri="{FF2B5EF4-FFF2-40B4-BE49-F238E27FC236}">
-                <a16:creationId xmlns:a16="http://schemas.microsoft.com/office/drawing/2014/main" id="{26245C8B-FFB5-4EED-9865-778595E3BC8E}"/>
+                <a16:creationId xmlns:a16="http://schemas.microsoft.com/office/drawing/2014/main" id="{A70381C8-0B57-417E-9D36-854917DD9AA4}"/>
               </a:ext>
             </a:extLst>
           </p:cNvPr>
@@ -10399,7 +10346,7 @@
                 <a:ea typeface="Arial"/>
                 <a:cs typeface="Arial"/>
               </a:rPr>
-              <a:t>Dækningsgrad: 64,8 %</a:t>
+              <a:t>Dækningsgrad: 64,9 %</a:t>
             </a:r>
           </a:p>
         </p:txBody>
@@ -10409,7 +10356,7 @@
           <p:cNvPr id="10" name="text-6">
             <a:extLst xmlns:a="http://schemas.openxmlformats.org/drawingml/2006/main">
               <a:ext uri="{FF2B5EF4-FFF2-40B4-BE49-F238E27FC236}">
-                <a16:creationId xmlns:a16="http://schemas.microsoft.com/office/drawing/2014/main" id="{E24ACC1C-52CB-4830-9776-8CB43DE157E4}"/>
+                <a16:creationId xmlns:a16="http://schemas.microsoft.com/office/drawing/2014/main" id="{45A09066-48B5-422B-8E23-747EE31E8A2B}"/>
               </a:ext>
             </a:extLst>
           </p:cNvPr>
@@ -10489,7 +10436,7 @@
           <p:cNvPr id="11" name="text-7">
             <a:extLst xmlns:a="http://schemas.openxmlformats.org/drawingml/2006/main">
               <a:ext uri="{FF2B5EF4-FFF2-40B4-BE49-F238E27FC236}">
-                <a16:creationId xmlns:a16="http://schemas.microsoft.com/office/drawing/2014/main" id="{0FC2BB5A-F7DB-4E48-98DE-9C8297A1036F}"/>
+                <a16:creationId xmlns:a16="http://schemas.microsoft.com/office/drawing/2014/main" id="{6FDD121E-A389-4F6C-8D93-361D155A7A8D}"/>
               </a:ext>
             </a:extLst>
           </p:cNvPr>
@@ -10544,7 +10491,7 @@
     </p:spTree>
     <p:extLst>
       <p:ext uri="{BB962C8B-B14F-4D97-AF65-F5344CB8AC3E}">
-        <p14:creationId xmlns:p14="http://schemas.microsoft.com/office/powerpoint/2010/main" val="915672477"/>
+        <p14:creationId xmlns:p14="http://schemas.microsoft.com/office/powerpoint/2010/main" val="1500657721"/>
       </p:ext>
     </p:extLst>
   </p:cSld>
@@ -10575,7 +10522,7 @@
           <p:cNvPr id="8" name="text-0">
             <a:extLst xmlns:a="http://schemas.openxmlformats.org/drawingml/2006/main">
               <a:ext uri="{FF2B5EF4-FFF2-40B4-BE49-F238E27FC236}">
-                <a16:creationId xmlns:a16="http://schemas.microsoft.com/office/drawing/2014/main" id="{562A68EF-B3EA-4F5F-B3E4-5C2F12A4369A}"/>
+                <a16:creationId xmlns:a16="http://schemas.microsoft.com/office/drawing/2014/main" id="{D35D8F36-3F6D-4AE6-BE69-D7BE862EDE06}"/>
               </a:ext>
             </a:extLst>
           </p:cNvPr>
@@ -10632,7 +10579,7 @@
           <p:cNvPr id="2" name="text-1">
             <a:extLst xmlns:a="http://schemas.openxmlformats.org/drawingml/2006/main">
               <a:ext uri="{FF2B5EF4-FFF2-40B4-BE49-F238E27FC236}">
-                <a16:creationId xmlns:a16="http://schemas.microsoft.com/office/drawing/2014/main" id="{2D1E9A50-470F-411B-9FE6-C405C8432FCD}"/>
+                <a16:creationId xmlns:a16="http://schemas.microsoft.com/office/drawing/2014/main" id="{82A3C9E5-F680-4CBB-B96C-60DEEBF477DE}"/>
               </a:ext>
             </a:extLst>
           </p:cNvPr>
@@ -10887,7 +10834,7 @@
                           <a:ea typeface="Arial"/>
                           <a:cs typeface="Arial"/>
                         </a:rPr>
-                        <a:t>12.450,00 kr.</a:t>
+                        <a:t>12.500,00 kr.</a:t>
                       </a:r>
                     </a:p>
                   </a:txBody>
@@ -10941,7 +10888,7 @@
                           <a:ea typeface="Arial"/>
                           <a:cs typeface="Arial"/>
                         </a:rPr>
-                        <a:t>7.309,22 kr.</a:t>
+                        <a:t>7.359,22 kr.</a:t>
                       </a:r>
                     </a:p>
                   </a:txBody>
@@ -10968,7 +10915,7 @@
                           <a:ea typeface="Arial"/>
                           <a:cs typeface="Arial"/>
                         </a:rPr>
-                        <a:t>6.734,62 kr.</a:t>
+                        <a:t>6.784,62 kr.</a:t>
                       </a:r>
                     </a:p>
                   </a:txBody>
@@ -11024,7 +10971,7 @@
                           <a:ea typeface="Arial"/>
                           <a:cs typeface="Arial"/>
                         </a:rPr>
-                        <a:t>28.900,00 kr.</a:t>
+                        <a:t>29.000,00 kr.</a:t>
                       </a:r>
                     </a:p>
                   </a:txBody>
@@ -11078,7 +11025,7 @@
                           <a:ea typeface="Arial"/>
                           <a:cs typeface="Arial"/>
                         </a:rPr>
-                        <a:t>18.715,19 kr.</a:t>
+                        <a:t>18.815,19 kr.</a:t>
                       </a:r>
                     </a:p>
                   </a:txBody>
@@ -11105,7 +11052,7 @@
                           <a:ea typeface="Arial"/>
                           <a:cs typeface="Arial"/>
                         </a:rPr>
-                        <a:t>18.140,59 kr.</a:t>
+                        <a:t>18.240,59 kr.</a:t>
                       </a:r>
                     </a:p>
                   </a:txBody>
@@ -11161,7 +11108,7 @@
                           <a:ea typeface="Arial"/>
                           <a:cs typeface="Arial"/>
                         </a:rPr>
-                        <a:t>45.800,00 kr.</a:t>
+                        <a:t>46.000,00 kr.</a:t>
                       </a:r>
                     </a:p>
                   </a:txBody>
@@ -11215,7 +11162,7 @@
                           <a:ea typeface="Arial"/>
                           <a:cs typeface="Arial"/>
                         </a:rPr>
-                        <a:t>25.527,13 kr.</a:t>
+                        <a:t>25.727,13 kr.</a:t>
                       </a:r>
                     </a:p>
                   </a:txBody>
@@ -11242,7 +11189,7 @@
                           <a:ea typeface="Arial"/>
                           <a:cs typeface="Arial"/>
                         </a:rPr>
-                        <a:t>24.952,53 kr.</a:t>
+                        <a:t>25.152,53 kr.</a:t>
                       </a:r>
                     </a:p>
                   </a:txBody>
@@ -11298,7 +11245,7 @@
                           <a:ea typeface="Arial"/>
                           <a:cs typeface="Arial"/>
                         </a:rPr>
-                        <a:t>249.000,00 kr.</a:t>
+                        <a:t>250.000,00 kr.</a:t>
                       </a:r>
                     </a:p>
                   </a:txBody>
@@ -11352,7 +11299,7 @@
                           <a:ea typeface="Arial"/>
                           <a:cs typeface="Arial"/>
                         </a:rPr>
-                        <a:t>148.022,67 kr.</a:t>
+                        <a:t>149.022,67 kr.</a:t>
                       </a:r>
                     </a:p>
                   </a:txBody>
@@ -11379,7 +11326,7 @@
                           <a:ea typeface="Arial"/>
                           <a:cs typeface="Arial"/>
                         </a:rPr>
-                        <a:t>147.448,07 kr.</a:t>
+                        <a:t>148.448,07 kr.</a:t>
                       </a:r>
                     </a:p>
                   </a:txBody>
@@ -11399,7 +11346,7 @@
           <p:cNvPr id="4" name="text-2">
             <a:extLst xmlns:a="http://schemas.openxmlformats.org/drawingml/2006/main">
               <a:ext uri="{FF2B5EF4-FFF2-40B4-BE49-F238E27FC236}">
-                <a16:creationId xmlns:a16="http://schemas.microsoft.com/office/drawing/2014/main" id="{E465109E-4AF9-4705-AC1C-A5FAC419C77C}"/>
+                <a16:creationId xmlns:a16="http://schemas.microsoft.com/office/drawing/2014/main" id="{58607585-57B0-4A35-98E8-C5C2061EEA14}"/>
               </a:ext>
             </a:extLst>
           </p:cNvPr>
@@ -11653,7 +11600,7 @@
                           <a:ea typeface="Arial"/>
                           <a:cs typeface="Arial"/>
                         </a:rPr>
-                        <a:t>18.715,19 kr.</a:t>
+                        <a:t>18.815,19 kr.</a:t>
                       </a:r>
                     </a:p>
                   </a:txBody>
@@ -11680,7 +11627,7 @@
                           <a:ea typeface="Arial"/>
                           <a:cs typeface="Arial"/>
                         </a:rPr>
-                        <a:t>18.140,59 kr.</a:t>
+                        <a:t>18.240,59 kr.</a:t>
                       </a:r>
                     </a:p>
                   </a:txBody>
@@ -11763,7 +11710,7 @@
                           <a:ea typeface="Arial"/>
                           <a:cs typeface="Arial"/>
                         </a:rPr>
-                        <a:t>17.515,19 kr.</a:t>
+                        <a:t>17.615,19 kr.</a:t>
                       </a:r>
                     </a:p>
                   </a:txBody>
@@ -11790,7 +11737,7 @@
                           <a:ea typeface="Arial"/>
                           <a:cs typeface="Arial"/>
                         </a:rPr>
-                        <a:t>16.940,59 kr.</a:t>
+                        <a:t>17.040,59 kr.</a:t>
                       </a:r>
                     </a:p>
                   </a:txBody>
@@ -11873,7 +11820,7 @@
                           <a:ea typeface="Arial"/>
                           <a:cs typeface="Arial"/>
                         </a:rPr>
-                        <a:t>16.315,19 kr.</a:t>
+                        <a:t>16.415,19 kr.</a:t>
                       </a:r>
                     </a:p>
                   </a:txBody>
@@ -11900,7 +11847,7 @@
                           <a:ea typeface="Arial"/>
                           <a:cs typeface="Arial"/>
                         </a:rPr>
-                        <a:t>15.740,59 kr.</a:t>
+                        <a:t>15.840,59 kr.</a:t>
                       </a:r>
                     </a:p>
                   </a:txBody>
@@ -11983,7 +11930,7 @@
                           <a:ea typeface="Arial"/>
                           <a:cs typeface="Arial"/>
                         </a:rPr>
-                        <a:t>15.115,19 kr.</a:t>
+                        <a:t>15.215,19 kr.</a:t>
                       </a:r>
                     </a:p>
                   </a:txBody>
@@ -12010,7 +11957,7 @@
                           <a:ea typeface="Arial"/>
                           <a:cs typeface="Arial"/>
                         </a:rPr>
-                        <a:t>14.540,59 kr.</a:t>
+                        <a:t>14.640,59 kr.</a:t>
                       </a:r>
                     </a:p>
                   </a:txBody>
@@ -12030,7 +11977,7 @@
           <p:cNvPr id="6" name="text-3">
             <a:extLst xmlns:a="http://schemas.openxmlformats.org/drawingml/2006/main">
               <a:ext uri="{FF2B5EF4-FFF2-40B4-BE49-F238E27FC236}">
-                <a16:creationId xmlns:a16="http://schemas.microsoft.com/office/drawing/2014/main" id="{62F5DA6C-2355-4111-ADEA-B556204FB18F}"/>
+                <a16:creationId xmlns:a16="http://schemas.microsoft.com/office/drawing/2014/main" id="{D9125FDF-CD0B-4515-BABF-61FC0D3C1EDF}"/>
               </a:ext>
             </a:extLst>
           </p:cNvPr>
@@ -12087,7 +12034,7 @@
           <p:cNvPr id="7" name="text-4">
             <a:extLst xmlns:a="http://schemas.openxmlformats.org/drawingml/2006/main">
               <a:ext uri="{FF2B5EF4-FFF2-40B4-BE49-F238E27FC236}">
-                <a16:creationId xmlns:a16="http://schemas.microsoft.com/office/drawing/2014/main" id="{74B87A18-2941-4DFE-A647-74D53E1E88BD}"/>
+                <a16:creationId xmlns:a16="http://schemas.microsoft.com/office/drawing/2014/main" id="{D1562358-C3C1-46A7-BAFD-E69D57DB95CC}"/>
               </a:ext>
             </a:extLst>
           </p:cNvPr>
@@ -12142,7 +12089,7 @@
     </p:spTree>
     <p:extLst>
       <p:ext uri="{BB962C8B-B14F-4D97-AF65-F5344CB8AC3E}">
-        <p14:creationId xmlns:p14="http://schemas.microsoft.com/office/powerpoint/2010/main" val="1133193740"/>
+        <p14:creationId xmlns:p14="http://schemas.microsoft.com/office/powerpoint/2010/main" val="1507327196"/>
       </p:ext>
     </p:extLst>
   </p:cSld>
@@ -12173,7 +12120,7 @@
           <p:cNvPr id="8" name="text-0">
             <a:extLst xmlns:a="http://schemas.openxmlformats.org/drawingml/2006/main">
               <a:ext uri="{FF2B5EF4-FFF2-40B4-BE49-F238E27FC236}">
-                <a16:creationId xmlns:a16="http://schemas.microsoft.com/office/drawing/2014/main" id="{935629AC-F0F3-46C8-98DC-210F2693388F}"/>
+                <a16:creationId xmlns:a16="http://schemas.microsoft.com/office/drawing/2014/main" id="{876937D0-E672-4F12-A4B9-2B154E939FC1}"/>
               </a:ext>
             </a:extLst>
           </p:cNvPr>
@@ -12230,7 +12177,7 @@
           <p:cNvPr id="2" name="text-1">
             <a:extLst xmlns:a="http://schemas.openxmlformats.org/drawingml/2006/main">
               <a:ext uri="{FF2B5EF4-FFF2-40B4-BE49-F238E27FC236}">
-                <a16:creationId xmlns:a16="http://schemas.microsoft.com/office/drawing/2014/main" id="{DC299A4A-1075-4AC5-865F-CDABCA686567}"/>
+                <a16:creationId xmlns:a16="http://schemas.microsoft.com/office/drawing/2014/main" id="{1275F69A-94F3-4D86-B793-D6AC8EA53312}"/>
               </a:ext>
             </a:extLst>
           </p:cNvPr>
@@ -12277,7 +12224,7 @@
                 <a:ea typeface="Arial"/>
                 <a:cs typeface="Arial"/>
               </a:rPr>
-              <a:t>Budget pr. 9. september 2026. Krav før salg med fast pris.</a:t>
+              <a:t>Budget pr. 10. september 2026. Krav før salg med fast pris.</a:t>
             </a:r>
           </a:p>
         </p:txBody>
@@ -12533,7 +12480,7 @@
           <p:cNvPr id="4" name="text-2">
             <a:extLst xmlns:a="http://schemas.openxmlformats.org/drawingml/2006/main">
               <a:ext uri="{FF2B5EF4-FFF2-40B4-BE49-F238E27FC236}">
-                <a16:creationId xmlns:a16="http://schemas.microsoft.com/office/drawing/2014/main" id="{CE329D9B-A083-4113-8809-26D582B2DC48}"/>
+                <a16:creationId xmlns:a16="http://schemas.microsoft.com/office/drawing/2014/main" id="{8A29FC77-EB35-4F46-970B-42E6B1730EE1}"/>
               </a:ext>
             </a:extLst>
           </p:cNvPr>
@@ -12590,7 +12537,7 @@
           <p:cNvPr id="5" name="text-3">
             <a:extLst xmlns:a="http://schemas.openxmlformats.org/drawingml/2006/main">
               <a:ext uri="{FF2B5EF4-FFF2-40B4-BE49-F238E27FC236}">
-                <a16:creationId xmlns:a16="http://schemas.microsoft.com/office/drawing/2014/main" id="{969E2F8A-B0DF-4070-B629-BBDCF991DB67}"/>
+                <a16:creationId xmlns:a16="http://schemas.microsoft.com/office/drawing/2014/main" id="{D539B9FB-CD7D-443A-BB44-1AD10618221B}"/>
               </a:ext>
             </a:extLst>
           </p:cNvPr>
@@ -12647,7 +12594,7 @@
           <p:cNvPr id="6" name="text-4">
             <a:extLst xmlns:a="http://schemas.openxmlformats.org/drawingml/2006/main">
               <a:ext uri="{FF2B5EF4-FFF2-40B4-BE49-F238E27FC236}">
-                <a16:creationId xmlns:a16="http://schemas.microsoft.com/office/drawing/2014/main" id="{3D03BFD6-B02C-4130-98FF-9DB339A8043B}"/>
+                <a16:creationId xmlns:a16="http://schemas.microsoft.com/office/drawing/2014/main" id="{30B894B7-269B-4357-930C-9E4421D2300C}"/>
               </a:ext>
             </a:extLst>
           </p:cNvPr>
@@ -12704,7 +12651,7 @@
           <p:cNvPr id="7" name="text-5">
             <a:extLst xmlns:a="http://schemas.openxmlformats.org/drawingml/2006/main">
               <a:ext uri="{FF2B5EF4-FFF2-40B4-BE49-F238E27FC236}">
-                <a16:creationId xmlns:a16="http://schemas.microsoft.com/office/drawing/2014/main" id="{3A3E21EB-9991-4E7B-AAEB-455B86429299}"/>
+                <a16:creationId xmlns:a16="http://schemas.microsoft.com/office/drawing/2014/main" id="{A8834A13-F84A-48F1-ADBB-B11E94EA039F}"/>
               </a:ext>
             </a:extLst>
           </p:cNvPr>
@@ -12759,7 +12706,7 @@
     </p:spTree>
     <p:extLst>
       <p:ext uri="{BB962C8B-B14F-4D97-AF65-F5344CB8AC3E}">
-        <p14:creationId xmlns:p14="http://schemas.microsoft.com/office/powerpoint/2010/main" val="1693677603"/>
+        <p14:creationId xmlns:p14="http://schemas.microsoft.com/office/powerpoint/2010/main" val="740801880"/>
       </p:ext>
     </p:extLst>
   </p:cSld>

</xml_diff>